<commit_message>
docs: add orchestration-layer / bring-your-own-agent vision slide
Position Mochi as an orchestration layer rather than a point solution.
New slide 8 frames the structured stance contract (position, rationale,
assumptions, confidence) as an open interface: today managed agents fill
it per participant; the roadmap is bring-your-own-agent, where a user
points their own agent at Mochi, keeps their context private, and emits
only a structured stance. Labeled roadmap, not a shipped demo feature.

- Add slides/slide-08.mjs (orchestration layer + BYOA, page 8).
- Move the close to slides/slide-09.mjs (page 9).
- Bump build slide-count to 9; update deck README references.
- Regenerate pptx, previews, and layout artifacts.
</commit_message>
<xml_diff>
--- a/docs/pitch-deck/output/per-my-last-email-hackathon-pitch.pptx
+++ b/docs/pitch-deck/output/per-my-last-email-hackathon-pitch.pptx
@@ -2,20 +2,21 @@
 <file path=ppt/presentation.xml><?xml version="1.0" encoding="utf-8"?>
 <p:presentation xmlns:p="http://schemas.openxmlformats.org/presentationml/2006/main">
   <p:sldMasterIdLst>
-    <p:sldMasterId xmlns:r="http://schemas.openxmlformats.org/officeDocument/2006/relationships" id="2147483648" r:id="R3162387ab941485a"/>
+    <p:sldMasterId xmlns:r="http://schemas.openxmlformats.org/officeDocument/2006/relationships" id="2147483648" r:id="Rd1b8f314d8594d3b"/>
   </p:sldMasterIdLst>
   <p:notesMasterIdLst>
-    <p:notesMasterId xmlns:r="http://schemas.openxmlformats.org/officeDocument/2006/relationships" r:id="R27258a725f5f4bf4"/>
+    <p:notesMasterId xmlns:r="http://schemas.openxmlformats.org/officeDocument/2006/relationships" r:id="R09eedc72819543be"/>
   </p:notesMasterIdLst>
   <p:sldIdLst>
-    <p:sldId xmlns:r="http://schemas.openxmlformats.org/officeDocument/2006/relationships" id="256" r:id="Rb367038a77ec446d"/>
-    <p:sldId xmlns:r="http://schemas.openxmlformats.org/officeDocument/2006/relationships" id="257" r:id="R39a99aa04ea745e4"/>
-    <p:sldId xmlns:r="http://schemas.openxmlformats.org/officeDocument/2006/relationships" id="258" r:id="Rdfcec4295a4e4439"/>
-    <p:sldId xmlns:r="http://schemas.openxmlformats.org/officeDocument/2006/relationships" id="259" r:id="R66ef2503d14b428f"/>
-    <p:sldId xmlns:r="http://schemas.openxmlformats.org/officeDocument/2006/relationships" id="260" r:id="Rb9fd664021fe437a"/>
-    <p:sldId xmlns:r="http://schemas.openxmlformats.org/officeDocument/2006/relationships" id="261" r:id="R7778894b99bd4968"/>
-    <p:sldId xmlns:r="http://schemas.openxmlformats.org/officeDocument/2006/relationships" id="262" r:id="R26ae0c5dc02b460c"/>
-    <p:sldId xmlns:r="http://schemas.openxmlformats.org/officeDocument/2006/relationships" id="263" r:id="Rce954219e1184daa"/>
+    <p:sldId xmlns:r="http://schemas.openxmlformats.org/officeDocument/2006/relationships" id="256" r:id="Rfd67ad8818454f5c"/>
+    <p:sldId xmlns:r="http://schemas.openxmlformats.org/officeDocument/2006/relationships" id="257" r:id="R6f489d4db9ca4e67"/>
+    <p:sldId xmlns:r="http://schemas.openxmlformats.org/officeDocument/2006/relationships" id="258" r:id="Rda1171b1146f40b2"/>
+    <p:sldId xmlns:r="http://schemas.openxmlformats.org/officeDocument/2006/relationships" id="259" r:id="Rbe164bc226434f56"/>
+    <p:sldId xmlns:r="http://schemas.openxmlformats.org/officeDocument/2006/relationships" id="260" r:id="Rf08fc3c621d54011"/>
+    <p:sldId xmlns:r="http://schemas.openxmlformats.org/officeDocument/2006/relationships" id="261" r:id="Rb2f9a058af2a4be6"/>
+    <p:sldId xmlns:r="http://schemas.openxmlformats.org/officeDocument/2006/relationships" id="262" r:id="Rc68fadc79c954c41"/>
+    <p:sldId xmlns:r="http://schemas.openxmlformats.org/officeDocument/2006/relationships" id="263" r:id="R01912ffae2bf4a47"/>
+    <p:sldId xmlns:r="http://schemas.openxmlformats.org/officeDocument/2006/relationships" id="264" r:id="R31e1be4df9d64229"/>
   </p:sldIdLst>
   <p:sldSz cx="12192000" cy="6858000"/>
   <p:notesSz cx="6858000" cy="9144000"/>
@@ -988,7 +989,77 @@
           <a:lstStyle xmlns:a="http://schemas.openxmlformats.org/drawingml/2006/main"/>
           <a:p xmlns:a="http://schemas.openxmlformats.org/drawingml/2006/main">
             <a:r>
-              <a:t>Close. Bring the judges back to the sentence from the live script: meetings do not fail because people think they agree. Mochi catches the fake agreement before the hour is gone, inside Slack. Stop at the generated pre-meeting brief; do not imply a final influencer decision. The repo URL is now on the slide for submission. Still missing for final submission: optional hosted demo link, live trace artifact, and latency/reliability or measured adoption/time-saved only if measured.</a:t>
+              <a:t>Vision slide, framed as architecture and roadmap, not a shipped demo feature. Mochi is an orchestration layer: it coordinates agents rather than replacing them. The structured stance contract (position, rationale, assumptions, confidence) is the open interface. Today, managed agents fill that contract for each participant. The roadmap is bring-your-own-agent: a user points their own personal agent at Mochi; it negotiates their stance in their voice, keeps their context private, and emits only a structured stance. Do not claim BYOA is demoed; label it roadmap. The point is that Mochi is the protocol for pre-meeting agent reasoning, not a silo.</a:t>
+            </a:r>
+          </a:p>
+        </p:txBody>
+      </p:sp>
+      <p:sp>
+        <p:nvSpPr>
+          <p:cNvPr id="4" name="Slide Number Placeholder 3"/>
+          <p:cNvSpPr>
+            <a:spLocks xmlns:a="http://schemas.openxmlformats.org/drawingml/2006/main" noGrp="1"/>
+          </p:cNvSpPr>
+          <p:nvPr>
+            <p:ph type="sldNum" idx="5"/>
+          </p:nvPr>
+        </p:nvSpPr>
+        <p:spPr/>
+        <p:txBody>
+          <a:bodyPr xmlns:a="http://schemas.openxmlformats.org/drawingml/2006/main"/>
+          <a:lstStyle xmlns:a="http://schemas.openxmlformats.org/drawingml/2006/main"/>
+          <a:p xmlns:a="http://schemas.openxmlformats.org/drawingml/2006/main"/>
+        </p:txBody>
+      </p:sp>
+    </p:spTree>
+  </p:cSld>
+  <p:clrMapOvr>
+    <a:masterClrMapping xmlns:a="http://schemas.openxmlformats.org/drawingml/2006/main"/>
+  </p:clrMapOvr>
+</p:notes>
+</file>
+
+<file path=ppt/notesSlides/notesSlide9.xml><?xml version="1.0" encoding="utf-8"?>
+<p:notes xmlns:p="http://schemas.openxmlformats.org/presentationml/2006/main">
+  <p:cSld>
+    <p:spTree>
+      <p:nvGrpSpPr>
+        <p:cNvPr id="1" name=""/>
+        <p:cNvGrpSpPr/>
+        <p:nvPr/>
+      </p:nvGrpSpPr>
+      <p:grpSpPr>
+        <a:xfrm xmlns:a="http://schemas.openxmlformats.org/drawingml/2006/main"/>
+      </p:grpSpPr>
+      <p:sp>
+        <p:nvSpPr>
+          <p:cNvPr id="2" name="Slide Image Placeholder 1"/>
+          <p:cNvSpPr>
+            <a:spLocks xmlns:a="http://schemas.openxmlformats.org/drawingml/2006/main" noGrp="1"/>
+          </p:cNvSpPr>
+          <p:nvPr>
+            <p:ph type="sldImg" idx="0"/>
+          </p:nvPr>
+        </p:nvSpPr>
+        <p:spPr/>
+      </p:sp>
+      <p:sp>
+        <p:nvSpPr>
+          <p:cNvPr id="3" name="Notes Placeholder 2"/>
+          <p:cNvSpPr>
+            <a:spLocks xmlns:a="http://schemas.openxmlformats.org/drawingml/2006/main" noGrp="1"/>
+          </p:cNvSpPr>
+          <p:nvPr>
+            <p:ph type="body" idx="1"/>
+          </p:nvPr>
+        </p:nvSpPr>
+        <p:spPr/>
+        <p:txBody>
+          <a:bodyPr xmlns:a="http://schemas.openxmlformats.org/drawingml/2006/main"/>
+          <a:lstStyle xmlns:a="http://schemas.openxmlformats.org/drawingml/2006/main"/>
+          <a:p xmlns:a="http://schemas.openxmlformats.org/drawingml/2006/main">
+            <a:r>
+              <a:t>Close. Bring the judges back to the sentence from the live script: meetings do not fail because people think they agree. Mochi catches the fake agreement before the hour is gone, inside Slack. Stop at the generated pre-meeting brief; do not imply a final influencer decision. The repo URL is on the slide for submission. Still missing for final submission: optional hosted demo link, live trace artifact, and latency/reliability or measured adoption/time-saved only if measured.</a:t>
             </a:r>
           </a:p>
         </p:txBody>
@@ -1056,7 +1127,7 @@
   </p:cSld>
   <p:clrMap bg1="lt1" tx1="dk1" bg2="lt2" tx2="dk2" accent1="accent1" accent2="accent2" accent3="accent3" accent4="accent4" accent5="accent5" accent6="accent6" hlink="hlink" folHlink="folHlink"/>
   <p:sldLayoutIdLst>
-    <p:sldLayoutId xmlns:r="http://schemas.openxmlformats.org/officeDocument/2006/relationships" id="2147483649" r:id="Rc43a85dd62424c5d"/>
+    <p:sldLayoutId xmlns:r="http://schemas.openxmlformats.org/officeDocument/2006/relationships" id="2147483649" r:id="Rcda8e940c79a41f5"/>
   </p:sldLayoutIdLst>
   <p:txStyles>
     <p:titleStyle>
@@ -1565,7 +1636,7 @@
           <p:nvPr/>
         </p:nvPicPr>
         <p:blipFill>
-          <a:blip xmlns:r="http://schemas.openxmlformats.org/officeDocument/2006/relationships" xmlns:a="http://schemas.openxmlformats.org/drawingml/2006/main" r:embed="Rff28054db3ee4a04"/>
+          <a:blip xmlns:r="http://schemas.openxmlformats.org/officeDocument/2006/relationships" xmlns:a="http://schemas.openxmlformats.org/drawingml/2006/main" r:embed="Rfaa91be96e52443b"/>
           <a:srcRect xmlns:a="http://schemas.openxmlformats.org/drawingml/2006/main" l="0" t="0" r="0" b="0"/>
           <a:stretch xmlns:a="http://schemas.openxmlformats.org/drawingml/2006/main">
             <a:fillRect l="0" t="0" r="0" b="0"/>
@@ -1586,7 +1657,7 @@
           <p:cNvPr id="2" name="">
             <a:extLst xmlns:a="http://schemas.openxmlformats.org/drawingml/2006/main">
               <a:ext uri="{FF2B5EF4-FFF2-40B4-BE49-F238E27FC236}">
-                <a16:creationId xmlns:a16="http://schemas.microsoft.com/office/drawing/2014/main" id="{BD7AE22C-76A0-495B-AAF7-5D6CB94250F3}"/>
+                <a16:creationId xmlns:a16="http://schemas.microsoft.com/office/drawing/2014/main" id="{99173127-8F5C-4FF7-A95E-A8CEC5B5DE9C}"/>
               </a:ext>
             </a:extLst>
           </p:cNvPr>
@@ -1633,7 +1704,7 @@
           <p:cNvPr id="3" name="">
             <a:extLst xmlns:a="http://schemas.openxmlformats.org/drawingml/2006/main">
               <a:ext uri="{FF2B5EF4-FFF2-40B4-BE49-F238E27FC236}">
-                <a16:creationId xmlns:a16="http://schemas.microsoft.com/office/drawing/2014/main" id="{7AE41958-B9A2-45CC-B0D2-9053AE272AD8}"/>
+                <a16:creationId xmlns:a16="http://schemas.microsoft.com/office/drawing/2014/main" id="{2CC1026F-9328-46C8-84D6-40974F1AC588}"/>
               </a:ext>
             </a:extLst>
           </p:cNvPr>
@@ -1667,7 +1738,7 @@
           <p:cNvPr id="4" name="">
             <a:extLst xmlns:a="http://schemas.openxmlformats.org/drawingml/2006/main">
               <a:ext uri="{FF2B5EF4-FFF2-40B4-BE49-F238E27FC236}">
-                <a16:creationId xmlns:a16="http://schemas.microsoft.com/office/drawing/2014/main" id="{8438FFBB-8F0B-4D45-BD42-67209086F54C}"/>
+                <a16:creationId xmlns:a16="http://schemas.microsoft.com/office/drawing/2014/main" id="{A83CC41D-22F1-4DD9-BF36-F28B13930226}"/>
               </a:ext>
             </a:extLst>
           </p:cNvPr>
@@ -1724,7 +1795,7 @@
           <p:cNvPr id="5" name="">
             <a:extLst xmlns:a="http://schemas.openxmlformats.org/drawingml/2006/main">
               <a:ext uri="{FF2B5EF4-FFF2-40B4-BE49-F238E27FC236}">
-                <a16:creationId xmlns:a16="http://schemas.microsoft.com/office/drawing/2014/main" id="{8E416F68-B340-4637-BAF7-0C7F77E473D6}"/>
+                <a16:creationId xmlns:a16="http://schemas.microsoft.com/office/drawing/2014/main" id="{44138AD1-DFCD-4F62-8A9B-0D67964E34B1}"/>
               </a:ext>
             </a:extLst>
           </p:cNvPr>
@@ -1784,7 +1855,7 @@
           <p:cNvPr id="6" name="">
             <a:extLst xmlns:a="http://schemas.openxmlformats.org/drawingml/2006/main">
               <a:ext uri="{FF2B5EF4-FFF2-40B4-BE49-F238E27FC236}">
-                <a16:creationId xmlns:a16="http://schemas.microsoft.com/office/drawing/2014/main" id="{08B8B259-11FB-4E30-BC21-2957A9AB1A70}"/>
+                <a16:creationId xmlns:a16="http://schemas.microsoft.com/office/drawing/2014/main" id="{24F705AD-8E9B-433E-B4A8-5FB5A624A142}"/>
               </a:ext>
             </a:extLst>
           </p:cNvPr>
@@ -1831,7 +1902,7 @@
           <p:cNvPr id="7" name="">
             <a:extLst xmlns:a="http://schemas.openxmlformats.org/drawingml/2006/main">
               <a:ext uri="{FF2B5EF4-FFF2-40B4-BE49-F238E27FC236}">
-                <a16:creationId xmlns:a16="http://schemas.microsoft.com/office/drawing/2014/main" id="{761045AF-BDB7-4898-8DAA-4DE46FC5BA19}"/>
+                <a16:creationId xmlns:a16="http://schemas.microsoft.com/office/drawing/2014/main" id="{97E4694A-6CC9-4DDB-BA54-007F33DE055B}"/>
               </a:ext>
             </a:extLst>
           </p:cNvPr>
@@ -1861,7 +1932,7 @@
           <p:cNvPr id="8" name="">
             <a:extLst xmlns:a="http://schemas.openxmlformats.org/drawingml/2006/main">
               <a:ext uri="{FF2B5EF4-FFF2-40B4-BE49-F238E27FC236}">
-                <a16:creationId xmlns:a16="http://schemas.microsoft.com/office/drawing/2014/main" id="{D3D9CB1B-E6AD-4C0E-888C-E09083AE0294}"/>
+                <a16:creationId xmlns:a16="http://schemas.microsoft.com/office/drawing/2014/main" id="{14FD7E9B-E235-49A8-BFAD-6DD58435E9DF}"/>
               </a:ext>
             </a:extLst>
           </p:cNvPr>
@@ -1908,7 +1979,7 @@
           <p:cNvPr id="9" name="">
             <a:extLst xmlns:a="http://schemas.openxmlformats.org/drawingml/2006/main">
               <a:ext uri="{FF2B5EF4-FFF2-40B4-BE49-F238E27FC236}">
-                <a16:creationId xmlns:a16="http://schemas.microsoft.com/office/drawing/2014/main" id="{75E4266A-15D8-44C5-8F06-9A39A246DBB7}"/>
+                <a16:creationId xmlns:a16="http://schemas.microsoft.com/office/drawing/2014/main" id="{D6BD6E5C-107A-4ED5-8FB9-91C55815E4E0}"/>
               </a:ext>
             </a:extLst>
           </p:cNvPr>
@@ -1959,7 +2030,7 @@
           <p:nvPr/>
         </p:nvPicPr>
         <p:blipFill>
-          <a:blip xmlns:r="http://schemas.openxmlformats.org/officeDocument/2006/relationships" xmlns:a="http://schemas.openxmlformats.org/drawingml/2006/main" r:embed="Rca86d6a5a3f54fa3"/>
+          <a:blip xmlns:r="http://schemas.openxmlformats.org/officeDocument/2006/relationships" xmlns:a="http://schemas.openxmlformats.org/drawingml/2006/main" r:embed="Rd35601a782824e29"/>
           <a:srcRect xmlns:a="http://schemas.openxmlformats.org/drawingml/2006/main" l="0" t="0" r="0" b="0"/>
           <a:stretch xmlns:a="http://schemas.openxmlformats.org/drawingml/2006/main">
             <a:fillRect l="0" t="0" r="0" b="0"/>
@@ -1980,7 +2051,7 @@
           <p:cNvPr id="11" name="">
             <a:extLst xmlns:a="http://schemas.openxmlformats.org/drawingml/2006/main">
               <a:ext uri="{FF2B5EF4-FFF2-40B4-BE49-F238E27FC236}">
-                <a16:creationId xmlns:a16="http://schemas.microsoft.com/office/drawing/2014/main" id="{EFFF8DFE-52B4-44C1-A000-C10DD5D134B2}"/>
+                <a16:creationId xmlns:a16="http://schemas.microsoft.com/office/drawing/2014/main" id="{67D62F32-7FF7-4CD1-80C9-B9D6967F3881}"/>
               </a:ext>
             </a:extLst>
           </p:cNvPr>
@@ -2037,7 +2108,7 @@
           <p:cNvPr id="12" name="">
             <a:extLst xmlns:a="http://schemas.openxmlformats.org/drawingml/2006/main">
               <a:ext uri="{FF2B5EF4-FFF2-40B4-BE49-F238E27FC236}">
-                <a16:creationId xmlns:a16="http://schemas.microsoft.com/office/drawing/2014/main" id="{1E43B078-D8AB-4EA2-8D5F-F3A475F66339}"/>
+                <a16:creationId xmlns:a16="http://schemas.microsoft.com/office/drawing/2014/main" id="{81A5595D-E413-4DF6-BC36-CA261E0AF2C7}"/>
               </a:ext>
             </a:extLst>
           </p:cNvPr>
@@ -2069,7 +2140,7 @@
           <p:cNvPr id="13" name="">
             <a:extLst xmlns:a="http://schemas.openxmlformats.org/drawingml/2006/main">
               <a:ext uri="{FF2B5EF4-FFF2-40B4-BE49-F238E27FC236}">
-                <a16:creationId xmlns:a16="http://schemas.microsoft.com/office/drawing/2014/main" id="{05DD280E-778C-4CD6-A15B-82E6245EF77C}"/>
+                <a16:creationId xmlns:a16="http://schemas.microsoft.com/office/drawing/2014/main" id="{735385D4-B2B6-4623-A582-CE958A0878E3}"/>
               </a:ext>
             </a:extLst>
           </p:cNvPr>
@@ -2116,7 +2187,7 @@
           <p:cNvPr id="14" name="">
             <a:extLst xmlns:a="http://schemas.openxmlformats.org/drawingml/2006/main">
               <a:ext uri="{FF2B5EF4-FFF2-40B4-BE49-F238E27FC236}">
-                <a16:creationId xmlns:a16="http://schemas.microsoft.com/office/drawing/2014/main" id="{8CCD2696-BDB1-4AA5-B365-375D33E63848}"/>
+                <a16:creationId xmlns:a16="http://schemas.microsoft.com/office/drawing/2014/main" id="{A3E48470-4438-4720-8BD8-54465BD3EDAC}"/>
               </a:ext>
             </a:extLst>
           </p:cNvPr>
@@ -2173,7 +2244,7 @@
           <p:cNvPr id="15" name="">
             <a:extLst xmlns:a="http://schemas.openxmlformats.org/drawingml/2006/main">
               <a:ext uri="{FF2B5EF4-FFF2-40B4-BE49-F238E27FC236}">
-                <a16:creationId xmlns:a16="http://schemas.microsoft.com/office/drawing/2014/main" id="{48B6A66C-68F3-489C-B9B5-36CFA72FD546}"/>
+                <a16:creationId xmlns:a16="http://schemas.microsoft.com/office/drawing/2014/main" id="{CBD62B0E-C0DE-45F1-8367-96049B5DDF9D}"/>
               </a:ext>
             </a:extLst>
           </p:cNvPr>
@@ -2230,7 +2301,7 @@
           <p:cNvPr id="16" name="">
             <a:extLst xmlns:a="http://schemas.openxmlformats.org/drawingml/2006/main">
               <a:ext uri="{FF2B5EF4-FFF2-40B4-BE49-F238E27FC236}">
-                <a16:creationId xmlns:a16="http://schemas.microsoft.com/office/drawing/2014/main" id="{365C8F9D-64C6-4BD9-BB81-E843F2542FAC}"/>
+                <a16:creationId xmlns:a16="http://schemas.microsoft.com/office/drawing/2014/main" id="{40DC3540-1332-4B95-B4B0-DA0424A4BA26}"/>
               </a:ext>
             </a:extLst>
           </p:cNvPr>
@@ -2287,7 +2358,7 @@
           <p:cNvPr id="17" name="">
             <a:extLst xmlns:a="http://schemas.openxmlformats.org/drawingml/2006/main">
               <a:ext uri="{FF2B5EF4-FFF2-40B4-BE49-F238E27FC236}">
-                <a16:creationId xmlns:a16="http://schemas.microsoft.com/office/drawing/2014/main" id="{85D09BEC-6FCF-48A5-AD7A-420459D5612A}"/>
+                <a16:creationId xmlns:a16="http://schemas.microsoft.com/office/drawing/2014/main" id="{5F6B9DEC-34AD-4742-B113-20E340A3E2DC}"/>
               </a:ext>
             </a:extLst>
           </p:cNvPr>
@@ -2344,7 +2415,7 @@
           <p:cNvPr id="18" name="">
             <a:extLst xmlns:a="http://schemas.openxmlformats.org/drawingml/2006/main">
               <a:ext uri="{FF2B5EF4-FFF2-40B4-BE49-F238E27FC236}">
-                <a16:creationId xmlns:a16="http://schemas.microsoft.com/office/drawing/2014/main" id="{F27564CD-40A5-4A66-AADA-ECB5C6F8FBFC}"/>
+                <a16:creationId xmlns:a16="http://schemas.microsoft.com/office/drawing/2014/main" id="{17B2F95E-2021-4F96-B189-D4D911B06828}"/>
               </a:ext>
             </a:extLst>
           </p:cNvPr>
@@ -2401,7 +2472,7 @@
           <p:cNvPr id="19" name="">
             <a:extLst xmlns:a="http://schemas.openxmlformats.org/drawingml/2006/main">
               <a:ext uri="{FF2B5EF4-FFF2-40B4-BE49-F238E27FC236}">
-                <a16:creationId xmlns:a16="http://schemas.microsoft.com/office/drawing/2014/main" id="{3838989E-DF74-4B5B-AE0C-CC46D393C893}"/>
+                <a16:creationId xmlns:a16="http://schemas.microsoft.com/office/drawing/2014/main" id="{F8CB6FEE-BC77-4A60-9A63-A898972A0F98}"/>
               </a:ext>
             </a:extLst>
           </p:cNvPr>
@@ -2431,7 +2502,7 @@
           <p:cNvPr id="20" name="">
             <a:extLst xmlns:a="http://schemas.openxmlformats.org/drawingml/2006/main">
               <a:ext uri="{FF2B5EF4-FFF2-40B4-BE49-F238E27FC236}">
-                <a16:creationId xmlns:a16="http://schemas.microsoft.com/office/drawing/2014/main" id="{0937AB40-6408-4047-8013-6605D3E9FCFF}"/>
+                <a16:creationId xmlns:a16="http://schemas.microsoft.com/office/drawing/2014/main" id="{BE34CEE4-3DE6-4045-9EEE-F97BA3377A89}"/>
               </a:ext>
             </a:extLst>
           </p:cNvPr>
@@ -2504,7 +2575,7 @@
           <p:cNvPr id="21" name="">
             <a:extLst xmlns:a="http://schemas.openxmlformats.org/drawingml/2006/main">
               <a:ext uri="{FF2B5EF4-FFF2-40B4-BE49-F238E27FC236}">
-                <a16:creationId xmlns:a16="http://schemas.microsoft.com/office/drawing/2014/main" id="{3F373B01-C8F7-43BB-8BA6-B501D584F0E9}"/>
+                <a16:creationId xmlns:a16="http://schemas.microsoft.com/office/drawing/2014/main" id="{CBA5B887-E59E-4364-940E-1F81E0350F37}"/>
               </a:ext>
             </a:extLst>
           </p:cNvPr>
@@ -2551,7 +2622,7 @@
           <p:cNvPr id="22" name="">
             <a:extLst xmlns:a="http://schemas.openxmlformats.org/drawingml/2006/main">
               <a:ext uri="{FF2B5EF4-FFF2-40B4-BE49-F238E27FC236}">
-                <a16:creationId xmlns:a16="http://schemas.microsoft.com/office/drawing/2014/main" id="{93A7BB5E-022E-4EFE-8C9A-5D75C9006FF4}"/>
+                <a16:creationId xmlns:a16="http://schemas.microsoft.com/office/drawing/2014/main" id="{EB7B498D-7590-4A39-A781-22B766A1D8AE}"/>
               </a:ext>
             </a:extLst>
           </p:cNvPr>
@@ -2606,7 +2677,7 @@
     </p:spTree>
     <p:extLst>
       <p:ext uri="{BB962C8B-B14F-4D97-AF65-F5344CB8AC3E}">
-        <p14:creationId xmlns:p14="http://schemas.microsoft.com/office/powerpoint/2010/main" val="1515950008"/>
+        <p14:creationId xmlns:p14="http://schemas.microsoft.com/office/powerpoint/2010/main" val="1830093650"/>
       </p:ext>
     </p:extLst>
   </p:cSld>
@@ -2641,7 +2712,7 @@
           <p:nvPr/>
         </p:nvPicPr>
         <p:blipFill>
-          <a:blip xmlns:r="http://schemas.openxmlformats.org/officeDocument/2006/relationships" xmlns:a="http://schemas.openxmlformats.org/drawingml/2006/main" r:embed="R50d13fc6094c45aa"/>
+          <a:blip xmlns:r="http://schemas.openxmlformats.org/officeDocument/2006/relationships" xmlns:a="http://schemas.openxmlformats.org/drawingml/2006/main" r:embed="Rb6a8bd8aca6a4ae7"/>
           <a:srcRect xmlns:a="http://schemas.openxmlformats.org/drawingml/2006/main" l="0" t="0" r="0" b="0"/>
           <a:stretch xmlns:a="http://schemas.openxmlformats.org/drawingml/2006/main">
             <a:fillRect l="0" t="0" r="0" b="0"/>
@@ -2662,7 +2733,7 @@
           <p:cNvPr id="2" name="">
             <a:extLst xmlns:a="http://schemas.openxmlformats.org/drawingml/2006/main">
               <a:ext uri="{FF2B5EF4-FFF2-40B4-BE49-F238E27FC236}">
-                <a16:creationId xmlns:a16="http://schemas.microsoft.com/office/drawing/2014/main" id="{A075D9CD-4A97-465F-9CEF-43B2C2BEF473}"/>
+                <a16:creationId xmlns:a16="http://schemas.microsoft.com/office/drawing/2014/main" id="{DEDCF0E3-05E9-4946-A2E8-54EFA87A958E}"/>
               </a:ext>
             </a:extLst>
           </p:cNvPr>
@@ -2709,7 +2780,7 @@
           <p:cNvPr id="3" name="">
             <a:extLst xmlns:a="http://schemas.openxmlformats.org/drawingml/2006/main">
               <a:ext uri="{FF2B5EF4-FFF2-40B4-BE49-F238E27FC236}">
-                <a16:creationId xmlns:a16="http://schemas.microsoft.com/office/drawing/2014/main" id="{E01E38A4-FABD-4FE0-B010-BE313B9B51FC}"/>
+                <a16:creationId xmlns:a16="http://schemas.microsoft.com/office/drawing/2014/main" id="{6A2CE70C-ADAE-474A-937B-C2960D4D6F0F}"/>
               </a:ext>
             </a:extLst>
           </p:cNvPr>
@@ -2769,7 +2840,7 @@
           <p:cNvPr id="4" name="">
             <a:extLst xmlns:a="http://schemas.openxmlformats.org/drawingml/2006/main">
               <a:ext uri="{FF2B5EF4-FFF2-40B4-BE49-F238E27FC236}">
-                <a16:creationId xmlns:a16="http://schemas.microsoft.com/office/drawing/2014/main" id="{16720C64-7553-4F23-889E-6E2E2A6496C1}"/>
+                <a16:creationId xmlns:a16="http://schemas.microsoft.com/office/drawing/2014/main" id="{66577C25-9CE9-4DCD-87C2-274FFBECF642}"/>
               </a:ext>
             </a:extLst>
           </p:cNvPr>
@@ -2816,7 +2887,7 @@
           <p:cNvPr id="5" name="">
             <a:extLst xmlns:a="http://schemas.openxmlformats.org/drawingml/2006/main">
               <a:ext uri="{FF2B5EF4-FFF2-40B4-BE49-F238E27FC236}">
-                <a16:creationId xmlns:a16="http://schemas.microsoft.com/office/drawing/2014/main" id="{0360C2D2-A447-44F0-AE72-2A3764CFAB82}"/>
+                <a16:creationId xmlns:a16="http://schemas.microsoft.com/office/drawing/2014/main" id="{371165B8-EBDB-4A9D-8805-9F9C35887FB1}"/>
               </a:ext>
             </a:extLst>
           </p:cNvPr>
@@ -2873,7 +2944,7 @@
           <p:cNvPr id="6" name="">
             <a:extLst xmlns:a="http://schemas.openxmlformats.org/drawingml/2006/main">
               <a:ext uri="{FF2B5EF4-FFF2-40B4-BE49-F238E27FC236}">
-                <a16:creationId xmlns:a16="http://schemas.microsoft.com/office/drawing/2014/main" id="{A99B405A-D115-4433-9628-7DAB4FE1D181}"/>
+                <a16:creationId xmlns:a16="http://schemas.microsoft.com/office/drawing/2014/main" id="{5711E873-F185-44DB-B43E-104B9E508D67}"/>
               </a:ext>
             </a:extLst>
           </p:cNvPr>
@@ -2907,7 +2978,7 @@
           <p:cNvPr id="7" name="">
             <a:extLst xmlns:a="http://schemas.openxmlformats.org/drawingml/2006/main">
               <a:ext uri="{FF2B5EF4-FFF2-40B4-BE49-F238E27FC236}">
-                <a16:creationId xmlns:a16="http://schemas.microsoft.com/office/drawing/2014/main" id="{F5AB5A5D-BF4B-430C-A991-E3DECE1B71BF}"/>
+                <a16:creationId xmlns:a16="http://schemas.microsoft.com/office/drawing/2014/main" id="{09209C9F-9D4A-4087-961A-4A045374390F}"/>
               </a:ext>
             </a:extLst>
           </p:cNvPr>
@@ -2967,7 +3038,7 @@
           <p:cNvPr id="8" name="">
             <a:extLst xmlns:a="http://schemas.openxmlformats.org/drawingml/2006/main">
               <a:ext uri="{FF2B5EF4-FFF2-40B4-BE49-F238E27FC236}">
-                <a16:creationId xmlns:a16="http://schemas.microsoft.com/office/drawing/2014/main" id="{A98C1A8C-4763-4370-98A3-011BDE99E814}"/>
+                <a16:creationId xmlns:a16="http://schemas.microsoft.com/office/drawing/2014/main" id="{03A5D5B2-DCD1-4511-968E-E66A17E8B48D}"/>
               </a:ext>
             </a:extLst>
           </p:cNvPr>
@@ -3014,7 +3085,7 @@
           <p:cNvPr id="9" name="">
             <a:extLst xmlns:a="http://schemas.openxmlformats.org/drawingml/2006/main">
               <a:ext uri="{FF2B5EF4-FFF2-40B4-BE49-F238E27FC236}">
-                <a16:creationId xmlns:a16="http://schemas.microsoft.com/office/drawing/2014/main" id="{3387FCA9-E807-4FB2-9867-E6A1EDDAC890}"/>
+                <a16:creationId xmlns:a16="http://schemas.microsoft.com/office/drawing/2014/main" id="{1CCF973F-2872-4603-BAC7-4939B56DD30B}"/>
               </a:ext>
             </a:extLst>
           </p:cNvPr>
@@ -3061,7 +3132,7 @@
           <p:cNvPr id="10" name="">
             <a:extLst xmlns:a="http://schemas.openxmlformats.org/drawingml/2006/main">
               <a:ext uri="{FF2B5EF4-FFF2-40B4-BE49-F238E27FC236}">
-                <a16:creationId xmlns:a16="http://schemas.microsoft.com/office/drawing/2014/main" id="{5925B920-398B-4730-B4A9-CCA806F642F5}"/>
+                <a16:creationId xmlns:a16="http://schemas.microsoft.com/office/drawing/2014/main" id="{6EE8C7DE-7FF1-4595-9EE8-988AAAF910B9}"/>
               </a:ext>
             </a:extLst>
           </p:cNvPr>
@@ -3095,7 +3166,7 @@
           <p:cNvPr id="11" name="">
             <a:extLst xmlns:a="http://schemas.openxmlformats.org/drawingml/2006/main">
               <a:ext uri="{FF2B5EF4-FFF2-40B4-BE49-F238E27FC236}">
-                <a16:creationId xmlns:a16="http://schemas.microsoft.com/office/drawing/2014/main" id="{B6CF99B9-982C-451B-B3CB-03EF16C80F5D}"/>
+                <a16:creationId xmlns:a16="http://schemas.microsoft.com/office/drawing/2014/main" id="{5CCA4735-06A7-4A71-91B1-E01EEAFD1C52}"/>
               </a:ext>
             </a:extLst>
           </p:cNvPr>
@@ -3142,7 +3213,7 @@
           <p:cNvPr id="12" name="">
             <a:extLst xmlns:a="http://schemas.openxmlformats.org/drawingml/2006/main">
               <a:ext uri="{FF2B5EF4-FFF2-40B4-BE49-F238E27FC236}">
-                <a16:creationId xmlns:a16="http://schemas.microsoft.com/office/drawing/2014/main" id="{35504C91-1300-435E-88F9-DA5676F4B857}"/>
+                <a16:creationId xmlns:a16="http://schemas.microsoft.com/office/drawing/2014/main" id="{8F81C259-51F5-4760-8194-C8D1C45298AC}"/>
               </a:ext>
             </a:extLst>
           </p:cNvPr>
@@ -3189,7 +3260,7 @@
           <p:cNvPr id="13" name="">
             <a:extLst xmlns:a="http://schemas.openxmlformats.org/drawingml/2006/main">
               <a:ext uri="{FF2B5EF4-FFF2-40B4-BE49-F238E27FC236}">
-                <a16:creationId xmlns:a16="http://schemas.microsoft.com/office/drawing/2014/main" id="{18B30376-72DF-4E01-916B-A1EA8FF07DF6}"/>
+                <a16:creationId xmlns:a16="http://schemas.microsoft.com/office/drawing/2014/main" id="{5E491F3F-2E83-459C-AFD7-EDFAEB4A045D}"/>
               </a:ext>
             </a:extLst>
           </p:cNvPr>
@@ -3223,7 +3294,7 @@
           <p:cNvPr id="14" name="">
             <a:extLst xmlns:a="http://schemas.openxmlformats.org/drawingml/2006/main">
               <a:ext uri="{FF2B5EF4-FFF2-40B4-BE49-F238E27FC236}">
-                <a16:creationId xmlns:a16="http://schemas.microsoft.com/office/drawing/2014/main" id="{DB978575-D007-4936-AEDF-74F2F159FF0C}"/>
+                <a16:creationId xmlns:a16="http://schemas.microsoft.com/office/drawing/2014/main" id="{BC39CD06-C733-4464-BFC6-6DE684A3777B}"/>
               </a:ext>
             </a:extLst>
           </p:cNvPr>
@@ -3270,7 +3341,7 @@
           <p:cNvPr id="15" name="">
             <a:extLst xmlns:a="http://schemas.openxmlformats.org/drawingml/2006/main">
               <a:ext uri="{FF2B5EF4-FFF2-40B4-BE49-F238E27FC236}">
-                <a16:creationId xmlns:a16="http://schemas.microsoft.com/office/drawing/2014/main" id="{FAF71905-CA34-499D-BF32-C330C804BC91}"/>
+                <a16:creationId xmlns:a16="http://schemas.microsoft.com/office/drawing/2014/main" id="{68B49C89-BEA1-4C6E-A034-6DEA57EACD49}"/>
               </a:ext>
             </a:extLst>
           </p:cNvPr>
@@ -3317,7 +3388,7 @@
           <p:cNvPr id="16" name="">
             <a:extLst xmlns:a="http://schemas.openxmlformats.org/drawingml/2006/main">
               <a:ext uri="{FF2B5EF4-FFF2-40B4-BE49-F238E27FC236}">
-                <a16:creationId xmlns:a16="http://schemas.microsoft.com/office/drawing/2014/main" id="{55AB1194-00F8-4629-9865-749DE670E609}"/>
+                <a16:creationId xmlns:a16="http://schemas.microsoft.com/office/drawing/2014/main" id="{149E510E-F51D-4652-B95E-720267A10212}"/>
               </a:ext>
             </a:extLst>
           </p:cNvPr>
@@ -3351,7 +3422,7 @@
           <p:cNvPr id="17" name="">
             <a:extLst xmlns:a="http://schemas.openxmlformats.org/drawingml/2006/main">
               <a:ext uri="{FF2B5EF4-FFF2-40B4-BE49-F238E27FC236}">
-                <a16:creationId xmlns:a16="http://schemas.microsoft.com/office/drawing/2014/main" id="{78F5D1AE-0242-4AB7-8411-E7EAF8617B79}"/>
+                <a16:creationId xmlns:a16="http://schemas.microsoft.com/office/drawing/2014/main" id="{6F9778E3-164A-47E0-B39D-AA035E318BC2}"/>
               </a:ext>
             </a:extLst>
           </p:cNvPr>
@@ -3398,7 +3469,7 @@
           <p:cNvPr id="18" name="">
             <a:extLst xmlns:a="http://schemas.openxmlformats.org/drawingml/2006/main">
               <a:ext uri="{FF2B5EF4-FFF2-40B4-BE49-F238E27FC236}">
-                <a16:creationId xmlns:a16="http://schemas.microsoft.com/office/drawing/2014/main" id="{9C5C6CDA-9B88-4B67-85F3-0C63C2436061}"/>
+                <a16:creationId xmlns:a16="http://schemas.microsoft.com/office/drawing/2014/main" id="{A9656299-5099-45CC-B223-42D86ACA664F}"/>
               </a:ext>
             </a:extLst>
           </p:cNvPr>
@@ -3445,7 +3516,7 @@
           <p:cNvPr id="19" name="">
             <a:extLst xmlns:a="http://schemas.openxmlformats.org/drawingml/2006/main">
               <a:ext uri="{FF2B5EF4-FFF2-40B4-BE49-F238E27FC236}">
-                <a16:creationId xmlns:a16="http://schemas.microsoft.com/office/drawing/2014/main" id="{97E6D868-4D5D-4A46-BD54-9B317E036064}"/>
+                <a16:creationId xmlns:a16="http://schemas.microsoft.com/office/drawing/2014/main" id="{34E91A72-6CA3-4071-AD19-448CEC02E872}"/>
               </a:ext>
             </a:extLst>
           </p:cNvPr>
@@ -3479,7 +3550,7 @@
           <p:cNvPr id="20" name="">
             <a:extLst xmlns:a="http://schemas.openxmlformats.org/drawingml/2006/main">
               <a:ext uri="{FF2B5EF4-FFF2-40B4-BE49-F238E27FC236}">
-                <a16:creationId xmlns:a16="http://schemas.microsoft.com/office/drawing/2014/main" id="{CD99C3B3-09F5-4845-A094-30E14203812C}"/>
+                <a16:creationId xmlns:a16="http://schemas.microsoft.com/office/drawing/2014/main" id="{913C1C82-1ADC-48BF-8E7B-036A5B6F01EC}"/>
               </a:ext>
             </a:extLst>
           </p:cNvPr>
@@ -3526,7 +3597,7 @@
           <p:cNvPr id="21" name="">
             <a:extLst xmlns:a="http://schemas.openxmlformats.org/drawingml/2006/main">
               <a:ext uri="{FF2B5EF4-FFF2-40B4-BE49-F238E27FC236}">
-                <a16:creationId xmlns:a16="http://schemas.microsoft.com/office/drawing/2014/main" id="{4F6EACDA-F948-4BA7-9D43-244613102A30}"/>
+                <a16:creationId xmlns:a16="http://schemas.microsoft.com/office/drawing/2014/main" id="{B97F8635-7662-4812-A4A6-1185BE881F13}"/>
               </a:ext>
             </a:extLst>
           </p:cNvPr>
@@ -3573,7 +3644,7 @@
           <p:cNvPr id="22" name="">
             <a:extLst xmlns:a="http://schemas.openxmlformats.org/drawingml/2006/main">
               <a:ext uri="{FF2B5EF4-FFF2-40B4-BE49-F238E27FC236}">
-                <a16:creationId xmlns:a16="http://schemas.microsoft.com/office/drawing/2014/main" id="{1EEBB38C-090A-47E6-9081-469F64B8A8BC}"/>
+                <a16:creationId xmlns:a16="http://schemas.microsoft.com/office/drawing/2014/main" id="{AFC5163E-7B76-4CA2-9325-F5F432A2C2C6}"/>
               </a:ext>
             </a:extLst>
           </p:cNvPr>
@@ -3603,7 +3674,7 @@
           <p:cNvPr id="23" name="">
             <a:extLst xmlns:a="http://schemas.openxmlformats.org/drawingml/2006/main">
               <a:ext uri="{FF2B5EF4-FFF2-40B4-BE49-F238E27FC236}">
-                <a16:creationId xmlns:a16="http://schemas.microsoft.com/office/drawing/2014/main" id="{38A3CB9D-57D6-4902-8CA5-55CD801643B0}"/>
+                <a16:creationId xmlns:a16="http://schemas.microsoft.com/office/drawing/2014/main" id="{E80F08E0-01BC-4A06-8191-345E939B8391}"/>
               </a:ext>
             </a:extLst>
           </p:cNvPr>
@@ -3648,7 +3719,7 @@
     </p:spTree>
     <p:extLst>
       <p:ext uri="{BB962C8B-B14F-4D97-AF65-F5344CB8AC3E}">
-        <p14:creationId xmlns:p14="http://schemas.microsoft.com/office/powerpoint/2010/main" val="2053052634"/>
+        <p14:creationId xmlns:p14="http://schemas.microsoft.com/office/powerpoint/2010/main" val="1384174491"/>
       </p:ext>
     </p:extLst>
   </p:cSld>
@@ -3683,7 +3754,7 @@
           <p:nvPr/>
         </p:nvPicPr>
         <p:blipFill>
-          <a:blip xmlns:r="http://schemas.openxmlformats.org/officeDocument/2006/relationships" xmlns:a="http://schemas.openxmlformats.org/drawingml/2006/main" r:embed="R90313174aea74cad"/>
+          <a:blip xmlns:r="http://schemas.openxmlformats.org/officeDocument/2006/relationships" xmlns:a="http://schemas.openxmlformats.org/drawingml/2006/main" r:embed="R446febec2fdf485c"/>
           <a:srcRect xmlns:a="http://schemas.openxmlformats.org/drawingml/2006/main" l="0" t="0" r="0" b="0"/>
           <a:stretch xmlns:a="http://schemas.openxmlformats.org/drawingml/2006/main">
             <a:fillRect l="0" t="0" r="0" b="0"/>
@@ -3704,7 +3775,7 @@
           <p:cNvPr id="2" name="">
             <a:extLst xmlns:a="http://schemas.openxmlformats.org/drawingml/2006/main">
               <a:ext uri="{FF2B5EF4-FFF2-40B4-BE49-F238E27FC236}">
-                <a16:creationId xmlns:a16="http://schemas.microsoft.com/office/drawing/2014/main" id="{BFDACDF7-48F7-44C8-A729-601B3E1BE950}"/>
+                <a16:creationId xmlns:a16="http://schemas.microsoft.com/office/drawing/2014/main" id="{1F69E7AD-E981-4FE6-AE8D-017777EAE111}"/>
               </a:ext>
             </a:extLst>
           </p:cNvPr>
@@ -3751,7 +3822,7 @@
           <p:cNvPr id="3" name="">
             <a:extLst xmlns:a="http://schemas.openxmlformats.org/drawingml/2006/main">
               <a:ext uri="{FF2B5EF4-FFF2-40B4-BE49-F238E27FC236}">
-                <a16:creationId xmlns:a16="http://schemas.microsoft.com/office/drawing/2014/main" id="{C8430216-9EC6-4701-9901-BD2DC5F436D5}"/>
+                <a16:creationId xmlns:a16="http://schemas.microsoft.com/office/drawing/2014/main" id="{F84B42C4-53B4-4E0D-B02E-F16E390AE1F1}"/>
               </a:ext>
             </a:extLst>
           </p:cNvPr>
@@ -3811,7 +3882,7 @@
           <p:cNvPr id="4" name="">
             <a:extLst xmlns:a="http://schemas.openxmlformats.org/drawingml/2006/main">
               <a:ext uri="{FF2B5EF4-FFF2-40B4-BE49-F238E27FC236}">
-                <a16:creationId xmlns:a16="http://schemas.microsoft.com/office/drawing/2014/main" id="{92CFAC22-E2AF-4FAB-8CF6-2213718B0E33}"/>
+                <a16:creationId xmlns:a16="http://schemas.microsoft.com/office/drawing/2014/main" id="{E371A1CE-1F29-447B-A369-9ACEE814754C}"/>
               </a:ext>
             </a:extLst>
           </p:cNvPr>
@@ -3858,7 +3929,7 @@
           <p:cNvPr id="5" name="">
             <a:extLst xmlns:a="http://schemas.openxmlformats.org/drawingml/2006/main">
               <a:ext uri="{FF2B5EF4-FFF2-40B4-BE49-F238E27FC236}">
-                <a16:creationId xmlns:a16="http://schemas.microsoft.com/office/drawing/2014/main" id="{B91E98EE-FC88-4693-AFF6-811676641AB1}"/>
+                <a16:creationId xmlns:a16="http://schemas.microsoft.com/office/drawing/2014/main" id="{6F5A0A52-A08A-4766-9199-DE3248A0D3AB}"/>
               </a:ext>
             </a:extLst>
           </p:cNvPr>
@@ -3915,7 +3986,7 @@
           <p:cNvPr id="6" name="">
             <a:extLst xmlns:a="http://schemas.openxmlformats.org/drawingml/2006/main">
               <a:ext uri="{FF2B5EF4-FFF2-40B4-BE49-F238E27FC236}">
-                <a16:creationId xmlns:a16="http://schemas.microsoft.com/office/drawing/2014/main" id="{1EA0A5F4-AD84-428A-ADD8-75939700D0F5}"/>
+                <a16:creationId xmlns:a16="http://schemas.microsoft.com/office/drawing/2014/main" id="{8EAE699B-D50E-41CD-B6BC-AE483E14E70D}"/>
               </a:ext>
             </a:extLst>
           </p:cNvPr>
@@ -3949,7 +4020,7 @@
           <p:cNvPr id="7" name="">
             <a:extLst xmlns:a="http://schemas.openxmlformats.org/drawingml/2006/main">
               <a:ext uri="{FF2B5EF4-FFF2-40B4-BE49-F238E27FC236}">
-                <a16:creationId xmlns:a16="http://schemas.microsoft.com/office/drawing/2014/main" id="{3E1ADCC0-901D-46DB-9EC0-816BFF9685A7}"/>
+                <a16:creationId xmlns:a16="http://schemas.microsoft.com/office/drawing/2014/main" id="{CB9B6D6B-8C3F-49DD-8DF6-22BC0DD1C458}"/>
               </a:ext>
             </a:extLst>
           </p:cNvPr>
@@ -3996,7 +4067,7 @@
           <p:cNvPr id="8" name="">
             <a:extLst xmlns:a="http://schemas.openxmlformats.org/drawingml/2006/main">
               <a:ext uri="{FF2B5EF4-FFF2-40B4-BE49-F238E27FC236}">
-                <a16:creationId xmlns:a16="http://schemas.microsoft.com/office/drawing/2014/main" id="{B0D5F83A-C52A-49E8-BEEE-3D918FBC681B}"/>
+                <a16:creationId xmlns:a16="http://schemas.microsoft.com/office/drawing/2014/main" id="{DE942173-EF2E-4E6D-82C6-C3237023D012}"/>
               </a:ext>
             </a:extLst>
           </p:cNvPr>
@@ -4056,7 +4127,7 @@
           <p:cNvPr id="9" name="">
             <a:extLst xmlns:a="http://schemas.openxmlformats.org/drawingml/2006/main">
               <a:ext uri="{FF2B5EF4-FFF2-40B4-BE49-F238E27FC236}">
-                <a16:creationId xmlns:a16="http://schemas.microsoft.com/office/drawing/2014/main" id="{7E930DD4-8704-4BB0-980C-6F95E10E5378}"/>
+                <a16:creationId xmlns:a16="http://schemas.microsoft.com/office/drawing/2014/main" id="{83F4BF82-23D4-4FF9-992E-9493F913EAE9}"/>
               </a:ext>
             </a:extLst>
           </p:cNvPr>
@@ -4086,7 +4157,7 @@
           <p:cNvPr id="10" name="">
             <a:extLst xmlns:a="http://schemas.openxmlformats.org/drawingml/2006/main">
               <a:ext uri="{FF2B5EF4-FFF2-40B4-BE49-F238E27FC236}">
-                <a16:creationId xmlns:a16="http://schemas.microsoft.com/office/drawing/2014/main" id="{B3DB0933-B1BC-45CF-BF68-3288BBCF91ED}"/>
+                <a16:creationId xmlns:a16="http://schemas.microsoft.com/office/drawing/2014/main" id="{2BC3A905-C6BA-401C-B7B0-5C889C6505B8}"/>
               </a:ext>
             </a:extLst>
           </p:cNvPr>
@@ -4116,7 +4187,7 @@
           <p:cNvPr id="11" name="">
             <a:extLst xmlns:a="http://schemas.openxmlformats.org/drawingml/2006/main">
               <a:ext uri="{FF2B5EF4-FFF2-40B4-BE49-F238E27FC236}">
-                <a16:creationId xmlns:a16="http://schemas.microsoft.com/office/drawing/2014/main" id="{F6A2CA78-4A38-4E3C-8231-B4615E9FDB24}"/>
+                <a16:creationId xmlns:a16="http://schemas.microsoft.com/office/drawing/2014/main" id="{20996AE7-10D4-4C2E-BE5E-99235D8CC8C8}"/>
               </a:ext>
             </a:extLst>
           </p:cNvPr>
@@ -4150,7 +4221,7 @@
           <p:cNvPr id="12" name="">
             <a:extLst xmlns:a="http://schemas.openxmlformats.org/drawingml/2006/main">
               <a:ext uri="{FF2B5EF4-FFF2-40B4-BE49-F238E27FC236}">
-                <a16:creationId xmlns:a16="http://schemas.microsoft.com/office/drawing/2014/main" id="{A70D695F-8562-48BC-88FB-BFFFD62CCFCA}"/>
+                <a16:creationId xmlns:a16="http://schemas.microsoft.com/office/drawing/2014/main" id="{E3D9DEF5-B1DC-4488-B373-744E93384650}"/>
               </a:ext>
             </a:extLst>
           </p:cNvPr>
@@ -4197,7 +4268,7 @@
           <p:cNvPr id="13" name="">
             <a:extLst xmlns:a="http://schemas.openxmlformats.org/drawingml/2006/main">
               <a:ext uri="{FF2B5EF4-FFF2-40B4-BE49-F238E27FC236}">
-                <a16:creationId xmlns:a16="http://schemas.microsoft.com/office/drawing/2014/main" id="{BA2E1791-E583-49F1-82FD-A29C609F6011}"/>
+                <a16:creationId xmlns:a16="http://schemas.microsoft.com/office/drawing/2014/main" id="{46A7BBE8-734D-4541-85D3-87A73AD3FF3E}"/>
               </a:ext>
             </a:extLst>
           </p:cNvPr>
@@ -4257,7 +4328,7 @@
           <p:cNvPr id="14" name="">
             <a:extLst xmlns:a="http://schemas.openxmlformats.org/drawingml/2006/main">
               <a:ext uri="{FF2B5EF4-FFF2-40B4-BE49-F238E27FC236}">
-                <a16:creationId xmlns:a16="http://schemas.microsoft.com/office/drawing/2014/main" id="{A5BA3623-72AC-4C0A-BDD6-9D4284A8369D}"/>
+                <a16:creationId xmlns:a16="http://schemas.microsoft.com/office/drawing/2014/main" id="{4CFFA1A0-7350-4243-9633-29EDA8066F2E}"/>
               </a:ext>
             </a:extLst>
           </p:cNvPr>
@@ -4287,7 +4358,7 @@
           <p:cNvPr id="15" name="">
             <a:extLst xmlns:a="http://schemas.openxmlformats.org/drawingml/2006/main">
               <a:ext uri="{FF2B5EF4-FFF2-40B4-BE49-F238E27FC236}">
-                <a16:creationId xmlns:a16="http://schemas.microsoft.com/office/drawing/2014/main" id="{1DFD22DC-148B-4520-81EE-D77D5158F703}"/>
+                <a16:creationId xmlns:a16="http://schemas.microsoft.com/office/drawing/2014/main" id="{BEA38414-1735-4654-B866-29CDF30C3624}"/>
               </a:ext>
             </a:extLst>
           </p:cNvPr>
@@ -4317,7 +4388,7 @@
           <p:cNvPr id="16" name="">
             <a:extLst xmlns:a="http://schemas.openxmlformats.org/drawingml/2006/main">
               <a:ext uri="{FF2B5EF4-FFF2-40B4-BE49-F238E27FC236}">
-                <a16:creationId xmlns:a16="http://schemas.microsoft.com/office/drawing/2014/main" id="{F0EC5604-DA9C-4089-BFFD-1C1FB6E3F425}"/>
+                <a16:creationId xmlns:a16="http://schemas.microsoft.com/office/drawing/2014/main" id="{82D3085D-E0D5-4F54-8D1B-BDB02195FE82}"/>
               </a:ext>
             </a:extLst>
           </p:cNvPr>
@@ -4351,7 +4422,7 @@
           <p:cNvPr id="17" name="">
             <a:extLst xmlns:a="http://schemas.openxmlformats.org/drawingml/2006/main">
               <a:ext uri="{FF2B5EF4-FFF2-40B4-BE49-F238E27FC236}">
-                <a16:creationId xmlns:a16="http://schemas.microsoft.com/office/drawing/2014/main" id="{0BF9A376-B02C-40B3-8691-BFC1BFE506CF}"/>
+                <a16:creationId xmlns:a16="http://schemas.microsoft.com/office/drawing/2014/main" id="{31AF256F-1566-40D4-B434-D89F44323FAF}"/>
               </a:ext>
             </a:extLst>
           </p:cNvPr>
@@ -4398,7 +4469,7 @@
           <p:cNvPr id="18" name="">
             <a:extLst xmlns:a="http://schemas.openxmlformats.org/drawingml/2006/main">
               <a:ext uri="{FF2B5EF4-FFF2-40B4-BE49-F238E27FC236}">
-                <a16:creationId xmlns:a16="http://schemas.microsoft.com/office/drawing/2014/main" id="{EAB0B18D-EC4E-4526-9DB2-B9FFD5C99335}"/>
+                <a16:creationId xmlns:a16="http://schemas.microsoft.com/office/drawing/2014/main" id="{9C2320E6-FF90-484E-911A-F638364288AD}"/>
               </a:ext>
             </a:extLst>
           </p:cNvPr>
@@ -4458,7 +4529,7 @@
           <p:cNvPr id="19" name="">
             <a:extLst xmlns:a="http://schemas.openxmlformats.org/drawingml/2006/main">
               <a:ext uri="{FF2B5EF4-FFF2-40B4-BE49-F238E27FC236}">
-                <a16:creationId xmlns:a16="http://schemas.microsoft.com/office/drawing/2014/main" id="{F0FBD15C-DEE5-483E-8697-1AA9B60420B2}"/>
+                <a16:creationId xmlns:a16="http://schemas.microsoft.com/office/drawing/2014/main" id="{CE2E72C7-D830-4075-8DC3-DC3A9133877F}"/>
               </a:ext>
             </a:extLst>
           </p:cNvPr>
@@ -4488,7 +4559,7 @@
           <p:cNvPr id="20" name="">
             <a:extLst xmlns:a="http://schemas.openxmlformats.org/drawingml/2006/main">
               <a:ext uri="{FF2B5EF4-FFF2-40B4-BE49-F238E27FC236}">
-                <a16:creationId xmlns:a16="http://schemas.microsoft.com/office/drawing/2014/main" id="{7AE82E50-F042-4CB1-A7FF-9B61CCA5FC97}"/>
+                <a16:creationId xmlns:a16="http://schemas.microsoft.com/office/drawing/2014/main" id="{15D20A9C-3C63-470F-8F33-6FE8A881B934}"/>
               </a:ext>
             </a:extLst>
           </p:cNvPr>
@@ -4518,7 +4589,7 @@
           <p:cNvPr id="21" name="">
             <a:extLst xmlns:a="http://schemas.openxmlformats.org/drawingml/2006/main">
               <a:ext uri="{FF2B5EF4-FFF2-40B4-BE49-F238E27FC236}">
-                <a16:creationId xmlns:a16="http://schemas.microsoft.com/office/drawing/2014/main" id="{FFCC54E0-C1EF-4172-AAC8-E858267246EE}"/>
+                <a16:creationId xmlns:a16="http://schemas.microsoft.com/office/drawing/2014/main" id="{8D07A466-1B05-473C-9E85-7A256F93B1E7}"/>
               </a:ext>
             </a:extLst>
           </p:cNvPr>
@@ -4552,7 +4623,7 @@
           <p:cNvPr id="22" name="">
             <a:extLst xmlns:a="http://schemas.openxmlformats.org/drawingml/2006/main">
               <a:ext uri="{FF2B5EF4-FFF2-40B4-BE49-F238E27FC236}">
-                <a16:creationId xmlns:a16="http://schemas.microsoft.com/office/drawing/2014/main" id="{9AF81413-0233-4A8F-B8B7-D4D6D04072B6}"/>
+                <a16:creationId xmlns:a16="http://schemas.microsoft.com/office/drawing/2014/main" id="{8F59E034-49B6-4693-BCE3-E2FEBA5CB048}"/>
               </a:ext>
             </a:extLst>
           </p:cNvPr>
@@ -4599,7 +4670,7 @@
           <p:cNvPr id="23" name="">
             <a:extLst xmlns:a="http://schemas.openxmlformats.org/drawingml/2006/main">
               <a:ext uri="{FF2B5EF4-FFF2-40B4-BE49-F238E27FC236}">
-                <a16:creationId xmlns:a16="http://schemas.microsoft.com/office/drawing/2014/main" id="{9F1C4399-66A6-4465-9EC0-60F3F72DD064}"/>
+                <a16:creationId xmlns:a16="http://schemas.microsoft.com/office/drawing/2014/main" id="{2C1DE4A3-90D6-449B-9A03-C29E4EE44D28}"/>
               </a:ext>
             </a:extLst>
           </p:cNvPr>
@@ -4659,7 +4730,7 @@
           <p:cNvPr id="24" name="">
             <a:extLst xmlns:a="http://schemas.openxmlformats.org/drawingml/2006/main">
               <a:ext uri="{FF2B5EF4-FFF2-40B4-BE49-F238E27FC236}">
-                <a16:creationId xmlns:a16="http://schemas.microsoft.com/office/drawing/2014/main" id="{248B36B1-5D7E-4970-9CE0-20DE6A7F16F5}"/>
+                <a16:creationId xmlns:a16="http://schemas.microsoft.com/office/drawing/2014/main" id="{33FAFFA5-595B-4CFD-BD55-C77B70132963}"/>
               </a:ext>
             </a:extLst>
           </p:cNvPr>
@@ -4689,7 +4760,7 @@
           <p:cNvPr id="25" name="">
             <a:extLst xmlns:a="http://schemas.openxmlformats.org/drawingml/2006/main">
               <a:ext uri="{FF2B5EF4-FFF2-40B4-BE49-F238E27FC236}">
-                <a16:creationId xmlns:a16="http://schemas.microsoft.com/office/drawing/2014/main" id="{5F7814D6-AEAE-4B12-B1EC-3767C8DB8E88}"/>
+                <a16:creationId xmlns:a16="http://schemas.microsoft.com/office/drawing/2014/main" id="{AAAE3482-D46C-482C-A39E-1114D98922FF}"/>
               </a:ext>
             </a:extLst>
           </p:cNvPr>
@@ -4719,7 +4790,7 @@
           <p:cNvPr id="26" name="">
             <a:extLst xmlns:a="http://schemas.openxmlformats.org/drawingml/2006/main">
               <a:ext uri="{FF2B5EF4-FFF2-40B4-BE49-F238E27FC236}">
-                <a16:creationId xmlns:a16="http://schemas.microsoft.com/office/drawing/2014/main" id="{17BD1FC6-1333-4719-A385-C9972F74D8CA}"/>
+                <a16:creationId xmlns:a16="http://schemas.microsoft.com/office/drawing/2014/main" id="{A303D5EC-751A-44CD-AFC8-BD1B37B36E35}"/>
               </a:ext>
             </a:extLst>
           </p:cNvPr>
@@ -4753,7 +4824,7 @@
           <p:cNvPr id="27" name="">
             <a:extLst xmlns:a="http://schemas.openxmlformats.org/drawingml/2006/main">
               <a:ext uri="{FF2B5EF4-FFF2-40B4-BE49-F238E27FC236}">
-                <a16:creationId xmlns:a16="http://schemas.microsoft.com/office/drawing/2014/main" id="{FBCC18B8-544A-4AFD-BFD0-D2777D832677}"/>
+                <a16:creationId xmlns:a16="http://schemas.microsoft.com/office/drawing/2014/main" id="{8978671C-12F8-4BFF-BFF6-31C35DCA5BE2}"/>
               </a:ext>
             </a:extLst>
           </p:cNvPr>
@@ -4800,7 +4871,7 @@
           <p:cNvPr id="28" name="">
             <a:extLst xmlns:a="http://schemas.openxmlformats.org/drawingml/2006/main">
               <a:ext uri="{FF2B5EF4-FFF2-40B4-BE49-F238E27FC236}">
-                <a16:creationId xmlns:a16="http://schemas.microsoft.com/office/drawing/2014/main" id="{722642FD-16F1-4DBE-90EC-EDDCF2A8D4A1}"/>
+                <a16:creationId xmlns:a16="http://schemas.microsoft.com/office/drawing/2014/main" id="{07307849-BDA5-44F9-B222-297C5AE66663}"/>
               </a:ext>
             </a:extLst>
           </p:cNvPr>
@@ -4860,7 +4931,7 @@
           <p:cNvPr id="29" name="">
             <a:extLst xmlns:a="http://schemas.openxmlformats.org/drawingml/2006/main">
               <a:ext uri="{FF2B5EF4-FFF2-40B4-BE49-F238E27FC236}">
-                <a16:creationId xmlns:a16="http://schemas.microsoft.com/office/drawing/2014/main" id="{4FFDB390-6432-4D38-8508-4BC9188F498E}"/>
+                <a16:creationId xmlns:a16="http://schemas.microsoft.com/office/drawing/2014/main" id="{7607C8F9-153A-449B-B585-61BC868E2DEF}"/>
               </a:ext>
             </a:extLst>
           </p:cNvPr>
@@ -4905,7 +4976,7 @@
     </p:spTree>
     <p:extLst>
       <p:ext uri="{BB962C8B-B14F-4D97-AF65-F5344CB8AC3E}">
-        <p14:creationId xmlns:p14="http://schemas.microsoft.com/office/powerpoint/2010/main" val="1375759587"/>
+        <p14:creationId xmlns:p14="http://schemas.microsoft.com/office/powerpoint/2010/main" val="1401297879"/>
       </p:ext>
     </p:extLst>
   </p:cSld>
@@ -4940,7 +5011,7 @@
           <p:nvPr/>
         </p:nvPicPr>
         <p:blipFill>
-          <a:blip xmlns:r="http://schemas.openxmlformats.org/officeDocument/2006/relationships" xmlns:a="http://schemas.openxmlformats.org/drawingml/2006/main" r:embed="R5685f96ce99847dc"/>
+          <a:blip xmlns:r="http://schemas.openxmlformats.org/officeDocument/2006/relationships" xmlns:a="http://schemas.openxmlformats.org/drawingml/2006/main" r:embed="Ra46d70e7105a4f42"/>
           <a:srcRect xmlns:a="http://schemas.openxmlformats.org/drawingml/2006/main" l="0" t="0" r="0" b="0"/>
           <a:stretch xmlns:a="http://schemas.openxmlformats.org/drawingml/2006/main">
             <a:fillRect l="0" t="0" r="0" b="0"/>
@@ -4961,7 +5032,7 @@
           <p:cNvPr id="2" name="">
             <a:extLst xmlns:a="http://schemas.openxmlformats.org/drawingml/2006/main">
               <a:ext uri="{FF2B5EF4-FFF2-40B4-BE49-F238E27FC236}">
-                <a16:creationId xmlns:a16="http://schemas.microsoft.com/office/drawing/2014/main" id="{727D26AF-C40B-4115-AE80-BD1DE61367E9}"/>
+                <a16:creationId xmlns:a16="http://schemas.microsoft.com/office/drawing/2014/main" id="{49343024-39D3-48C5-A499-6084E0605FD7}"/>
               </a:ext>
             </a:extLst>
           </p:cNvPr>
@@ -5008,7 +5079,7 @@
           <p:cNvPr id="3" name="">
             <a:extLst xmlns:a="http://schemas.openxmlformats.org/drawingml/2006/main">
               <a:ext uri="{FF2B5EF4-FFF2-40B4-BE49-F238E27FC236}">
-                <a16:creationId xmlns:a16="http://schemas.microsoft.com/office/drawing/2014/main" id="{F43D13FD-3A42-4E67-AB31-92A8882E8142}"/>
+                <a16:creationId xmlns:a16="http://schemas.microsoft.com/office/drawing/2014/main" id="{7495D71F-B8F4-4AAB-9E1E-15E94317621C}"/>
               </a:ext>
             </a:extLst>
           </p:cNvPr>
@@ -5068,7 +5139,7 @@
           <p:cNvPr id="4" name="">
             <a:extLst xmlns:a="http://schemas.openxmlformats.org/drawingml/2006/main">
               <a:ext uri="{FF2B5EF4-FFF2-40B4-BE49-F238E27FC236}">
-                <a16:creationId xmlns:a16="http://schemas.microsoft.com/office/drawing/2014/main" id="{19F62702-37E8-4EB3-83DB-93709872494A}"/>
+                <a16:creationId xmlns:a16="http://schemas.microsoft.com/office/drawing/2014/main" id="{26BFEBE8-0044-4580-99E5-B81368C808CD}"/>
               </a:ext>
             </a:extLst>
           </p:cNvPr>
@@ -5115,7 +5186,7 @@
           <p:cNvPr id="5" name="">
             <a:extLst xmlns:a="http://schemas.openxmlformats.org/drawingml/2006/main">
               <a:ext uri="{FF2B5EF4-FFF2-40B4-BE49-F238E27FC236}">
-                <a16:creationId xmlns:a16="http://schemas.microsoft.com/office/drawing/2014/main" id="{621664F5-3AF9-4FDA-BD9F-F08BF3170584}"/>
+                <a16:creationId xmlns:a16="http://schemas.microsoft.com/office/drawing/2014/main" id="{AD02CDBE-FAE2-452E-9AF8-0F7B9C5B794C}"/>
               </a:ext>
             </a:extLst>
           </p:cNvPr>
@@ -5172,7 +5243,7 @@
           <p:cNvPr id="6" name="">
             <a:extLst xmlns:a="http://schemas.openxmlformats.org/drawingml/2006/main">
               <a:ext uri="{FF2B5EF4-FFF2-40B4-BE49-F238E27FC236}">
-                <a16:creationId xmlns:a16="http://schemas.microsoft.com/office/drawing/2014/main" id="{E3B21232-67B0-4D40-9AE5-06A963CC6FD0}"/>
+                <a16:creationId xmlns:a16="http://schemas.microsoft.com/office/drawing/2014/main" id="{744C3FE2-1036-4C11-A2E3-037271410464}"/>
               </a:ext>
             </a:extLst>
           </p:cNvPr>
@@ -5206,7 +5277,7 @@
           <p:cNvPr id="7" name="">
             <a:extLst xmlns:a="http://schemas.openxmlformats.org/drawingml/2006/main">
               <a:ext uri="{FF2B5EF4-FFF2-40B4-BE49-F238E27FC236}">
-                <a16:creationId xmlns:a16="http://schemas.microsoft.com/office/drawing/2014/main" id="{76EC590A-F379-430D-90F6-18DB929029AE}"/>
+                <a16:creationId xmlns:a16="http://schemas.microsoft.com/office/drawing/2014/main" id="{FE15348F-3D9D-40DE-B2C5-BD4EB1DCA7F0}"/>
               </a:ext>
             </a:extLst>
           </p:cNvPr>
@@ -5253,7 +5324,7 @@
           <p:cNvPr id="8" name="">
             <a:extLst xmlns:a="http://schemas.openxmlformats.org/drawingml/2006/main">
               <a:ext uri="{FF2B5EF4-FFF2-40B4-BE49-F238E27FC236}">
-                <a16:creationId xmlns:a16="http://schemas.microsoft.com/office/drawing/2014/main" id="{27AFF37E-00BA-46FE-87AB-946400352265}"/>
+                <a16:creationId xmlns:a16="http://schemas.microsoft.com/office/drawing/2014/main" id="{B14329D1-643B-4897-B7D3-C06908CEF985}"/>
               </a:ext>
             </a:extLst>
           </p:cNvPr>
@@ -5300,7 +5371,7 @@
           <p:cNvPr id="9" name="">
             <a:extLst xmlns:a="http://schemas.openxmlformats.org/drawingml/2006/main">
               <a:ext uri="{FF2B5EF4-FFF2-40B4-BE49-F238E27FC236}">
-                <a16:creationId xmlns:a16="http://schemas.microsoft.com/office/drawing/2014/main" id="{29B66CC9-9514-4323-8D24-218B5547E842}"/>
+                <a16:creationId xmlns:a16="http://schemas.microsoft.com/office/drawing/2014/main" id="{45DD3F18-93E5-4B63-AB86-81C35E051AE7}"/>
               </a:ext>
             </a:extLst>
           </p:cNvPr>
@@ -5347,7 +5418,7 @@
           <p:cNvPr id="10" name="">
             <a:extLst xmlns:a="http://schemas.openxmlformats.org/drawingml/2006/main">
               <a:ext uri="{FF2B5EF4-FFF2-40B4-BE49-F238E27FC236}">
-                <a16:creationId xmlns:a16="http://schemas.microsoft.com/office/drawing/2014/main" id="{234EA946-DA7F-4DD5-9468-C904B0D52A43}"/>
+                <a16:creationId xmlns:a16="http://schemas.microsoft.com/office/drawing/2014/main" id="{2A2E0331-A3E1-4B71-B1F8-53B4C9140379}"/>
               </a:ext>
             </a:extLst>
           </p:cNvPr>
@@ -5394,7 +5465,7 @@
           <p:cNvPr id="11" name="">
             <a:extLst xmlns:a="http://schemas.openxmlformats.org/drawingml/2006/main">
               <a:ext uri="{FF2B5EF4-FFF2-40B4-BE49-F238E27FC236}">
-                <a16:creationId xmlns:a16="http://schemas.microsoft.com/office/drawing/2014/main" id="{3473197D-DA83-4004-B45C-AB2E9AF86C95}"/>
+                <a16:creationId xmlns:a16="http://schemas.microsoft.com/office/drawing/2014/main" id="{9393652F-FD27-454E-8D02-8354FAB7EE41}"/>
               </a:ext>
             </a:extLst>
           </p:cNvPr>
@@ -5441,7 +5512,7 @@
           <p:cNvPr id="12" name="">
             <a:extLst xmlns:a="http://schemas.openxmlformats.org/drawingml/2006/main">
               <a:ext uri="{FF2B5EF4-FFF2-40B4-BE49-F238E27FC236}">
-                <a16:creationId xmlns:a16="http://schemas.microsoft.com/office/drawing/2014/main" id="{BDDF9424-54BC-4883-9975-E81C48C4D6BF}"/>
+                <a16:creationId xmlns:a16="http://schemas.microsoft.com/office/drawing/2014/main" id="{D5E6B229-FCB6-4B3E-AE4A-9FDF35AE0F5E}"/>
               </a:ext>
             </a:extLst>
           </p:cNvPr>
@@ -5471,7 +5542,7 @@
           <p:cNvPr id="13" name="">
             <a:extLst xmlns:a="http://schemas.openxmlformats.org/drawingml/2006/main">
               <a:ext uri="{FF2B5EF4-FFF2-40B4-BE49-F238E27FC236}">
-                <a16:creationId xmlns:a16="http://schemas.microsoft.com/office/drawing/2014/main" id="{8B9FE5A0-0A99-413D-A44F-5F9045E40856}"/>
+                <a16:creationId xmlns:a16="http://schemas.microsoft.com/office/drawing/2014/main" id="{DAFD08D7-05AB-4A4B-9090-76E42A7894B6}"/>
               </a:ext>
             </a:extLst>
           </p:cNvPr>
@@ -5501,7 +5572,7 @@
           <p:cNvPr id="14" name="">
             <a:extLst xmlns:a="http://schemas.openxmlformats.org/drawingml/2006/main">
               <a:ext uri="{FF2B5EF4-FFF2-40B4-BE49-F238E27FC236}">
-                <a16:creationId xmlns:a16="http://schemas.microsoft.com/office/drawing/2014/main" id="{F56407A6-219D-455E-ABE5-5A488B849FD0}"/>
+                <a16:creationId xmlns:a16="http://schemas.microsoft.com/office/drawing/2014/main" id="{2C8BAC71-C1C0-43E9-9D72-74DFFCB88E75}"/>
               </a:ext>
             </a:extLst>
           </p:cNvPr>
@@ -5535,7 +5606,7 @@
           <p:cNvPr id="15" name="">
             <a:extLst xmlns:a="http://schemas.openxmlformats.org/drawingml/2006/main">
               <a:ext uri="{FF2B5EF4-FFF2-40B4-BE49-F238E27FC236}">
-                <a16:creationId xmlns:a16="http://schemas.microsoft.com/office/drawing/2014/main" id="{732E7089-B65F-4701-8249-815A6A3637F2}"/>
+                <a16:creationId xmlns:a16="http://schemas.microsoft.com/office/drawing/2014/main" id="{465D6AF5-DBB4-49DA-840C-2FD3A415BBF6}"/>
               </a:ext>
             </a:extLst>
           </p:cNvPr>
@@ -5582,7 +5653,7 @@
           <p:cNvPr id="16" name="">
             <a:extLst xmlns:a="http://schemas.openxmlformats.org/drawingml/2006/main">
               <a:ext uri="{FF2B5EF4-FFF2-40B4-BE49-F238E27FC236}">
-                <a16:creationId xmlns:a16="http://schemas.microsoft.com/office/drawing/2014/main" id="{4D218BFE-6DEE-492E-9FCB-5E73A710BBC4}"/>
+                <a16:creationId xmlns:a16="http://schemas.microsoft.com/office/drawing/2014/main" id="{61EBFDA2-924F-4690-99A4-3972CEE6FCCB}"/>
               </a:ext>
             </a:extLst>
           </p:cNvPr>
@@ -5629,7 +5700,7 @@
           <p:cNvPr id="17" name="">
             <a:extLst xmlns:a="http://schemas.openxmlformats.org/drawingml/2006/main">
               <a:ext uri="{FF2B5EF4-FFF2-40B4-BE49-F238E27FC236}">
-                <a16:creationId xmlns:a16="http://schemas.microsoft.com/office/drawing/2014/main" id="{1EC5BFE6-850C-4E91-BBC2-0E80AB50EC46}"/>
+                <a16:creationId xmlns:a16="http://schemas.microsoft.com/office/drawing/2014/main" id="{219F9513-4EDF-41B5-AB2F-9FEB9677D322}"/>
               </a:ext>
             </a:extLst>
           </p:cNvPr>
@@ -5702,7 +5773,7 @@
           <p:cNvPr id="18" name="">
             <a:extLst xmlns:a="http://schemas.openxmlformats.org/drawingml/2006/main">
               <a:ext uri="{FF2B5EF4-FFF2-40B4-BE49-F238E27FC236}">
-                <a16:creationId xmlns:a16="http://schemas.microsoft.com/office/drawing/2014/main" id="{514BA200-3A12-465F-8F11-BA47BC781D94}"/>
+                <a16:creationId xmlns:a16="http://schemas.microsoft.com/office/drawing/2014/main" id="{65356181-7918-4C83-86BF-6E297C0B0AB7}"/>
               </a:ext>
             </a:extLst>
           </p:cNvPr>
@@ -5749,7 +5820,7 @@
           <p:cNvPr id="19" name="">
             <a:extLst xmlns:a="http://schemas.openxmlformats.org/drawingml/2006/main">
               <a:ext uri="{FF2B5EF4-FFF2-40B4-BE49-F238E27FC236}">
-                <a16:creationId xmlns:a16="http://schemas.microsoft.com/office/drawing/2014/main" id="{134EC26C-3926-46DB-BC82-2AA18134A4E9}"/>
+                <a16:creationId xmlns:a16="http://schemas.microsoft.com/office/drawing/2014/main" id="{E2C3FCDC-79FB-4992-96C2-47C37B6515AE}"/>
               </a:ext>
             </a:extLst>
           </p:cNvPr>
@@ -5796,7 +5867,7 @@
           <p:cNvPr id="20" name="">
             <a:extLst xmlns:a="http://schemas.openxmlformats.org/drawingml/2006/main">
               <a:ext uri="{FF2B5EF4-FFF2-40B4-BE49-F238E27FC236}">
-                <a16:creationId xmlns:a16="http://schemas.microsoft.com/office/drawing/2014/main" id="{30BE319D-1B71-419C-974D-227461ABAD77}"/>
+                <a16:creationId xmlns:a16="http://schemas.microsoft.com/office/drawing/2014/main" id="{D5C0CE03-175D-4043-9E5E-61F10753F0C3}"/>
               </a:ext>
             </a:extLst>
           </p:cNvPr>
@@ -5843,7 +5914,7 @@
           <p:cNvPr id="21" name="">
             <a:extLst xmlns:a="http://schemas.openxmlformats.org/drawingml/2006/main">
               <a:ext uri="{FF2B5EF4-FFF2-40B4-BE49-F238E27FC236}">
-                <a16:creationId xmlns:a16="http://schemas.microsoft.com/office/drawing/2014/main" id="{CFF33047-7CEF-4D55-9533-B1ADC0FD65C7}"/>
+                <a16:creationId xmlns:a16="http://schemas.microsoft.com/office/drawing/2014/main" id="{76ECCD9E-C01A-4599-99EE-C7438F329469}"/>
               </a:ext>
             </a:extLst>
           </p:cNvPr>
@@ -5875,7 +5946,7 @@
           <p:cNvPr id="22" name="">
             <a:extLst xmlns:a="http://schemas.openxmlformats.org/drawingml/2006/main">
               <a:ext uri="{FF2B5EF4-FFF2-40B4-BE49-F238E27FC236}">
-                <a16:creationId xmlns:a16="http://schemas.microsoft.com/office/drawing/2014/main" id="{3A5F8B02-1D63-4EDA-BD47-A21478050238}"/>
+                <a16:creationId xmlns:a16="http://schemas.microsoft.com/office/drawing/2014/main" id="{0813271D-02FD-4989-AEBE-A36D32B5A748}"/>
               </a:ext>
             </a:extLst>
           </p:cNvPr>
@@ -5920,7 +5991,7 @@
     </p:spTree>
     <p:extLst>
       <p:ext uri="{BB962C8B-B14F-4D97-AF65-F5344CB8AC3E}">
-        <p14:creationId xmlns:p14="http://schemas.microsoft.com/office/powerpoint/2010/main" val="191750982"/>
+        <p14:creationId xmlns:p14="http://schemas.microsoft.com/office/powerpoint/2010/main" val="610982986"/>
       </p:ext>
     </p:extLst>
   </p:cSld>
@@ -5955,7 +6026,7 @@
           <p:nvPr/>
         </p:nvPicPr>
         <p:blipFill>
-          <a:blip xmlns:r="http://schemas.openxmlformats.org/officeDocument/2006/relationships" xmlns:a="http://schemas.openxmlformats.org/drawingml/2006/main" r:embed="R36222a3aec564ee4"/>
+          <a:blip xmlns:r="http://schemas.openxmlformats.org/officeDocument/2006/relationships" xmlns:a="http://schemas.openxmlformats.org/drawingml/2006/main" r:embed="Rccac91a802fb48e9"/>
           <a:srcRect xmlns:a="http://schemas.openxmlformats.org/drawingml/2006/main" l="0" t="0" r="0" b="0"/>
           <a:stretch xmlns:a="http://schemas.openxmlformats.org/drawingml/2006/main">
             <a:fillRect l="0" t="0" r="0" b="0"/>
@@ -5976,7 +6047,7 @@
           <p:cNvPr id="2" name="">
             <a:extLst xmlns:a="http://schemas.openxmlformats.org/drawingml/2006/main">
               <a:ext uri="{FF2B5EF4-FFF2-40B4-BE49-F238E27FC236}">
-                <a16:creationId xmlns:a16="http://schemas.microsoft.com/office/drawing/2014/main" id="{FF82EAB5-A2E8-4DA8-9341-B40EFA283A42}"/>
+                <a16:creationId xmlns:a16="http://schemas.microsoft.com/office/drawing/2014/main" id="{41A0750D-051C-45DF-B1CB-B74DA2F69E27}"/>
               </a:ext>
             </a:extLst>
           </p:cNvPr>
@@ -6023,7 +6094,7 @@
           <p:cNvPr id="3" name="">
             <a:extLst xmlns:a="http://schemas.openxmlformats.org/drawingml/2006/main">
               <a:ext uri="{FF2B5EF4-FFF2-40B4-BE49-F238E27FC236}">
-                <a16:creationId xmlns:a16="http://schemas.microsoft.com/office/drawing/2014/main" id="{BE6CF71D-D3E0-4409-ABAF-8DB9620EB559}"/>
+                <a16:creationId xmlns:a16="http://schemas.microsoft.com/office/drawing/2014/main" id="{99932153-E708-47B4-8876-E775977CA579}"/>
               </a:ext>
             </a:extLst>
           </p:cNvPr>
@@ -6070,7 +6141,7 @@
           <p:cNvPr id="4" name="">
             <a:extLst xmlns:a="http://schemas.openxmlformats.org/drawingml/2006/main">
               <a:ext uri="{FF2B5EF4-FFF2-40B4-BE49-F238E27FC236}">
-                <a16:creationId xmlns:a16="http://schemas.microsoft.com/office/drawing/2014/main" id="{C2FADCA4-75C4-419C-8B27-05B69BF1688C}"/>
+                <a16:creationId xmlns:a16="http://schemas.microsoft.com/office/drawing/2014/main" id="{EEDAE414-5608-43DB-A619-30220C62692F}"/>
               </a:ext>
             </a:extLst>
           </p:cNvPr>
@@ -6117,7 +6188,7 @@
           <p:cNvPr id="5" name="">
             <a:extLst xmlns:a="http://schemas.openxmlformats.org/drawingml/2006/main">
               <a:ext uri="{FF2B5EF4-FFF2-40B4-BE49-F238E27FC236}">
-                <a16:creationId xmlns:a16="http://schemas.microsoft.com/office/drawing/2014/main" id="{A6FA0362-80A9-4F61-B511-F6FD3F5DFAC6}"/>
+                <a16:creationId xmlns:a16="http://schemas.microsoft.com/office/drawing/2014/main" id="{F64D43BE-D619-4222-910F-FDB8B9E86815}"/>
               </a:ext>
             </a:extLst>
           </p:cNvPr>
@@ -6174,7 +6245,7 @@
           <p:cNvPr id="6" name="">
             <a:extLst xmlns:a="http://schemas.openxmlformats.org/drawingml/2006/main">
               <a:ext uri="{FF2B5EF4-FFF2-40B4-BE49-F238E27FC236}">
-                <a16:creationId xmlns:a16="http://schemas.microsoft.com/office/drawing/2014/main" id="{1567E6F4-653E-4CF3-88EB-5358CDF24D12}"/>
+                <a16:creationId xmlns:a16="http://schemas.microsoft.com/office/drawing/2014/main" id="{FE0299CA-6149-4908-9318-8EA43CF8F553}"/>
               </a:ext>
             </a:extLst>
           </p:cNvPr>
@@ -6208,7 +6279,7 @@
           <p:cNvPr id="7" name="">
             <a:extLst xmlns:a="http://schemas.openxmlformats.org/drawingml/2006/main">
               <a:ext uri="{FF2B5EF4-FFF2-40B4-BE49-F238E27FC236}">
-                <a16:creationId xmlns:a16="http://schemas.microsoft.com/office/drawing/2014/main" id="{28C713BF-DA0F-4515-8C3F-9B3D576CCD8B}"/>
+                <a16:creationId xmlns:a16="http://schemas.microsoft.com/office/drawing/2014/main" id="{2FAE1A1C-8D7F-45E2-A90F-CA0CFDAF6B4F}"/>
               </a:ext>
             </a:extLst>
           </p:cNvPr>
@@ -6255,7 +6326,7 @@
           <p:cNvPr id="8" name="">
             <a:extLst xmlns:a="http://schemas.openxmlformats.org/drawingml/2006/main">
               <a:ext uri="{FF2B5EF4-FFF2-40B4-BE49-F238E27FC236}">
-                <a16:creationId xmlns:a16="http://schemas.microsoft.com/office/drawing/2014/main" id="{66BC07AC-254C-456E-9FFF-A1BD4F5CBCC4}"/>
+                <a16:creationId xmlns:a16="http://schemas.microsoft.com/office/drawing/2014/main" id="{41B1B9CB-0466-417E-BEB7-F4152DCB8785}"/>
               </a:ext>
             </a:extLst>
           </p:cNvPr>
@@ -6302,7 +6373,7 @@
           <p:cNvPr id="9" name="">
             <a:extLst xmlns:a="http://schemas.openxmlformats.org/drawingml/2006/main">
               <a:ext uri="{FF2B5EF4-FFF2-40B4-BE49-F238E27FC236}">
-                <a16:creationId xmlns:a16="http://schemas.microsoft.com/office/drawing/2014/main" id="{B6C5CA12-9A2D-4FF3-A9FE-9122E22DA9EC}"/>
+                <a16:creationId xmlns:a16="http://schemas.microsoft.com/office/drawing/2014/main" id="{4EBFEA8E-8920-48CF-9278-7A7243581550}"/>
               </a:ext>
             </a:extLst>
           </p:cNvPr>
@@ -6336,7 +6407,7 @@
           <p:cNvPr id="10" name="">
             <a:extLst xmlns:a="http://schemas.openxmlformats.org/drawingml/2006/main">
               <a:ext uri="{FF2B5EF4-FFF2-40B4-BE49-F238E27FC236}">
-                <a16:creationId xmlns:a16="http://schemas.microsoft.com/office/drawing/2014/main" id="{A9EEEB2B-22F1-423B-AD03-CA716302D9A1}"/>
+                <a16:creationId xmlns:a16="http://schemas.microsoft.com/office/drawing/2014/main" id="{F1D8006D-8CFD-4F24-B95A-FB69B23888DA}"/>
               </a:ext>
             </a:extLst>
           </p:cNvPr>
@@ -6383,7 +6454,7 @@
           <p:cNvPr id="11" name="">
             <a:extLst xmlns:a="http://schemas.openxmlformats.org/drawingml/2006/main">
               <a:ext uri="{FF2B5EF4-FFF2-40B4-BE49-F238E27FC236}">
-                <a16:creationId xmlns:a16="http://schemas.microsoft.com/office/drawing/2014/main" id="{DEAD1696-E4C5-4BCE-BDB6-BD94A1F099A3}"/>
+                <a16:creationId xmlns:a16="http://schemas.microsoft.com/office/drawing/2014/main" id="{DDDC297A-31AD-4873-B4B4-076F41AD239E}"/>
               </a:ext>
             </a:extLst>
           </p:cNvPr>
@@ -6430,7 +6501,7 @@
           <p:cNvPr id="12" name="">
             <a:extLst xmlns:a="http://schemas.openxmlformats.org/drawingml/2006/main">
               <a:ext uri="{FF2B5EF4-FFF2-40B4-BE49-F238E27FC236}">
-                <a16:creationId xmlns:a16="http://schemas.microsoft.com/office/drawing/2014/main" id="{BB32DBD1-6E9D-4B8F-81C3-A9575279058B}"/>
+                <a16:creationId xmlns:a16="http://schemas.microsoft.com/office/drawing/2014/main" id="{E5C749B5-5567-48C0-A434-E2D6B9BD2F96}"/>
               </a:ext>
             </a:extLst>
           </p:cNvPr>
@@ -6477,7 +6548,7 @@
           <p:cNvPr id="13" name="">
             <a:extLst xmlns:a="http://schemas.openxmlformats.org/drawingml/2006/main">
               <a:ext uri="{FF2B5EF4-FFF2-40B4-BE49-F238E27FC236}">
-                <a16:creationId xmlns:a16="http://schemas.microsoft.com/office/drawing/2014/main" id="{92233C20-098D-4D04-B95A-0D15DAAD41DE}"/>
+                <a16:creationId xmlns:a16="http://schemas.microsoft.com/office/drawing/2014/main" id="{6ADFB71F-F8F8-48F8-AA44-7EAF4452CEE7}"/>
               </a:ext>
             </a:extLst>
           </p:cNvPr>
@@ -6511,7 +6582,7 @@
           <p:cNvPr id="14" name="">
             <a:extLst xmlns:a="http://schemas.openxmlformats.org/drawingml/2006/main">
               <a:ext uri="{FF2B5EF4-FFF2-40B4-BE49-F238E27FC236}">
-                <a16:creationId xmlns:a16="http://schemas.microsoft.com/office/drawing/2014/main" id="{5C33FFB3-FB0D-4866-9531-BCF8F13EB61F}"/>
+                <a16:creationId xmlns:a16="http://schemas.microsoft.com/office/drawing/2014/main" id="{F5FBC958-66FD-4889-B37C-8E2CCF9AFBF0}"/>
               </a:ext>
             </a:extLst>
           </p:cNvPr>
@@ -6558,7 +6629,7 @@
           <p:cNvPr id="15" name="">
             <a:extLst xmlns:a="http://schemas.openxmlformats.org/drawingml/2006/main">
               <a:ext uri="{FF2B5EF4-FFF2-40B4-BE49-F238E27FC236}">
-                <a16:creationId xmlns:a16="http://schemas.microsoft.com/office/drawing/2014/main" id="{6F9FA611-4008-4D61-A51E-300A48A0EC20}"/>
+                <a16:creationId xmlns:a16="http://schemas.microsoft.com/office/drawing/2014/main" id="{C11D814E-48A3-4D81-8828-B13417145FC8}"/>
               </a:ext>
             </a:extLst>
           </p:cNvPr>
@@ -6605,7 +6676,7 @@
           <p:cNvPr id="16" name="">
             <a:extLst xmlns:a="http://schemas.openxmlformats.org/drawingml/2006/main">
               <a:ext uri="{FF2B5EF4-FFF2-40B4-BE49-F238E27FC236}">
-                <a16:creationId xmlns:a16="http://schemas.microsoft.com/office/drawing/2014/main" id="{B7A41467-48A1-40B3-94FF-86DF276CCEED}"/>
+                <a16:creationId xmlns:a16="http://schemas.microsoft.com/office/drawing/2014/main" id="{4D981329-4133-495D-BB65-5FF55DB9B025}"/>
               </a:ext>
             </a:extLst>
           </p:cNvPr>
@@ -6652,7 +6723,7 @@
           <p:cNvPr id="17" name="">
             <a:extLst xmlns:a="http://schemas.openxmlformats.org/drawingml/2006/main">
               <a:ext uri="{FF2B5EF4-FFF2-40B4-BE49-F238E27FC236}">
-                <a16:creationId xmlns:a16="http://schemas.microsoft.com/office/drawing/2014/main" id="{07AD0C30-2805-47FF-85A5-C8337B2D20E1}"/>
+                <a16:creationId xmlns:a16="http://schemas.microsoft.com/office/drawing/2014/main" id="{F578FB1B-94D0-45F2-81FF-4EF3DFBFF759}"/>
               </a:ext>
             </a:extLst>
           </p:cNvPr>
@@ -6686,7 +6757,7 @@
           <p:cNvPr id="18" name="">
             <a:extLst xmlns:a="http://schemas.openxmlformats.org/drawingml/2006/main">
               <a:ext uri="{FF2B5EF4-FFF2-40B4-BE49-F238E27FC236}">
-                <a16:creationId xmlns:a16="http://schemas.microsoft.com/office/drawing/2014/main" id="{6CE851E4-7494-49D9-8F83-8592FFCFC4E1}"/>
+                <a16:creationId xmlns:a16="http://schemas.microsoft.com/office/drawing/2014/main" id="{1CB4AA1B-C79B-4EE1-9A5B-19CDAFCA2F1A}"/>
               </a:ext>
             </a:extLst>
           </p:cNvPr>
@@ -6733,7 +6804,7 @@
           <p:cNvPr id="19" name="">
             <a:extLst xmlns:a="http://schemas.openxmlformats.org/drawingml/2006/main">
               <a:ext uri="{FF2B5EF4-FFF2-40B4-BE49-F238E27FC236}">
-                <a16:creationId xmlns:a16="http://schemas.microsoft.com/office/drawing/2014/main" id="{BD3B687A-CB7F-4ECC-BC92-C9B4DA5BD6E9}"/>
+                <a16:creationId xmlns:a16="http://schemas.microsoft.com/office/drawing/2014/main" id="{0D2602BD-0E1D-4BC6-8253-FE3B8094E8D4}"/>
               </a:ext>
             </a:extLst>
           </p:cNvPr>
@@ -6780,7 +6851,7 @@
           <p:cNvPr id="20" name="">
             <a:extLst xmlns:a="http://schemas.openxmlformats.org/drawingml/2006/main">
               <a:ext uri="{FF2B5EF4-FFF2-40B4-BE49-F238E27FC236}">
-                <a16:creationId xmlns:a16="http://schemas.microsoft.com/office/drawing/2014/main" id="{58F3F0E1-5AC1-484C-A520-093D034804F3}"/>
+                <a16:creationId xmlns:a16="http://schemas.microsoft.com/office/drawing/2014/main" id="{2B19ABFD-10DC-47DB-9B7C-A6BD1EBED01A}"/>
               </a:ext>
             </a:extLst>
           </p:cNvPr>
@@ -6827,7 +6898,7 @@
           <p:cNvPr id="21" name="">
             <a:extLst xmlns:a="http://schemas.openxmlformats.org/drawingml/2006/main">
               <a:ext uri="{FF2B5EF4-FFF2-40B4-BE49-F238E27FC236}">
-                <a16:creationId xmlns:a16="http://schemas.microsoft.com/office/drawing/2014/main" id="{F3BBE40A-DF17-45E6-AF06-DEA762BCE80F}"/>
+                <a16:creationId xmlns:a16="http://schemas.microsoft.com/office/drawing/2014/main" id="{B9847A22-9B67-4BC4-ABA1-108C1C097BDE}"/>
               </a:ext>
             </a:extLst>
           </p:cNvPr>
@@ -6861,7 +6932,7 @@
           <p:cNvPr id="22" name="">
             <a:extLst xmlns:a="http://schemas.openxmlformats.org/drawingml/2006/main">
               <a:ext uri="{FF2B5EF4-FFF2-40B4-BE49-F238E27FC236}">
-                <a16:creationId xmlns:a16="http://schemas.microsoft.com/office/drawing/2014/main" id="{2AD241ED-6C4F-4959-94B8-4B995ABC31BA}"/>
+                <a16:creationId xmlns:a16="http://schemas.microsoft.com/office/drawing/2014/main" id="{F0D77265-0C33-4D93-86C2-EE1E6B739F19}"/>
               </a:ext>
             </a:extLst>
           </p:cNvPr>
@@ -6908,7 +6979,7 @@
           <p:cNvPr id="23" name="">
             <a:extLst xmlns:a="http://schemas.openxmlformats.org/drawingml/2006/main">
               <a:ext uri="{FF2B5EF4-FFF2-40B4-BE49-F238E27FC236}">
-                <a16:creationId xmlns:a16="http://schemas.microsoft.com/office/drawing/2014/main" id="{9531EEB3-919D-4F81-B362-0CB2797EB5AD}"/>
+                <a16:creationId xmlns:a16="http://schemas.microsoft.com/office/drawing/2014/main" id="{A0D50540-7503-4E8E-BEDB-8D503171AE6C}"/>
               </a:ext>
             </a:extLst>
           </p:cNvPr>
@@ -6955,7 +7026,7 @@
           <p:cNvPr id="24" name="">
             <a:extLst xmlns:a="http://schemas.openxmlformats.org/drawingml/2006/main">
               <a:ext uri="{FF2B5EF4-FFF2-40B4-BE49-F238E27FC236}">
-                <a16:creationId xmlns:a16="http://schemas.microsoft.com/office/drawing/2014/main" id="{EDB4ED5E-8419-4D18-A5CC-E48F8C8DCE30}"/>
+                <a16:creationId xmlns:a16="http://schemas.microsoft.com/office/drawing/2014/main" id="{5FCA14E9-B847-45C2-AE85-B7C057699765}"/>
               </a:ext>
             </a:extLst>
           </p:cNvPr>
@@ -6989,7 +7060,7 @@
           <p:cNvPr id="25" name="">
             <a:extLst xmlns:a="http://schemas.openxmlformats.org/drawingml/2006/main">
               <a:ext uri="{FF2B5EF4-FFF2-40B4-BE49-F238E27FC236}">
-                <a16:creationId xmlns:a16="http://schemas.microsoft.com/office/drawing/2014/main" id="{C3253482-E516-46DB-ADBD-D6752E5F07E5}"/>
+                <a16:creationId xmlns:a16="http://schemas.microsoft.com/office/drawing/2014/main" id="{4B26ADB7-E8DA-4377-8204-4ED4EDAB3014}"/>
               </a:ext>
             </a:extLst>
           </p:cNvPr>
@@ -7036,7 +7107,7 @@
           <p:cNvPr id="26" name="">
             <a:extLst xmlns:a="http://schemas.openxmlformats.org/drawingml/2006/main">
               <a:ext uri="{FF2B5EF4-FFF2-40B4-BE49-F238E27FC236}">
-                <a16:creationId xmlns:a16="http://schemas.microsoft.com/office/drawing/2014/main" id="{837D3E45-BDBC-42E6-8F29-D524A9DC4EA8}"/>
+                <a16:creationId xmlns:a16="http://schemas.microsoft.com/office/drawing/2014/main" id="{9FC3D0AC-2B28-46AE-BA72-3B990780D110}"/>
               </a:ext>
             </a:extLst>
           </p:cNvPr>
@@ -7083,7 +7154,7 @@
           <p:cNvPr id="27" name="">
             <a:extLst xmlns:a="http://schemas.openxmlformats.org/drawingml/2006/main">
               <a:ext uri="{FF2B5EF4-FFF2-40B4-BE49-F238E27FC236}">
-                <a16:creationId xmlns:a16="http://schemas.microsoft.com/office/drawing/2014/main" id="{ED973380-5495-4897-A391-E8804B23D1C3}"/>
+                <a16:creationId xmlns:a16="http://schemas.microsoft.com/office/drawing/2014/main" id="{8047BCE9-B40B-4078-8F2A-2B35DC07B6A3}"/>
               </a:ext>
             </a:extLst>
           </p:cNvPr>
@@ -7130,7 +7201,7 @@
           <p:cNvPr id="28" name="">
             <a:extLst xmlns:a="http://schemas.openxmlformats.org/drawingml/2006/main">
               <a:ext uri="{FF2B5EF4-FFF2-40B4-BE49-F238E27FC236}">
-                <a16:creationId xmlns:a16="http://schemas.microsoft.com/office/drawing/2014/main" id="{034E3012-BAF1-4572-9DA3-72F2F547BA79}"/>
+                <a16:creationId xmlns:a16="http://schemas.microsoft.com/office/drawing/2014/main" id="{D0412A30-CED7-4272-B293-302602CDA879}"/>
               </a:ext>
             </a:extLst>
           </p:cNvPr>
@@ -7175,7 +7246,7 @@
     </p:spTree>
     <p:extLst>
       <p:ext uri="{BB962C8B-B14F-4D97-AF65-F5344CB8AC3E}">
-        <p14:creationId xmlns:p14="http://schemas.microsoft.com/office/powerpoint/2010/main" val="1190048318"/>
+        <p14:creationId xmlns:p14="http://schemas.microsoft.com/office/powerpoint/2010/main" val="518151377"/>
       </p:ext>
     </p:extLst>
   </p:cSld>
@@ -7210,7 +7281,7 @@
           <p:nvPr/>
         </p:nvPicPr>
         <p:blipFill>
-          <a:blip xmlns:r="http://schemas.openxmlformats.org/officeDocument/2006/relationships" xmlns:a="http://schemas.openxmlformats.org/drawingml/2006/main" r:embed="Rb00e6114d3174c20"/>
+          <a:blip xmlns:r="http://schemas.openxmlformats.org/officeDocument/2006/relationships" xmlns:a="http://schemas.openxmlformats.org/drawingml/2006/main" r:embed="R65b9cc82884e4557"/>
           <a:srcRect xmlns:a="http://schemas.openxmlformats.org/drawingml/2006/main" l="0" t="0" r="0" b="0"/>
           <a:stretch xmlns:a="http://schemas.openxmlformats.org/drawingml/2006/main">
             <a:fillRect l="0" t="0" r="0" b="0"/>
@@ -7231,7 +7302,7 @@
           <p:cNvPr id="2" name="">
             <a:extLst xmlns:a="http://schemas.openxmlformats.org/drawingml/2006/main">
               <a:ext uri="{FF2B5EF4-FFF2-40B4-BE49-F238E27FC236}">
-                <a16:creationId xmlns:a16="http://schemas.microsoft.com/office/drawing/2014/main" id="{96AAF935-9C09-4C8D-AB9B-31E386CB6D77}"/>
+                <a16:creationId xmlns:a16="http://schemas.microsoft.com/office/drawing/2014/main" id="{0159BA41-6F25-4CB0-976D-DD9B7CA52D4B}"/>
               </a:ext>
             </a:extLst>
           </p:cNvPr>
@@ -7278,7 +7349,7 @@
           <p:cNvPr id="3" name="">
             <a:extLst xmlns:a="http://schemas.openxmlformats.org/drawingml/2006/main">
               <a:ext uri="{FF2B5EF4-FFF2-40B4-BE49-F238E27FC236}">
-                <a16:creationId xmlns:a16="http://schemas.microsoft.com/office/drawing/2014/main" id="{7C1E81D5-6232-48F9-8CE3-F1A89D9983E4}"/>
+                <a16:creationId xmlns:a16="http://schemas.microsoft.com/office/drawing/2014/main" id="{E2997099-BB98-43D9-AC22-D99A28851A0A}"/>
               </a:ext>
             </a:extLst>
           </p:cNvPr>
@@ -7338,7 +7409,7 @@
           <p:cNvPr id="4" name="">
             <a:extLst xmlns:a="http://schemas.openxmlformats.org/drawingml/2006/main">
               <a:ext uri="{FF2B5EF4-FFF2-40B4-BE49-F238E27FC236}">
-                <a16:creationId xmlns:a16="http://schemas.microsoft.com/office/drawing/2014/main" id="{6382F162-9168-4773-9C26-ED0442C4CA25}"/>
+                <a16:creationId xmlns:a16="http://schemas.microsoft.com/office/drawing/2014/main" id="{E194AA40-9A12-4897-830A-AD53AB7216E0}"/>
               </a:ext>
             </a:extLst>
           </p:cNvPr>
@@ -7385,7 +7456,7 @@
           <p:cNvPr id="5" name="">
             <a:extLst xmlns:a="http://schemas.openxmlformats.org/drawingml/2006/main">
               <a:ext uri="{FF2B5EF4-FFF2-40B4-BE49-F238E27FC236}">
-                <a16:creationId xmlns:a16="http://schemas.microsoft.com/office/drawing/2014/main" id="{9FB6C5F2-C814-495F-9C68-147CBC2997F7}"/>
+                <a16:creationId xmlns:a16="http://schemas.microsoft.com/office/drawing/2014/main" id="{BE177160-5FB5-48C3-9579-44CDA61D09CE}"/>
               </a:ext>
             </a:extLst>
           </p:cNvPr>
@@ -7442,7 +7513,7 @@
           <p:cNvPr id="6" name="">
             <a:extLst xmlns:a="http://schemas.openxmlformats.org/drawingml/2006/main">
               <a:ext uri="{FF2B5EF4-FFF2-40B4-BE49-F238E27FC236}">
-                <a16:creationId xmlns:a16="http://schemas.microsoft.com/office/drawing/2014/main" id="{771B69B7-C8C2-4D81-8FF6-60A1C2DB0D95}"/>
+                <a16:creationId xmlns:a16="http://schemas.microsoft.com/office/drawing/2014/main" id="{4977CDD4-2841-4A5D-94D2-1BE5B633D026}"/>
               </a:ext>
             </a:extLst>
           </p:cNvPr>
@@ -7476,7 +7547,7 @@
           <p:cNvPr id="7" name="">
             <a:extLst xmlns:a="http://schemas.openxmlformats.org/drawingml/2006/main">
               <a:ext uri="{FF2B5EF4-FFF2-40B4-BE49-F238E27FC236}">
-                <a16:creationId xmlns:a16="http://schemas.microsoft.com/office/drawing/2014/main" id="{A618F657-38B9-481E-9889-968D84E7E496}"/>
+                <a16:creationId xmlns:a16="http://schemas.microsoft.com/office/drawing/2014/main" id="{E0089813-F988-4921-9C31-8A193CE320D8}"/>
               </a:ext>
             </a:extLst>
           </p:cNvPr>
@@ -7523,7 +7594,7 @@
           <p:cNvPr id="8" name="">
             <a:extLst xmlns:a="http://schemas.openxmlformats.org/drawingml/2006/main">
               <a:ext uri="{FF2B5EF4-FFF2-40B4-BE49-F238E27FC236}">
-                <a16:creationId xmlns:a16="http://schemas.microsoft.com/office/drawing/2014/main" id="{65BB05DC-FD4C-4561-B19F-B9ACEC5C501D}"/>
+                <a16:creationId xmlns:a16="http://schemas.microsoft.com/office/drawing/2014/main" id="{5A533106-37D2-4470-A1DA-A22F85721F3E}"/>
               </a:ext>
             </a:extLst>
           </p:cNvPr>
@@ -7596,7 +7667,7 @@
           <p:cNvPr id="9" name="">
             <a:extLst xmlns:a="http://schemas.openxmlformats.org/drawingml/2006/main">
               <a:ext uri="{FF2B5EF4-FFF2-40B4-BE49-F238E27FC236}">
-                <a16:creationId xmlns:a16="http://schemas.microsoft.com/office/drawing/2014/main" id="{3D32FF3E-566D-4D19-AE7F-5D205D43721D}"/>
+                <a16:creationId xmlns:a16="http://schemas.microsoft.com/office/drawing/2014/main" id="{7EC35681-CF44-44F6-8E53-ED203AAE1C41}"/>
               </a:ext>
             </a:extLst>
           </p:cNvPr>
@@ -7626,7 +7697,7 @@
           <p:cNvPr id="10" name="">
             <a:extLst xmlns:a="http://schemas.openxmlformats.org/drawingml/2006/main">
               <a:ext uri="{FF2B5EF4-FFF2-40B4-BE49-F238E27FC236}">
-                <a16:creationId xmlns:a16="http://schemas.microsoft.com/office/drawing/2014/main" id="{774A8A88-C92D-4B66-A9CE-19D58F3FEE9A}"/>
+                <a16:creationId xmlns:a16="http://schemas.microsoft.com/office/drawing/2014/main" id="{E6829A01-5106-455C-918E-AFB750AA58BD}"/>
               </a:ext>
             </a:extLst>
           </p:cNvPr>
@@ -7656,7 +7727,7 @@
           <p:cNvPr id="11" name="">
             <a:extLst xmlns:a="http://schemas.openxmlformats.org/drawingml/2006/main">
               <a:ext uri="{FF2B5EF4-FFF2-40B4-BE49-F238E27FC236}">
-                <a16:creationId xmlns:a16="http://schemas.microsoft.com/office/drawing/2014/main" id="{CAC9D20D-4A4C-47AB-BEA7-346A074EF23F}"/>
+                <a16:creationId xmlns:a16="http://schemas.microsoft.com/office/drawing/2014/main" id="{811C7097-66E6-4A1D-B044-507EDC19A274}"/>
               </a:ext>
             </a:extLst>
           </p:cNvPr>
@@ -7690,7 +7761,7 @@
           <p:cNvPr id="12" name="">
             <a:extLst xmlns:a="http://schemas.openxmlformats.org/drawingml/2006/main">
               <a:ext uri="{FF2B5EF4-FFF2-40B4-BE49-F238E27FC236}">
-                <a16:creationId xmlns:a16="http://schemas.microsoft.com/office/drawing/2014/main" id="{8288D67B-9C96-4DB6-AF52-F48C9C86A2FD}"/>
+                <a16:creationId xmlns:a16="http://schemas.microsoft.com/office/drawing/2014/main" id="{91A176EB-B93F-44BE-A596-F519DF9C3A54}"/>
               </a:ext>
             </a:extLst>
           </p:cNvPr>
@@ -7737,7 +7808,7 @@
           <p:cNvPr id="13" name="">
             <a:extLst xmlns:a="http://schemas.openxmlformats.org/drawingml/2006/main">
               <a:ext uri="{FF2B5EF4-FFF2-40B4-BE49-F238E27FC236}">
-                <a16:creationId xmlns:a16="http://schemas.microsoft.com/office/drawing/2014/main" id="{6E74F71B-E202-46BF-B034-F4708A3B94F7}"/>
+                <a16:creationId xmlns:a16="http://schemas.microsoft.com/office/drawing/2014/main" id="{484A4F28-FC25-4CDC-9859-892C8184E4DD}"/>
               </a:ext>
             </a:extLst>
           </p:cNvPr>
@@ -7810,7 +7881,7 @@
           <p:cNvPr id="14" name="">
             <a:extLst xmlns:a="http://schemas.openxmlformats.org/drawingml/2006/main">
               <a:ext uri="{FF2B5EF4-FFF2-40B4-BE49-F238E27FC236}">
-                <a16:creationId xmlns:a16="http://schemas.microsoft.com/office/drawing/2014/main" id="{4DCFE65E-0907-4194-8035-30240D609757}"/>
+                <a16:creationId xmlns:a16="http://schemas.microsoft.com/office/drawing/2014/main" id="{F0334FBF-CA2C-4113-9DA7-A67968FC7F77}"/>
               </a:ext>
             </a:extLst>
           </p:cNvPr>
@@ -7840,7 +7911,7 @@
           <p:cNvPr id="15" name="">
             <a:extLst xmlns:a="http://schemas.openxmlformats.org/drawingml/2006/main">
               <a:ext uri="{FF2B5EF4-FFF2-40B4-BE49-F238E27FC236}">
-                <a16:creationId xmlns:a16="http://schemas.microsoft.com/office/drawing/2014/main" id="{B27E8FDC-E9B9-46C0-9694-0668C4F1994A}"/>
+                <a16:creationId xmlns:a16="http://schemas.microsoft.com/office/drawing/2014/main" id="{EA6DD7CB-ECB3-4AEB-ADCC-E90B5CB51857}"/>
               </a:ext>
             </a:extLst>
           </p:cNvPr>
@@ -7870,7 +7941,7 @@
           <p:cNvPr id="16" name="">
             <a:extLst xmlns:a="http://schemas.openxmlformats.org/drawingml/2006/main">
               <a:ext uri="{FF2B5EF4-FFF2-40B4-BE49-F238E27FC236}">
-                <a16:creationId xmlns:a16="http://schemas.microsoft.com/office/drawing/2014/main" id="{DEC91BC7-E18C-4D75-A2DE-096DB4B3FCC6}"/>
+                <a16:creationId xmlns:a16="http://schemas.microsoft.com/office/drawing/2014/main" id="{5C784AC0-4874-4B7F-89B6-0236D618C65A}"/>
               </a:ext>
             </a:extLst>
           </p:cNvPr>
@@ -7904,7 +7975,7 @@
           <p:cNvPr id="17" name="">
             <a:extLst xmlns:a="http://schemas.openxmlformats.org/drawingml/2006/main">
               <a:ext uri="{FF2B5EF4-FFF2-40B4-BE49-F238E27FC236}">
-                <a16:creationId xmlns:a16="http://schemas.microsoft.com/office/drawing/2014/main" id="{ADD90DEF-15DB-4BD0-BA3B-60C1ADB0C07D}"/>
+                <a16:creationId xmlns:a16="http://schemas.microsoft.com/office/drawing/2014/main" id="{2FEE6BA6-D224-45CD-AC3A-C9AA46D9ABA9}"/>
               </a:ext>
             </a:extLst>
           </p:cNvPr>
@@ -7951,7 +8022,7 @@
           <p:cNvPr id="18" name="">
             <a:extLst xmlns:a="http://schemas.openxmlformats.org/drawingml/2006/main">
               <a:ext uri="{FF2B5EF4-FFF2-40B4-BE49-F238E27FC236}">
-                <a16:creationId xmlns:a16="http://schemas.microsoft.com/office/drawing/2014/main" id="{D4E3262E-7D46-4D50-9147-462DD7CDC558}"/>
+                <a16:creationId xmlns:a16="http://schemas.microsoft.com/office/drawing/2014/main" id="{6E69E722-AE8A-47E1-BC03-F83664B3E4DD}"/>
               </a:ext>
             </a:extLst>
           </p:cNvPr>
@@ -8024,7 +8095,7 @@
           <p:cNvPr id="19" name="">
             <a:extLst xmlns:a="http://schemas.openxmlformats.org/drawingml/2006/main">
               <a:ext uri="{FF2B5EF4-FFF2-40B4-BE49-F238E27FC236}">
-                <a16:creationId xmlns:a16="http://schemas.microsoft.com/office/drawing/2014/main" id="{A752E7C8-CCF2-4A9A-BC59-D9E8C149EAA9}"/>
+                <a16:creationId xmlns:a16="http://schemas.microsoft.com/office/drawing/2014/main" id="{A8D3B64E-5445-4DC7-93CE-0FD3B69A37E0}"/>
               </a:ext>
             </a:extLst>
           </p:cNvPr>
@@ -8054,7 +8125,7 @@
           <p:cNvPr id="20" name="">
             <a:extLst xmlns:a="http://schemas.openxmlformats.org/drawingml/2006/main">
               <a:ext uri="{FF2B5EF4-FFF2-40B4-BE49-F238E27FC236}">
-                <a16:creationId xmlns:a16="http://schemas.microsoft.com/office/drawing/2014/main" id="{AF3D1E59-C6AB-4A3F-A93A-6B89C6293CAE}"/>
+                <a16:creationId xmlns:a16="http://schemas.microsoft.com/office/drawing/2014/main" id="{80988089-101F-4B1E-A39F-FD28B22CCD6E}"/>
               </a:ext>
             </a:extLst>
           </p:cNvPr>
@@ -8084,7 +8155,7 @@
           <p:cNvPr id="21" name="">
             <a:extLst xmlns:a="http://schemas.openxmlformats.org/drawingml/2006/main">
               <a:ext uri="{FF2B5EF4-FFF2-40B4-BE49-F238E27FC236}">
-                <a16:creationId xmlns:a16="http://schemas.microsoft.com/office/drawing/2014/main" id="{A61D269C-48C1-48B6-8EAC-A25149842AAE}"/>
+                <a16:creationId xmlns:a16="http://schemas.microsoft.com/office/drawing/2014/main" id="{B0545BBA-6A2E-443F-8CC9-D8BBB562FFF1}"/>
               </a:ext>
             </a:extLst>
           </p:cNvPr>
@@ -8118,7 +8189,7 @@
           <p:cNvPr id="22" name="">
             <a:extLst xmlns:a="http://schemas.openxmlformats.org/drawingml/2006/main">
               <a:ext uri="{FF2B5EF4-FFF2-40B4-BE49-F238E27FC236}">
-                <a16:creationId xmlns:a16="http://schemas.microsoft.com/office/drawing/2014/main" id="{2A6F7FDE-6C9A-4AA3-B389-D1ADDB2D77CF}"/>
+                <a16:creationId xmlns:a16="http://schemas.microsoft.com/office/drawing/2014/main" id="{DF96544F-10A8-45ED-A248-0A8523F975B8}"/>
               </a:ext>
             </a:extLst>
           </p:cNvPr>
@@ -8165,7 +8236,7 @@
           <p:cNvPr id="23" name="">
             <a:extLst xmlns:a="http://schemas.openxmlformats.org/drawingml/2006/main">
               <a:ext uri="{FF2B5EF4-FFF2-40B4-BE49-F238E27FC236}">
-                <a16:creationId xmlns:a16="http://schemas.microsoft.com/office/drawing/2014/main" id="{F129D3F2-9309-4B23-B1F3-E28B7A927096}"/>
+                <a16:creationId xmlns:a16="http://schemas.microsoft.com/office/drawing/2014/main" id="{088281EC-3A9E-4A31-AD19-A3F995993CC2}"/>
               </a:ext>
             </a:extLst>
           </p:cNvPr>
@@ -8238,7 +8309,7 @@
           <p:cNvPr id="24" name="">
             <a:extLst xmlns:a="http://schemas.openxmlformats.org/drawingml/2006/main">
               <a:ext uri="{FF2B5EF4-FFF2-40B4-BE49-F238E27FC236}">
-                <a16:creationId xmlns:a16="http://schemas.microsoft.com/office/drawing/2014/main" id="{DD67A836-CB74-4966-A7ED-B4C96B8D83C5}"/>
+                <a16:creationId xmlns:a16="http://schemas.microsoft.com/office/drawing/2014/main" id="{F9A5E4E7-31DF-4BAF-BCB4-90A1A3A91798}"/>
               </a:ext>
             </a:extLst>
           </p:cNvPr>
@@ -8272,7 +8343,7 @@
           <p:cNvPr id="25" name="">
             <a:extLst xmlns:a="http://schemas.openxmlformats.org/drawingml/2006/main">
               <a:ext uri="{FF2B5EF4-FFF2-40B4-BE49-F238E27FC236}">
-                <a16:creationId xmlns:a16="http://schemas.microsoft.com/office/drawing/2014/main" id="{991E8C57-7B39-4D85-AE2C-B4B39C7DD635}"/>
+                <a16:creationId xmlns:a16="http://schemas.microsoft.com/office/drawing/2014/main" id="{EBA14001-06E3-4799-AE78-4B4CCF8BE01E}"/>
               </a:ext>
             </a:extLst>
           </p:cNvPr>
@@ -8319,7 +8390,7 @@
           <p:cNvPr id="26" name="">
             <a:extLst xmlns:a="http://schemas.openxmlformats.org/drawingml/2006/main">
               <a:ext uri="{FF2B5EF4-FFF2-40B4-BE49-F238E27FC236}">
-                <a16:creationId xmlns:a16="http://schemas.microsoft.com/office/drawing/2014/main" id="{08450D1C-90D2-433C-AD68-D0F65AF2B0DC}"/>
+                <a16:creationId xmlns:a16="http://schemas.microsoft.com/office/drawing/2014/main" id="{12DE3D1C-D498-41FE-82C8-22A2499EA8CB}"/>
               </a:ext>
             </a:extLst>
           </p:cNvPr>
@@ -8351,7 +8422,7 @@
           <p:cNvPr id="27" name="">
             <a:extLst xmlns:a="http://schemas.openxmlformats.org/drawingml/2006/main">
               <a:ext uri="{FF2B5EF4-FFF2-40B4-BE49-F238E27FC236}">
-                <a16:creationId xmlns:a16="http://schemas.microsoft.com/office/drawing/2014/main" id="{C34E554F-BE29-4C18-A16B-026F74DE096F}"/>
+                <a16:creationId xmlns:a16="http://schemas.microsoft.com/office/drawing/2014/main" id="{0C9CB5AA-5878-42A5-B80C-9260B7A8B070}"/>
               </a:ext>
             </a:extLst>
           </p:cNvPr>
@@ -8398,7 +8469,7 @@
           <p:cNvPr id="28" name="">
             <a:extLst xmlns:a="http://schemas.openxmlformats.org/drawingml/2006/main">
               <a:ext uri="{FF2B5EF4-FFF2-40B4-BE49-F238E27FC236}">
-                <a16:creationId xmlns:a16="http://schemas.microsoft.com/office/drawing/2014/main" id="{5E1BEA9E-D5FB-4EF1-84DD-60640C960848}"/>
+                <a16:creationId xmlns:a16="http://schemas.microsoft.com/office/drawing/2014/main" id="{D1EC0990-E385-44DA-B2E7-634F4933DA2A}"/>
               </a:ext>
             </a:extLst>
           </p:cNvPr>
@@ -8443,7 +8514,7 @@
     </p:spTree>
     <p:extLst>
       <p:ext uri="{BB962C8B-B14F-4D97-AF65-F5344CB8AC3E}">
-        <p14:creationId xmlns:p14="http://schemas.microsoft.com/office/powerpoint/2010/main" val="600463836"/>
+        <p14:creationId xmlns:p14="http://schemas.microsoft.com/office/powerpoint/2010/main" val="1863406762"/>
       </p:ext>
     </p:extLst>
   </p:cSld>
@@ -8478,7 +8549,7 @@
           <p:nvPr/>
         </p:nvPicPr>
         <p:blipFill>
-          <a:blip xmlns:r="http://schemas.openxmlformats.org/officeDocument/2006/relationships" xmlns:a="http://schemas.openxmlformats.org/drawingml/2006/main" r:embed="R12fd535eb42b484b"/>
+          <a:blip xmlns:r="http://schemas.openxmlformats.org/officeDocument/2006/relationships" xmlns:a="http://schemas.openxmlformats.org/drawingml/2006/main" r:embed="R1d6c33b6b6874d77"/>
           <a:srcRect xmlns:a="http://schemas.openxmlformats.org/drawingml/2006/main" l="0" t="0" r="0" b="0"/>
           <a:stretch xmlns:a="http://schemas.openxmlformats.org/drawingml/2006/main">
             <a:fillRect l="0" t="0" r="0" b="0"/>
@@ -8499,7 +8570,7 @@
           <p:cNvPr id="2" name="">
             <a:extLst xmlns:a="http://schemas.openxmlformats.org/drawingml/2006/main">
               <a:ext uri="{FF2B5EF4-FFF2-40B4-BE49-F238E27FC236}">
-                <a16:creationId xmlns:a16="http://schemas.microsoft.com/office/drawing/2014/main" id="{CB1F4748-0BC5-457D-B408-949A6D614AFE}"/>
+                <a16:creationId xmlns:a16="http://schemas.microsoft.com/office/drawing/2014/main" id="{F075F4CB-8618-4B73-A8A6-E74F71761718}"/>
               </a:ext>
             </a:extLst>
           </p:cNvPr>
@@ -8546,7 +8617,7 @@
           <p:cNvPr id="3" name="">
             <a:extLst xmlns:a="http://schemas.openxmlformats.org/drawingml/2006/main">
               <a:ext uri="{FF2B5EF4-FFF2-40B4-BE49-F238E27FC236}">
-                <a16:creationId xmlns:a16="http://schemas.microsoft.com/office/drawing/2014/main" id="{6C523A4A-4FC1-44F0-A6E8-894F1667E9A9}"/>
+                <a16:creationId xmlns:a16="http://schemas.microsoft.com/office/drawing/2014/main" id="{7E10F14B-D139-4033-8FD3-7951CD4B7FDA}"/>
               </a:ext>
             </a:extLst>
           </p:cNvPr>
@@ -8606,7 +8677,7 @@
           <p:cNvPr id="4" name="">
             <a:extLst xmlns:a="http://schemas.openxmlformats.org/drawingml/2006/main">
               <a:ext uri="{FF2B5EF4-FFF2-40B4-BE49-F238E27FC236}">
-                <a16:creationId xmlns:a16="http://schemas.microsoft.com/office/drawing/2014/main" id="{0B55B1FF-370E-4990-9136-812ED5D82300}"/>
+                <a16:creationId xmlns:a16="http://schemas.microsoft.com/office/drawing/2014/main" id="{5531BDC1-6C15-4540-A013-2470E5C2208E}"/>
               </a:ext>
             </a:extLst>
           </p:cNvPr>
@@ -8653,7 +8724,7 @@
           <p:cNvPr id="5" name="">
             <a:extLst xmlns:a="http://schemas.openxmlformats.org/drawingml/2006/main">
               <a:ext uri="{FF2B5EF4-FFF2-40B4-BE49-F238E27FC236}">
-                <a16:creationId xmlns:a16="http://schemas.microsoft.com/office/drawing/2014/main" id="{04618A75-2047-409A-8661-0EC5C646677A}"/>
+                <a16:creationId xmlns:a16="http://schemas.microsoft.com/office/drawing/2014/main" id="{9DF22DF8-C0A5-4C1C-8D26-77FA7840E902}"/>
               </a:ext>
             </a:extLst>
           </p:cNvPr>
@@ -8710,7 +8781,7 @@
           <p:cNvPr id="6" name="">
             <a:extLst xmlns:a="http://schemas.openxmlformats.org/drawingml/2006/main">
               <a:ext uri="{FF2B5EF4-FFF2-40B4-BE49-F238E27FC236}">
-                <a16:creationId xmlns:a16="http://schemas.microsoft.com/office/drawing/2014/main" id="{8445C2C3-D98B-43D1-A91C-5B39C6D60323}"/>
+                <a16:creationId xmlns:a16="http://schemas.microsoft.com/office/drawing/2014/main" id="{934BFBFA-A66F-4D91-91A9-8F31F84FB505}"/>
               </a:ext>
             </a:extLst>
           </p:cNvPr>
@@ -8744,7 +8815,7 @@
           <p:cNvPr id="7" name="">
             <a:extLst xmlns:a="http://schemas.openxmlformats.org/drawingml/2006/main">
               <a:ext uri="{FF2B5EF4-FFF2-40B4-BE49-F238E27FC236}">
-                <a16:creationId xmlns:a16="http://schemas.microsoft.com/office/drawing/2014/main" id="{E90D2AAD-983C-4C07-A0A8-41D2BFADE0F0}"/>
+                <a16:creationId xmlns:a16="http://schemas.microsoft.com/office/drawing/2014/main" id="{8C4A70C6-8BD3-4E89-85C4-8848C4117257}"/>
               </a:ext>
             </a:extLst>
           </p:cNvPr>
@@ -8791,7 +8862,7 @@
           <p:cNvPr id="8" name="">
             <a:extLst xmlns:a="http://schemas.openxmlformats.org/drawingml/2006/main">
               <a:ext uri="{FF2B5EF4-FFF2-40B4-BE49-F238E27FC236}">
-                <a16:creationId xmlns:a16="http://schemas.microsoft.com/office/drawing/2014/main" id="{EE8B45F5-205B-44D9-89A0-22F286B5BABB}"/>
+                <a16:creationId xmlns:a16="http://schemas.microsoft.com/office/drawing/2014/main" id="{6D92D3CC-5E10-46BF-A316-98FBB1DE8766}"/>
               </a:ext>
             </a:extLst>
           </p:cNvPr>
@@ -8838,7 +8909,7 @@
           <p:cNvPr id="9" name="">
             <a:extLst xmlns:a="http://schemas.openxmlformats.org/drawingml/2006/main">
               <a:ext uri="{FF2B5EF4-FFF2-40B4-BE49-F238E27FC236}">
-                <a16:creationId xmlns:a16="http://schemas.microsoft.com/office/drawing/2014/main" id="{DD97560D-ADFC-495C-9CEF-63108A66AA76}"/>
+                <a16:creationId xmlns:a16="http://schemas.microsoft.com/office/drawing/2014/main" id="{F9598C28-7B16-4583-8238-FC41F1EDC4A3}"/>
               </a:ext>
             </a:extLst>
           </p:cNvPr>
@@ -8872,7 +8943,7 @@
           <p:cNvPr id="10" name="">
             <a:extLst xmlns:a="http://schemas.openxmlformats.org/drawingml/2006/main">
               <a:ext uri="{FF2B5EF4-FFF2-40B4-BE49-F238E27FC236}">
-                <a16:creationId xmlns:a16="http://schemas.microsoft.com/office/drawing/2014/main" id="{C60EAAE5-7199-4073-BA9C-659AD235A982}"/>
+                <a16:creationId xmlns:a16="http://schemas.microsoft.com/office/drawing/2014/main" id="{A0122FD0-040D-49CD-8691-784ADD260FFB}"/>
               </a:ext>
             </a:extLst>
           </p:cNvPr>
@@ -8919,7 +8990,7 @@
           <p:cNvPr id="11" name="">
             <a:extLst xmlns:a="http://schemas.openxmlformats.org/drawingml/2006/main">
               <a:ext uri="{FF2B5EF4-FFF2-40B4-BE49-F238E27FC236}">
-                <a16:creationId xmlns:a16="http://schemas.microsoft.com/office/drawing/2014/main" id="{19F8F2B0-C578-48CB-A552-D126A0D7CD6A}"/>
+                <a16:creationId xmlns:a16="http://schemas.microsoft.com/office/drawing/2014/main" id="{0D54949F-1F08-425A-8877-4653255AFFC2}"/>
               </a:ext>
             </a:extLst>
           </p:cNvPr>
@@ -8966,7 +9037,7 @@
           <p:cNvPr id="12" name="">
             <a:extLst xmlns:a="http://schemas.openxmlformats.org/drawingml/2006/main">
               <a:ext uri="{FF2B5EF4-FFF2-40B4-BE49-F238E27FC236}">
-                <a16:creationId xmlns:a16="http://schemas.microsoft.com/office/drawing/2014/main" id="{74A3CAE7-27A4-4777-809A-66011EA27178}"/>
+                <a16:creationId xmlns:a16="http://schemas.microsoft.com/office/drawing/2014/main" id="{A473CDB7-F9CC-4011-A05C-7A0CEF66A454}"/>
               </a:ext>
             </a:extLst>
           </p:cNvPr>
@@ -9000,7 +9071,7 @@
           <p:cNvPr id="13" name="">
             <a:extLst xmlns:a="http://schemas.openxmlformats.org/drawingml/2006/main">
               <a:ext uri="{FF2B5EF4-FFF2-40B4-BE49-F238E27FC236}">
-                <a16:creationId xmlns:a16="http://schemas.microsoft.com/office/drawing/2014/main" id="{61B0AB8C-15FE-41D0-9263-1DABE349472B}"/>
+                <a16:creationId xmlns:a16="http://schemas.microsoft.com/office/drawing/2014/main" id="{144205B4-3D0C-4917-9E8B-C35105CF9211}"/>
               </a:ext>
             </a:extLst>
           </p:cNvPr>
@@ -9047,7 +9118,7 @@
           <p:cNvPr id="14" name="">
             <a:extLst xmlns:a="http://schemas.openxmlformats.org/drawingml/2006/main">
               <a:ext uri="{FF2B5EF4-FFF2-40B4-BE49-F238E27FC236}">
-                <a16:creationId xmlns:a16="http://schemas.microsoft.com/office/drawing/2014/main" id="{EC5B0689-597E-4B8A-9273-61006849CDFB}"/>
+                <a16:creationId xmlns:a16="http://schemas.microsoft.com/office/drawing/2014/main" id="{C1545396-BED5-474E-B0DE-208F06DF3A7A}"/>
               </a:ext>
             </a:extLst>
           </p:cNvPr>
@@ -9094,7 +9165,7 @@
           <p:cNvPr id="15" name="">
             <a:extLst xmlns:a="http://schemas.openxmlformats.org/drawingml/2006/main">
               <a:ext uri="{FF2B5EF4-FFF2-40B4-BE49-F238E27FC236}">
-                <a16:creationId xmlns:a16="http://schemas.microsoft.com/office/drawing/2014/main" id="{7763C3F5-DC81-4A23-95C0-1638B80F017A}"/>
+                <a16:creationId xmlns:a16="http://schemas.microsoft.com/office/drawing/2014/main" id="{B3026721-5FB0-46A2-BA0E-36DB7A336552}"/>
               </a:ext>
             </a:extLst>
           </p:cNvPr>
@@ -9128,7 +9199,7 @@
           <p:cNvPr id="16" name="">
             <a:extLst xmlns:a="http://schemas.openxmlformats.org/drawingml/2006/main">
               <a:ext uri="{FF2B5EF4-FFF2-40B4-BE49-F238E27FC236}">
-                <a16:creationId xmlns:a16="http://schemas.microsoft.com/office/drawing/2014/main" id="{6683D1BF-C67A-4CFA-B732-F0F71BE8EF30}"/>
+                <a16:creationId xmlns:a16="http://schemas.microsoft.com/office/drawing/2014/main" id="{BF762D9B-6505-4797-82E7-E0E64EE4B07D}"/>
               </a:ext>
             </a:extLst>
           </p:cNvPr>
@@ -9175,7 +9246,7 @@
           <p:cNvPr id="17" name="">
             <a:extLst xmlns:a="http://schemas.openxmlformats.org/drawingml/2006/main">
               <a:ext uri="{FF2B5EF4-FFF2-40B4-BE49-F238E27FC236}">
-                <a16:creationId xmlns:a16="http://schemas.microsoft.com/office/drawing/2014/main" id="{089D3B8C-E426-472E-9712-E4B37303152D}"/>
+                <a16:creationId xmlns:a16="http://schemas.microsoft.com/office/drawing/2014/main" id="{FAE62876-79A1-40D9-AA02-A833E03606C6}"/>
               </a:ext>
             </a:extLst>
           </p:cNvPr>
@@ -9222,7 +9293,7 @@
           <p:cNvPr id="18" name="">
             <a:extLst xmlns:a="http://schemas.openxmlformats.org/drawingml/2006/main">
               <a:ext uri="{FF2B5EF4-FFF2-40B4-BE49-F238E27FC236}">
-                <a16:creationId xmlns:a16="http://schemas.microsoft.com/office/drawing/2014/main" id="{527AB77B-BD01-429B-BB17-22001B8F69DC}"/>
+                <a16:creationId xmlns:a16="http://schemas.microsoft.com/office/drawing/2014/main" id="{D0EF4329-DEE8-4F3F-9FD6-BDFD6D6D632F}"/>
               </a:ext>
             </a:extLst>
           </p:cNvPr>
@@ -9254,7 +9325,7 @@
           <p:cNvPr id="19" name="">
             <a:extLst xmlns:a="http://schemas.openxmlformats.org/drawingml/2006/main">
               <a:ext uri="{FF2B5EF4-FFF2-40B4-BE49-F238E27FC236}">
-                <a16:creationId xmlns:a16="http://schemas.microsoft.com/office/drawing/2014/main" id="{35114D75-5D65-472C-8333-B152B17BBF58}"/>
+                <a16:creationId xmlns:a16="http://schemas.microsoft.com/office/drawing/2014/main" id="{AC8C6CC7-1590-4EA1-AFB7-91E24820342E}"/>
               </a:ext>
             </a:extLst>
           </p:cNvPr>
@@ -9301,7 +9372,7 @@
           <p:cNvPr id="20" name="">
             <a:extLst xmlns:a="http://schemas.openxmlformats.org/drawingml/2006/main">
               <a:ext uri="{FF2B5EF4-FFF2-40B4-BE49-F238E27FC236}">
-                <a16:creationId xmlns:a16="http://schemas.microsoft.com/office/drawing/2014/main" id="{C7B92C3B-5812-4D10-AD54-F6EEF30B879B}"/>
+                <a16:creationId xmlns:a16="http://schemas.microsoft.com/office/drawing/2014/main" id="{B435339D-C860-4E3E-BE83-71DEFCD71F80}"/>
               </a:ext>
             </a:extLst>
           </p:cNvPr>
@@ -9346,7 +9417,7 @@
     </p:spTree>
     <p:extLst>
       <p:ext uri="{BB962C8B-B14F-4D97-AF65-F5344CB8AC3E}">
-        <p14:creationId xmlns:p14="http://schemas.microsoft.com/office/powerpoint/2010/main" val="1265292124"/>
+        <p14:creationId xmlns:p14="http://schemas.microsoft.com/office/powerpoint/2010/main" val="2137224476"/>
       </p:ext>
     </p:extLst>
   </p:cSld>
@@ -9381,7 +9452,7 @@
           <p:nvPr/>
         </p:nvPicPr>
         <p:blipFill>
-          <a:blip xmlns:r="http://schemas.openxmlformats.org/officeDocument/2006/relationships" xmlns:a="http://schemas.openxmlformats.org/drawingml/2006/main" r:embed="Rdaced7f1dbb848ce"/>
+          <a:blip xmlns:r="http://schemas.openxmlformats.org/officeDocument/2006/relationships" xmlns:a="http://schemas.openxmlformats.org/drawingml/2006/main" r:embed="Raabad5063b944892"/>
           <a:srcRect xmlns:a="http://schemas.openxmlformats.org/drawingml/2006/main" l="0" t="0" r="0" b="0"/>
           <a:stretch xmlns:a="http://schemas.openxmlformats.org/drawingml/2006/main">
             <a:fillRect l="0" t="0" r="0" b="0"/>
@@ -9402,7 +9473,7 @@
           <p:cNvPr id="2" name="">
             <a:extLst xmlns:a="http://schemas.openxmlformats.org/drawingml/2006/main">
               <a:ext uri="{FF2B5EF4-FFF2-40B4-BE49-F238E27FC236}">
-                <a16:creationId xmlns:a16="http://schemas.microsoft.com/office/drawing/2014/main" id="{8C3E949E-88BA-4B19-AF13-195378FE682F}"/>
+                <a16:creationId xmlns:a16="http://schemas.microsoft.com/office/drawing/2014/main" id="{95193529-291D-419D-A6AB-E3B72F68F986}"/>
               </a:ext>
             </a:extLst>
           </p:cNvPr>
@@ -9439,7 +9510,7 @@
                 <a:ea typeface="Inter"/>
                 <a:cs typeface="Inter"/>
               </a:rPr>
-              <a:t>CLOSE</a:t>
+              <a:t>VISION</a:t>
             </a:r>
           </a:p>
         </p:txBody>
@@ -9449,7 +9520,7 @@
           <p:cNvPr id="3" name="">
             <a:extLst xmlns:a="http://schemas.openxmlformats.org/drawingml/2006/main">
               <a:ext uri="{FF2B5EF4-FFF2-40B4-BE49-F238E27FC236}">
-                <a16:creationId xmlns:a16="http://schemas.microsoft.com/office/drawing/2014/main" id="{134C5EC3-98CC-45E3-843A-B7793315376A}"/>
+                <a16:creationId xmlns:a16="http://schemas.microsoft.com/office/drawing/2014/main" id="{3790AA51-BD9F-4EED-A82B-18431D13189E}"/>
               </a:ext>
             </a:extLst>
           </p:cNvPr>
@@ -9486,7 +9557,7 @@
                 <a:ea typeface="Inter"/>
                 <a:cs typeface="Inter"/>
               </a:rPr>
-              <a:t>Mochi catches fake agreement</a:t>
+              <a:t>An orchestration layer.</a:t>
             </a:r>
           </a:p>
           <a:p xmlns:a="http://schemas.openxmlformats.org/drawingml/2006/main">
@@ -9499,7 +9570,7 @@
                 <a:ea typeface="Inter"/>
                 <a:cs typeface="Inter"/>
               </a:rPr>
-              <a:t>before the hour is gone.</a:t>
+              <a:t>Bring your own agent.</a:t>
             </a:r>
           </a:p>
         </p:txBody>
@@ -9509,7 +9580,7 @@
           <p:cNvPr id="4" name="">
             <a:extLst xmlns:a="http://schemas.openxmlformats.org/drawingml/2006/main">
               <a:ext uri="{FF2B5EF4-FFF2-40B4-BE49-F238E27FC236}">
-                <a16:creationId xmlns:a16="http://schemas.microsoft.com/office/drawing/2014/main" id="{4C2614A4-5194-4BBD-988E-85EE593BB5E7}"/>
+                <a16:creationId xmlns:a16="http://schemas.microsoft.com/office/drawing/2014/main" id="{86497BE4-18D0-40BB-951A-F467348BA007}"/>
               </a:ext>
             </a:extLst>
           </p:cNvPr>
@@ -9546,7 +9617,7 @@
                 <a:ea typeface="Inter"/>
                 <a:cs typeface="Inter"/>
               </a:rPr>
-              <a:t>Sources: docs/pitch-script.md, docs/submission-checklist.md</a:t>
+              <a:t>Sources: docs/design-spec.md, AGENTS.md</a:t>
             </a:r>
           </a:p>
         </p:txBody>
@@ -9556,7 +9627,7 @@
           <p:cNvPr id="5" name="">
             <a:extLst xmlns:a="http://schemas.openxmlformats.org/drawingml/2006/main">
               <a:ext uri="{FF2B5EF4-FFF2-40B4-BE49-F238E27FC236}">
-                <a16:creationId xmlns:a16="http://schemas.microsoft.com/office/drawing/2014/main" id="{6124821F-C353-4DCF-A1AC-196087C98D2E}"/>
+                <a16:creationId xmlns:a16="http://schemas.microsoft.com/office/drawing/2014/main" id="{CF22C0CB-1361-4380-8092-26B5E582D081}"/>
               </a:ext>
             </a:extLst>
           </p:cNvPr>
@@ -9613,121 +9684,23 @@
           <p:cNvPr id="6" name="">
             <a:extLst xmlns:a="http://schemas.openxmlformats.org/drawingml/2006/main">
               <a:ext uri="{FF2B5EF4-FFF2-40B4-BE49-F238E27FC236}">
-                <a16:creationId xmlns:a16="http://schemas.microsoft.com/office/drawing/2014/main" id="{3B8A1C02-63BC-4A15-8FBE-21550EC45D8B}"/>
-              </a:ext>
-            </a:extLst>
-          </p:cNvPr>
-          <p:cNvSpPr>
-            <a:spLocks xmlns:a="http://schemas.openxmlformats.org/drawingml/2006/main" noGrp="1"/>
-          </p:cNvSpPr>
-          <p:nvPr/>
-        </p:nvSpPr>
-        <p:spPr>
-          <a:xfrm xmlns:a="http://schemas.openxmlformats.org/drawingml/2006/main">
-            <a:off x="876300" y="2038350"/>
-            <a:ext cx="5905500" cy="1257300"/>
-          </a:xfrm>
-          <a:prstGeom xmlns:a="http://schemas.openxmlformats.org/drawingml/2006/main" prst="rect">
-            <a:avLst/>
-          </a:prstGeom>
-          <a:noFill xmlns:a="http://schemas.openxmlformats.org/drawingml/2006/main"/>
-          <a:ln xmlns:a="http://schemas.openxmlformats.org/drawingml/2006/main" w="0">
-            <a:noFill/>
-          </a:ln>
-        </p:spPr>
-        <p:txBody>
-          <a:bodyPr xmlns:a="http://schemas.openxmlformats.org/drawingml/2006/main" wrap="square" lIns="38100" tIns="38100" rIns="38100" bIns="38100">
-            <a:noAutofit/>
-          </a:bodyPr>
-          <a:lstStyle xmlns:a="http://schemas.openxmlformats.org/drawingml/2006/main"/>
-          <a:p xmlns:a="http://schemas.openxmlformats.org/drawingml/2006/main">
-            <a:r>
-              <a:rPr sz="2700">
-                <a:solidFill>
-                  <a:srgbClr val="181818"/>
-                </a:solidFill>
-                <a:latin typeface="Inter"/>
-                <a:ea typeface="Inter"/>
-                <a:cs typeface="Inter"/>
-              </a:rPr>
-              <a:t>Not after-meeting summary.</a:t>
-            </a:r>
-          </a:p>
-          <a:p xmlns:a="http://schemas.openxmlformats.org/drawingml/2006/main">
-            <a:r>
-              <a:rPr sz="2700">
-                <a:solidFill>
-                  <a:srgbClr val="181818"/>
-                </a:solidFill>
-                <a:latin typeface="Inter"/>
-                <a:ea typeface="Inter"/>
-                <a:cs typeface="Inter"/>
-              </a:rPr>
-              <a:t>Before-meeting crux.</a:t>
-            </a:r>
-          </a:p>
-          <a:p xmlns:a="http://schemas.openxmlformats.org/drawingml/2006/main">
-            <a:r>
-              <a:rPr sz="2700">
-                <a:solidFill>
-                  <a:srgbClr val="181818"/>
-                </a:solidFill>
-                <a:latin typeface="Inter"/>
-                <a:ea typeface="Inter"/>
-                <a:cs typeface="Inter"/>
-              </a:rPr>
-              <a:t>Inside Slack.</a:t>
-            </a:r>
-          </a:p>
-        </p:txBody>
-      </p:sp>
-      <p:pic>
-        <p:nvPicPr>
-          <p:cNvPr id="7" name=""/>
-          <p:cNvPicPr>
-            <a:picLocks xmlns:a="http://schemas.openxmlformats.org/drawingml/2006/main" noChangeAspect="1"/>
-          </p:cNvPicPr>
-          <p:nvPr/>
-        </p:nvPicPr>
-        <p:blipFill>
-          <a:blip xmlns:r="http://schemas.openxmlformats.org/officeDocument/2006/relationships" xmlns:a="http://schemas.openxmlformats.org/drawingml/2006/main" r:embed="Rc8b73721e51d430d"/>
-          <a:srcRect xmlns:a="http://schemas.openxmlformats.org/drawingml/2006/main" l="0" t="0" r="0" b="0"/>
-          <a:stretch xmlns:a="http://schemas.openxmlformats.org/drawingml/2006/main">
-            <a:fillRect l="0" t="0" r="0" b="0"/>
-          </a:stretch>
-        </p:blipFill>
-        <p:spPr>
-          <a:xfrm xmlns:a="http://schemas.openxmlformats.org/drawingml/2006/main">
-            <a:off x="7524750" y="2019300"/>
-            <a:ext cx="1676400" cy="1676400"/>
-          </a:xfrm>
-          <a:prstGeom xmlns:a="http://schemas.openxmlformats.org/drawingml/2006/main" prst="rect">
-            <a:avLst/>
-          </a:prstGeom>
-        </p:spPr>
-      </p:pic>
-      <p:sp>
-        <p:nvSpPr>
-          <p:cNvPr id="8" name="">
-            <a:extLst xmlns:a="http://schemas.openxmlformats.org/drawingml/2006/main">
-              <a:ext uri="{FF2B5EF4-FFF2-40B4-BE49-F238E27FC236}">
-                <a16:creationId xmlns:a16="http://schemas.microsoft.com/office/drawing/2014/main" id="{8ACCE954-52A4-4208-BD38-83AE3EA19339}"/>
-              </a:ext>
-            </a:extLst>
-          </p:cNvPr>
-          <p:cNvSpPr>
-            <a:spLocks xmlns:a="http://schemas.openxmlformats.org/drawingml/2006/main" noGrp="1"/>
-          </p:cNvSpPr>
-          <p:nvPr/>
-        </p:nvSpPr>
-        <p:spPr>
-          <a:xfrm xmlns:a="http://schemas.openxmlformats.org/drawingml/2006/main">
-            <a:off x="876300" y="3695700"/>
-            <a:ext cx="6610350" cy="1295400"/>
+                <a16:creationId xmlns:a16="http://schemas.microsoft.com/office/drawing/2014/main" id="{3141463E-EA2D-4B0A-9046-D7C92B5B8A00}"/>
+              </a:ext>
+            </a:extLst>
+          </p:cNvPr>
+          <p:cNvSpPr>
+            <a:spLocks xmlns:a="http://schemas.openxmlformats.org/drawingml/2006/main" noGrp="1"/>
+          </p:cNvSpPr>
+          <p:nvPr/>
+        </p:nvSpPr>
+        <p:spPr>
+          <a:xfrm xmlns:a="http://schemas.openxmlformats.org/drawingml/2006/main">
+            <a:off x="895350" y="2133600"/>
+            <a:ext cx="2095500" cy="1676400"/>
           </a:xfrm>
           <a:prstGeom xmlns:a="http://schemas.openxmlformats.org/drawingml/2006/main" prst="roundRect">
             <a:avLst>
-              <a:gd name="adj" fmla="val 5882"/>
+              <a:gd name="adj" fmla="val 4545"/>
             </a:avLst>
           </a:prstGeom>
           <a:solidFill xmlns:a="http://schemas.openxmlformats.org/drawingml/2006/main">
@@ -9742,10 +9715,1642 @@
       </p:sp>
       <p:sp>
         <p:nvSpPr>
+          <p:cNvPr id="7" name="">
+            <a:extLst xmlns:a="http://schemas.openxmlformats.org/drawingml/2006/main">
+              <a:ext uri="{FF2B5EF4-FFF2-40B4-BE49-F238E27FC236}">
+                <a16:creationId xmlns:a16="http://schemas.microsoft.com/office/drawing/2014/main" id="{A6F465F8-CCD9-488C-BDA8-0CB7B4D9AD2D}"/>
+              </a:ext>
+            </a:extLst>
+          </p:cNvPr>
+          <p:cNvSpPr>
+            <a:spLocks xmlns:a="http://schemas.openxmlformats.org/drawingml/2006/main" noGrp="1"/>
+          </p:cNvSpPr>
+          <p:nvPr/>
+        </p:nvSpPr>
+        <p:spPr>
+          <a:xfrm xmlns:a="http://schemas.openxmlformats.org/drawingml/2006/main">
+            <a:off x="1104900" y="2381250"/>
+            <a:ext cx="1676400" cy="247650"/>
+          </a:xfrm>
+          <a:prstGeom xmlns:a="http://schemas.openxmlformats.org/drawingml/2006/main" prst="rect">
+            <a:avLst/>
+          </a:prstGeom>
+          <a:noFill xmlns:a="http://schemas.openxmlformats.org/drawingml/2006/main"/>
+          <a:ln xmlns:a="http://schemas.openxmlformats.org/drawingml/2006/main" w="0">
+            <a:noFill/>
+          </a:ln>
+        </p:spPr>
+        <p:txBody>
+          <a:bodyPr xmlns:a="http://schemas.openxmlformats.org/drawingml/2006/main" wrap="square" lIns="38100" tIns="38100" rIns="38100" bIns="38100">
+            <a:noAutofit/>
+          </a:bodyPr>
+          <a:lstStyle xmlns:a="http://schemas.openxmlformats.org/drawingml/2006/main"/>
+          <a:p xmlns:a="http://schemas.openxmlformats.org/drawingml/2006/main">
+            <a:r>
+              <a:rPr sz="1575" b="1">
+                <a:solidFill>
+                  <a:srgbClr val="181818"/>
+                </a:solidFill>
+                <a:latin typeface="Inter"/>
+                <a:ea typeface="Inter"/>
+                <a:cs typeface="Inter"/>
+              </a:rPr>
+              <a:t>Your agents</a:t>
+            </a:r>
+          </a:p>
+        </p:txBody>
+      </p:sp>
+      <p:sp>
+        <p:nvSpPr>
+          <p:cNvPr id="8" name="">
+            <a:extLst xmlns:a="http://schemas.openxmlformats.org/drawingml/2006/main">
+              <a:ext uri="{FF2B5EF4-FFF2-40B4-BE49-F238E27FC236}">
+                <a16:creationId xmlns:a16="http://schemas.microsoft.com/office/drawing/2014/main" id="{A9DE347A-DE34-47C8-A1D8-6F2346B4C20F}"/>
+              </a:ext>
+            </a:extLst>
+          </p:cNvPr>
+          <p:cNvSpPr>
+            <a:spLocks xmlns:a="http://schemas.openxmlformats.org/drawingml/2006/main" noGrp="1"/>
+          </p:cNvSpPr>
+          <p:nvPr/>
+        </p:nvSpPr>
+        <p:spPr>
+          <a:xfrm xmlns:a="http://schemas.openxmlformats.org/drawingml/2006/main">
+            <a:off x="1104900" y="2819400"/>
+            <a:ext cx="1676400" cy="914400"/>
+          </a:xfrm>
+          <a:prstGeom xmlns:a="http://schemas.openxmlformats.org/drawingml/2006/main" prst="rect">
+            <a:avLst/>
+          </a:prstGeom>
+          <a:noFill xmlns:a="http://schemas.openxmlformats.org/drawingml/2006/main"/>
+          <a:ln xmlns:a="http://schemas.openxmlformats.org/drawingml/2006/main" w="0">
+            <a:noFill/>
+          </a:ln>
+        </p:spPr>
+        <p:txBody>
+          <a:bodyPr xmlns:a="http://schemas.openxmlformats.org/drawingml/2006/main" wrap="square" lIns="38100" tIns="38100" rIns="38100" bIns="38100">
+            <a:noAutofit/>
+          </a:bodyPr>
+          <a:lstStyle xmlns:a="http://schemas.openxmlformats.org/drawingml/2006/main"/>
+          <a:p xmlns:a="http://schemas.openxmlformats.org/drawingml/2006/main">
+            <a:r>
+              <a:rPr sz="1275">
+                <a:solidFill>
+                  <a:srgbClr val="282828"/>
+                </a:solidFill>
+                <a:latin typeface="Inter"/>
+                <a:ea typeface="Inter"/>
+                <a:cs typeface="Inter"/>
+              </a:rPr>
+              <a:t>one per participant</a:t>
+            </a:r>
+          </a:p>
+          <a:p xmlns:a="http://schemas.openxmlformats.org/drawingml/2006/main">
+            <a:r>
+              <a:rPr sz="1275">
+                <a:solidFill>
+                  <a:srgbClr val="282828"/>
+                </a:solidFill>
+                <a:latin typeface="Inter"/>
+                <a:ea typeface="Inter"/>
+                <a:cs typeface="Inter"/>
+              </a:rPr>
+              <a:t>your model + context</a:t>
+            </a:r>
+          </a:p>
+          <a:p xmlns:a="http://schemas.openxmlformats.org/drawingml/2006/main">
+            <a:r>
+              <a:rPr sz="1275">
+                <a:solidFill>
+                  <a:srgbClr val="282828"/>
+                </a:solidFill>
+                <a:latin typeface="Inter"/>
+                <a:ea typeface="Inter"/>
+                <a:cs typeface="Inter"/>
+              </a:rPr>
+              <a:t>your tools</a:t>
+            </a:r>
+          </a:p>
+        </p:txBody>
+      </p:sp>
+      <p:sp>
+        <p:nvSpPr>
           <p:cNvPr id="9" name="">
             <a:extLst xmlns:a="http://schemas.openxmlformats.org/drawingml/2006/main">
               <a:ext uri="{FF2B5EF4-FFF2-40B4-BE49-F238E27FC236}">
-                <a16:creationId xmlns:a16="http://schemas.microsoft.com/office/drawing/2014/main" id="{4E040C5E-31F8-4E61-A8B6-997834F56477}"/>
+                <a16:creationId xmlns:a16="http://schemas.microsoft.com/office/drawing/2014/main" id="{5B695A37-5FE5-4ED5-97CF-3EDE6223EEAC}"/>
+              </a:ext>
+            </a:extLst>
+          </p:cNvPr>
+          <p:cNvSpPr>
+            <a:spLocks xmlns:a="http://schemas.openxmlformats.org/drawingml/2006/main" noGrp="1"/>
+          </p:cNvSpPr>
+          <p:nvPr/>
+        </p:nvSpPr>
+        <p:spPr>
+          <a:xfrm xmlns:a="http://schemas.openxmlformats.org/drawingml/2006/main">
+            <a:off x="3067050" y="2971800"/>
+            <a:ext cx="247650" cy="19050"/>
+          </a:xfrm>
+          <a:prstGeom xmlns:a="http://schemas.openxmlformats.org/drawingml/2006/main" prst="rect">
+            <a:avLst/>
+          </a:prstGeom>
+          <a:solidFill xmlns:a="http://schemas.openxmlformats.org/drawingml/2006/main">
+            <a:srgbClr val="EDEDED"/>
+          </a:solidFill>
+          <a:ln xmlns:a="http://schemas.openxmlformats.org/drawingml/2006/main" w="0">
+            <a:noFill/>
+          </a:ln>
+        </p:spPr>
+      </p:sp>
+      <p:sp>
+        <p:nvSpPr>
+          <p:cNvPr id="10" name="">
+            <a:extLst xmlns:a="http://schemas.openxmlformats.org/drawingml/2006/main">
+              <a:ext uri="{FF2B5EF4-FFF2-40B4-BE49-F238E27FC236}">
+                <a16:creationId xmlns:a16="http://schemas.microsoft.com/office/drawing/2014/main" id="{8BBBC225-F44F-4F12-B8FE-A9C4702471B2}"/>
+              </a:ext>
+            </a:extLst>
+          </p:cNvPr>
+          <p:cNvSpPr>
+            <a:spLocks xmlns:a="http://schemas.openxmlformats.org/drawingml/2006/main" noGrp="1"/>
+          </p:cNvSpPr>
+          <p:nvPr/>
+        </p:nvSpPr>
+        <p:spPr>
+          <a:xfrm xmlns:a="http://schemas.openxmlformats.org/drawingml/2006/main">
+            <a:off x="3295650" y="2933700"/>
+            <a:ext cx="133350" cy="95250"/>
+          </a:xfrm>
+          <a:prstGeom xmlns:a="http://schemas.openxmlformats.org/drawingml/2006/main" prst="triangle">
+            <a:avLst/>
+          </a:prstGeom>
+          <a:solidFill xmlns:a="http://schemas.openxmlformats.org/drawingml/2006/main">
+            <a:srgbClr val="EDEDED"/>
+          </a:solidFill>
+          <a:ln xmlns:a="http://schemas.openxmlformats.org/drawingml/2006/main" w="0">
+            <a:noFill/>
+          </a:ln>
+        </p:spPr>
+      </p:sp>
+      <p:sp>
+        <p:nvSpPr>
+          <p:cNvPr id="11" name="">
+            <a:extLst xmlns:a="http://schemas.openxmlformats.org/drawingml/2006/main">
+              <a:ext uri="{FF2B5EF4-FFF2-40B4-BE49-F238E27FC236}">
+                <a16:creationId xmlns:a16="http://schemas.microsoft.com/office/drawing/2014/main" id="{BB993BE6-89AA-4710-BB22-49E20205D618}"/>
+              </a:ext>
+            </a:extLst>
+          </p:cNvPr>
+          <p:cNvSpPr>
+            <a:spLocks xmlns:a="http://schemas.openxmlformats.org/drawingml/2006/main" noGrp="1"/>
+          </p:cNvSpPr>
+          <p:nvPr/>
+        </p:nvSpPr>
+        <p:spPr>
+          <a:xfrm xmlns:a="http://schemas.openxmlformats.org/drawingml/2006/main">
+            <a:off x="3448050" y="2133600"/>
+            <a:ext cx="2095500" cy="1676400"/>
+          </a:xfrm>
+          <a:prstGeom xmlns:a="http://schemas.openxmlformats.org/drawingml/2006/main" prst="roundRect">
+            <a:avLst>
+              <a:gd name="adj" fmla="val 4545"/>
+            </a:avLst>
+          </a:prstGeom>
+          <a:solidFill xmlns:a="http://schemas.openxmlformats.org/drawingml/2006/main">
+            <a:srgbClr val="F3F3F3"/>
+          </a:solidFill>
+          <a:ln xmlns:a="http://schemas.openxmlformats.org/drawingml/2006/main" w="9525">
+            <a:solidFill>
+              <a:srgbClr val="282828"/>
+            </a:solidFill>
+          </a:ln>
+        </p:spPr>
+      </p:sp>
+      <p:sp>
+        <p:nvSpPr>
+          <p:cNvPr id="12" name="">
+            <a:extLst xmlns:a="http://schemas.openxmlformats.org/drawingml/2006/main">
+              <a:ext uri="{FF2B5EF4-FFF2-40B4-BE49-F238E27FC236}">
+                <a16:creationId xmlns:a16="http://schemas.microsoft.com/office/drawing/2014/main" id="{6C5A0CC4-09E1-4936-89BB-F558F3CE2411}"/>
+              </a:ext>
+            </a:extLst>
+          </p:cNvPr>
+          <p:cNvSpPr>
+            <a:spLocks xmlns:a="http://schemas.openxmlformats.org/drawingml/2006/main" noGrp="1"/>
+          </p:cNvSpPr>
+          <p:nvPr/>
+        </p:nvSpPr>
+        <p:spPr>
+          <a:xfrm xmlns:a="http://schemas.openxmlformats.org/drawingml/2006/main">
+            <a:off x="3657600" y="2381250"/>
+            <a:ext cx="1676400" cy="247650"/>
+          </a:xfrm>
+          <a:prstGeom xmlns:a="http://schemas.openxmlformats.org/drawingml/2006/main" prst="rect">
+            <a:avLst/>
+          </a:prstGeom>
+          <a:noFill xmlns:a="http://schemas.openxmlformats.org/drawingml/2006/main"/>
+          <a:ln xmlns:a="http://schemas.openxmlformats.org/drawingml/2006/main" w="0">
+            <a:noFill/>
+          </a:ln>
+        </p:spPr>
+        <p:txBody>
+          <a:bodyPr xmlns:a="http://schemas.openxmlformats.org/drawingml/2006/main" wrap="square" lIns="38100" tIns="38100" rIns="38100" bIns="38100">
+            <a:noAutofit/>
+          </a:bodyPr>
+          <a:lstStyle xmlns:a="http://schemas.openxmlformats.org/drawingml/2006/main"/>
+          <a:p xmlns:a="http://schemas.openxmlformats.org/drawingml/2006/main">
+            <a:r>
+              <a:rPr sz="1575" b="1">
+                <a:solidFill>
+                  <a:srgbClr val="181818"/>
+                </a:solidFill>
+                <a:latin typeface="Inter"/>
+                <a:ea typeface="Inter"/>
+                <a:cs typeface="Inter"/>
+              </a:rPr>
+              <a:t>Stance contract</a:t>
+            </a:r>
+          </a:p>
+        </p:txBody>
+      </p:sp>
+      <p:sp>
+        <p:nvSpPr>
+          <p:cNvPr id="13" name="">
+            <a:extLst xmlns:a="http://schemas.openxmlformats.org/drawingml/2006/main">
+              <a:ext uri="{FF2B5EF4-FFF2-40B4-BE49-F238E27FC236}">
+                <a16:creationId xmlns:a16="http://schemas.microsoft.com/office/drawing/2014/main" id="{1812E6D8-D7F3-49CE-8FAA-3BA9A8FFA89D}"/>
+              </a:ext>
+            </a:extLst>
+          </p:cNvPr>
+          <p:cNvSpPr>
+            <a:spLocks xmlns:a="http://schemas.openxmlformats.org/drawingml/2006/main" noGrp="1"/>
+          </p:cNvSpPr>
+          <p:nvPr/>
+        </p:nvSpPr>
+        <p:spPr>
+          <a:xfrm xmlns:a="http://schemas.openxmlformats.org/drawingml/2006/main">
+            <a:off x="3657600" y="2819400"/>
+            <a:ext cx="1676400" cy="914400"/>
+          </a:xfrm>
+          <a:prstGeom xmlns:a="http://schemas.openxmlformats.org/drawingml/2006/main" prst="rect">
+            <a:avLst/>
+          </a:prstGeom>
+          <a:noFill xmlns:a="http://schemas.openxmlformats.org/drawingml/2006/main"/>
+          <a:ln xmlns:a="http://schemas.openxmlformats.org/drawingml/2006/main" w="0">
+            <a:noFill/>
+          </a:ln>
+        </p:spPr>
+        <p:txBody>
+          <a:bodyPr xmlns:a="http://schemas.openxmlformats.org/drawingml/2006/main" wrap="square" lIns="38100" tIns="38100" rIns="38100" bIns="38100">
+            <a:noAutofit/>
+          </a:bodyPr>
+          <a:lstStyle xmlns:a="http://schemas.openxmlformats.org/drawingml/2006/main"/>
+          <a:p xmlns:a="http://schemas.openxmlformats.org/drawingml/2006/main">
+            <a:r>
+              <a:rPr sz="1275">
+                <a:solidFill>
+                  <a:srgbClr val="282828"/>
+                </a:solidFill>
+                <a:latin typeface="Inter"/>
+                <a:ea typeface="Inter"/>
+                <a:cs typeface="Inter"/>
+              </a:rPr>
+              <a:t>position</a:t>
+            </a:r>
+          </a:p>
+          <a:p xmlns:a="http://schemas.openxmlformats.org/drawingml/2006/main">
+            <a:r>
+              <a:rPr sz="1275">
+                <a:solidFill>
+                  <a:srgbClr val="282828"/>
+                </a:solidFill>
+                <a:latin typeface="Inter"/>
+                <a:ea typeface="Inter"/>
+                <a:cs typeface="Inter"/>
+              </a:rPr>
+              <a:t>rationale, assumptions</a:t>
+            </a:r>
+          </a:p>
+          <a:p xmlns:a="http://schemas.openxmlformats.org/drawingml/2006/main">
+            <a:r>
+              <a:rPr sz="1275">
+                <a:solidFill>
+                  <a:srgbClr val="282828"/>
+                </a:solidFill>
+                <a:latin typeface="Inter"/>
+                <a:ea typeface="Inter"/>
+                <a:cs typeface="Inter"/>
+              </a:rPr>
+              <a:t>confidence</a:t>
+            </a:r>
+          </a:p>
+        </p:txBody>
+      </p:sp>
+      <p:sp>
+        <p:nvSpPr>
+          <p:cNvPr id="14" name="">
+            <a:extLst xmlns:a="http://schemas.openxmlformats.org/drawingml/2006/main">
+              <a:ext uri="{FF2B5EF4-FFF2-40B4-BE49-F238E27FC236}">
+                <a16:creationId xmlns:a16="http://schemas.microsoft.com/office/drawing/2014/main" id="{9195C212-E93E-4F2C-97C0-15AC0E8F5F42}"/>
+              </a:ext>
+            </a:extLst>
+          </p:cNvPr>
+          <p:cNvSpPr>
+            <a:spLocks xmlns:a="http://schemas.openxmlformats.org/drawingml/2006/main" noGrp="1"/>
+          </p:cNvSpPr>
+          <p:nvPr/>
+        </p:nvSpPr>
+        <p:spPr>
+          <a:xfrm xmlns:a="http://schemas.openxmlformats.org/drawingml/2006/main">
+            <a:off x="5619750" y="2971800"/>
+            <a:ext cx="247650" cy="19050"/>
+          </a:xfrm>
+          <a:prstGeom xmlns:a="http://schemas.openxmlformats.org/drawingml/2006/main" prst="rect">
+            <a:avLst/>
+          </a:prstGeom>
+          <a:solidFill xmlns:a="http://schemas.openxmlformats.org/drawingml/2006/main">
+            <a:srgbClr val="EDEDED"/>
+          </a:solidFill>
+          <a:ln xmlns:a="http://schemas.openxmlformats.org/drawingml/2006/main" w="0">
+            <a:noFill/>
+          </a:ln>
+        </p:spPr>
+      </p:sp>
+      <p:sp>
+        <p:nvSpPr>
+          <p:cNvPr id="15" name="">
+            <a:extLst xmlns:a="http://schemas.openxmlformats.org/drawingml/2006/main">
+              <a:ext uri="{FF2B5EF4-FFF2-40B4-BE49-F238E27FC236}">
+                <a16:creationId xmlns:a16="http://schemas.microsoft.com/office/drawing/2014/main" id="{21F2E357-5AE1-49CF-A0D4-9EDB58179E57}"/>
+              </a:ext>
+            </a:extLst>
+          </p:cNvPr>
+          <p:cNvSpPr>
+            <a:spLocks xmlns:a="http://schemas.openxmlformats.org/drawingml/2006/main" noGrp="1"/>
+          </p:cNvSpPr>
+          <p:nvPr/>
+        </p:nvSpPr>
+        <p:spPr>
+          <a:xfrm xmlns:a="http://schemas.openxmlformats.org/drawingml/2006/main">
+            <a:off x="5848350" y="2933700"/>
+            <a:ext cx="133350" cy="95250"/>
+          </a:xfrm>
+          <a:prstGeom xmlns:a="http://schemas.openxmlformats.org/drawingml/2006/main" prst="triangle">
+            <a:avLst/>
+          </a:prstGeom>
+          <a:solidFill xmlns:a="http://schemas.openxmlformats.org/drawingml/2006/main">
+            <a:srgbClr val="EDEDED"/>
+          </a:solidFill>
+          <a:ln xmlns:a="http://schemas.openxmlformats.org/drawingml/2006/main" w="0">
+            <a:noFill/>
+          </a:ln>
+        </p:spPr>
+      </p:sp>
+      <p:sp>
+        <p:nvSpPr>
+          <p:cNvPr id="16" name="">
+            <a:extLst xmlns:a="http://schemas.openxmlformats.org/drawingml/2006/main">
+              <a:ext uri="{FF2B5EF4-FFF2-40B4-BE49-F238E27FC236}">
+                <a16:creationId xmlns:a16="http://schemas.microsoft.com/office/drawing/2014/main" id="{1B3C72DE-D9B5-4E65-B367-55F2F6FB8058}"/>
+              </a:ext>
+            </a:extLst>
+          </p:cNvPr>
+          <p:cNvSpPr>
+            <a:spLocks xmlns:a="http://schemas.openxmlformats.org/drawingml/2006/main" noGrp="1"/>
+          </p:cNvSpPr>
+          <p:nvPr/>
+        </p:nvSpPr>
+        <p:spPr>
+          <a:xfrm xmlns:a="http://schemas.openxmlformats.org/drawingml/2006/main">
+            <a:off x="6000750" y="2133600"/>
+            <a:ext cx="2095500" cy="1676400"/>
+          </a:xfrm>
+          <a:prstGeom xmlns:a="http://schemas.openxmlformats.org/drawingml/2006/main" prst="roundRect">
+            <a:avLst>
+              <a:gd name="adj" fmla="val 4545"/>
+            </a:avLst>
+          </a:prstGeom>
+          <a:solidFill xmlns:a="http://schemas.openxmlformats.org/drawingml/2006/main">
+            <a:srgbClr val="FFFFFF"/>
+          </a:solidFill>
+          <a:ln xmlns:a="http://schemas.openxmlformats.org/drawingml/2006/main" w="9525">
+            <a:solidFill>
+              <a:srgbClr val="EDEDED"/>
+            </a:solidFill>
+          </a:ln>
+        </p:spPr>
+      </p:sp>
+      <p:sp>
+        <p:nvSpPr>
+          <p:cNvPr id="17" name="">
+            <a:extLst xmlns:a="http://schemas.openxmlformats.org/drawingml/2006/main">
+              <a:ext uri="{FF2B5EF4-FFF2-40B4-BE49-F238E27FC236}">
+                <a16:creationId xmlns:a16="http://schemas.microsoft.com/office/drawing/2014/main" id="{80FE9681-17FC-49EA-B1DD-A8B494EEC60C}"/>
+              </a:ext>
+            </a:extLst>
+          </p:cNvPr>
+          <p:cNvSpPr>
+            <a:spLocks xmlns:a="http://schemas.openxmlformats.org/drawingml/2006/main" noGrp="1"/>
+          </p:cNvSpPr>
+          <p:nvPr/>
+        </p:nvSpPr>
+        <p:spPr>
+          <a:xfrm xmlns:a="http://schemas.openxmlformats.org/drawingml/2006/main">
+            <a:off x="6210300" y="2381250"/>
+            <a:ext cx="1676400" cy="247650"/>
+          </a:xfrm>
+          <a:prstGeom xmlns:a="http://schemas.openxmlformats.org/drawingml/2006/main" prst="rect">
+            <a:avLst/>
+          </a:prstGeom>
+          <a:noFill xmlns:a="http://schemas.openxmlformats.org/drawingml/2006/main"/>
+          <a:ln xmlns:a="http://schemas.openxmlformats.org/drawingml/2006/main" w="0">
+            <a:noFill/>
+          </a:ln>
+        </p:spPr>
+        <p:txBody>
+          <a:bodyPr xmlns:a="http://schemas.openxmlformats.org/drawingml/2006/main" wrap="square" lIns="38100" tIns="38100" rIns="38100" bIns="38100">
+            <a:noAutofit/>
+          </a:bodyPr>
+          <a:lstStyle xmlns:a="http://schemas.openxmlformats.org/drawingml/2006/main"/>
+          <a:p xmlns:a="http://schemas.openxmlformats.org/drawingml/2006/main">
+            <a:r>
+              <a:rPr sz="1575" b="1">
+                <a:solidFill>
+                  <a:srgbClr val="181818"/>
+                </a:solidFill>
+                <a:latin typeface="Inter"/>
+                <a:ea typeface="Inter"/>
+                <a:cs typeface="Inter"/>
+              </a:rPr>
+              <a:t>Mochi orchestrator</a:t>
+            </a:r>
+          </a:p>
+        </p:txBody>
+      </p:sp>
+      <p:sp>
+        <p:nvSpPr>
+          <p:cNvPr id="18" name="">
+            <a:extLst xmlns:a="http://schemas.openxmlformats.org/drawingml/2006/main">
+              <a:ext uri="{FF2B5EF4-FFF2-40B4-BE49-F238E27FC236}">
+                <a16:creationId xmlns:a16="http://schemas.microsoft.com/office/drawing/2014/main" id="{67592BCF-0159-4DAD-A8CE-20CC27773488}"/>
+              </a:ext>
+            </a:extLst>
+          </p:cNvPr>
+          <p:cNvSpPr>
+            <a:spLocks xmlns:a="http://schemas.openxmlformats.org/drawingml/2006/main" noGrp="1"/>
+          </p:cNvSpPr>
+          <p:nvPr/>
+        </p:nvSpPr>
+        <p:spPr>
+          <a:xfrm xmlns:a="http://schemas.openxmlformats.org/drawingml/2006/main">
+            <a:off x="6210300" y="2819400"/>
+            <a:ext cx="1676400" cy="914400"/>
+          </a:xfrm>
+          <a:prstGeom xmlns:a="http://schemas.openxmlformats.org/drawingml/2006/main" prst="rect">
+            <a:avLst/>
+          </a:prstGeom>
+          <a:noFill xmlns:a="http://schemas.openxmlformats.org/drawingml/2006/main"/>
+          <a:ln xmlns:a="http://schemas.openxmlformats.org/drawingml/2006/main" w="0">
+            <a:noFill/>
+          </a:ln>
+        </p:spPr>
+        <p:txBody>
+          <a:bodyPr xmlns:a="http://schemas.openxmlformats.org/drawingml/2006/main" wrap="square" lIns="38100" tIns="38100" rIns="38100" bIns="38100">
+            <a:noAutofit/>
+          </a:bodyPr>
+          <a:lstStyle xmlns:a="http://schemas.openxmlformats.org/drawingml/2006/main"/>
+          <a:p xmlns:a="http://schemas.openxmlformats.org/drawingml/2006/main">
+            <a:r>
+              <a:rPr sz="1275">
+                <a:solidFill>
+                  <a:srgbClr val="282828"/>
+                </a:solidFill>
+                <a:latin typeface="Inter"/>
+                <a:ea typeface="Inter"/>
+                <a:cs typeface="Inter"/>
+              </a:rPr>
+              <a:t>compares assumptions</a:t>
+            </a:r>
+          </a:p>
+          <a:p xmlns:a="http://schemas.openxmlformats.org/drawingml/2006/main">
+            <a:r>
+              <a:rPr sz="1275">
+                <a:solidFill>
+                  <a:srgbClr val="282828"/>
+                </a:solidFill>
+                <a:latin typeface="Inter"/>
+                <a:ea typeface="Inter"/>
+                <a:cs typeface="Inter"/>
+              </a:rPr>
+              <a:t>clears easy items</a:t>
+            </a:r>
+          </a:p>
+          <a:p xmlns:a="http://schemas.openxmlformats.org/drawingml/2006/main">
+            <a:r>
+              <a:rPr sz="1275">
+                <a:solidFill>
+                  <a:srgbClr val="282828"/>
+                </a:solidFill>
+                <a:latin typeface="Inter"/>
+                <a:ea typeface="Inter"/>
+                <a:cs typeface="Inter"/>
+              </a:rPr>
+              <a:t>then dissolves</a:t>
+            </a:r>
+          </a:p>
+        </p:txBody>
+      </p:sp>
+      <p:sp>
+        <p:nvSpPr>
+          <p:cNvPr id="19" name="">
+            <a:extLst xmlns:a="http://schemas.openxmlformats.org/drawingml/2006/main">
+              <a:ext uri="{FF2B5EF4-FFF2-40B4-BE49-F238E27FC236}">
+                <a16:creationId xmlns:a16="http://schemas.microsoft.com/office/drawing/2014/main" id="{18717CB7-5693-4688-AFEF-4FD6D2AA9260}"/>
+              </a:ext>
+            </a:extLst>
+          </p:cNvPr>
+          <p:cNvSpPr>
+            <a:spLocks xmlns:a="http://schemas.openxmlformats.org/drawingml/2006/main" noGrp="1"/>
+          </p:cNvSpPr>
+          <p:nvPr/>
+        </p:nvSpPr>
+        <p:spPr>
+          <a:xfrm xmlns:a="http://schemas.openxmlformats.org/drawingml/2006/main">
+            <a:off x="8172450" y="2971800"/>
+            <a:ext cx="247650" cy="19050"/>
+          </a:xfrm>
+          <a:prstGeom xmlns:a="http://schemas.openxmlformats.org/drawingml/2006/main" prst="rect">
+            <a:avLst/>
+          </a:prstGeom>
+          <a:solidFill xmlns:a="http://schemas.openxmlformats.org/drawingml/2006/main">
+            <a:srgbClr val="EDEDED"/>
+          </a:solidFill>
+          <a:ln xmlns:a="http://schemas.openxmlformats.org/drawingml/2006/main" w="0">
+            <a:noFill/>
+          </a:ln>
+        </p:spPr>
+      </p:sp>
+      <p:sp>
+        <p:nvSpPr>
+          <p:cNvPr id="20" name="">
+            <a:extLst xmlns:a="http://schemas.openxmlformats.org/drawingml/2006/main">
+              <a:ext uri="{FF2B5EF4-FFF2-40B4-BE49-F238E27FC236}">
+                <a16:creationId xmlns:a16="http://schemas.microsoft.com/office/drawing/2014/main" id="{20727AD9-06E6-42F1-AD61-FF3DD77360B8}"/>
+              </a:ext>
+            </a:extLst>
+          </p:cNvPr>
+          <p:cNvSpPr>
+            <a:spLocks xmlns:a="http://schemas.openxmlformats.org/drawingml/2006/main" noGrp="1"/>
+          </p:cNvSpPr>
+          <p:nvPr/>
+        </p:nvSpPr>
+        <p:spPr>
+          <a:xfrm xmlns:a="http://schemas.openxmlformats.org/drawingml/2006/main">
+            <a:off x="8401050" y="2933700"/>
+            <a:ext cx="133350" cy="95250"/>
+          </a:xfrm>
+          <a:prstGeom xmlns:a="http://schemas.openxmlformats.org/drawingml/2006/main" prst="triangle">
+            <a:avLst/>
+          </a:prstGeom>
+          <a:solidFill xmlns:a="http://schemas.openxmlformats.org/drawingml/2006/main">
+            <a:srgbClr val="EDEDED"/>
+          </a:solidFill>
+          <a:ln xmlns:a="http://schemas.openxmlformats.org/drawingml/2006/main" w="0">
+            <a:noFill/>
+          </a:ln>
+        </p:spPr>
+      </p:sp>
+      <p:sp>
+        <p:nvSpPr>
+          <p:cNvPr id="21" name="">
+            <a:extLst xmlns:a="http://schemas.openxmlformats.org/drawingml/2006/main">
+              <a:ext uri="{FF2B5EF4-FFF2-40B4-BE49-F238E27FC236}">
+                <a16:creationId xmlns:a16="http://schemas.microsoft.com/office/drawing/2014/main" id="{F1EA8529-F10E-48B2-9B92-29DEA14EB260}"/>
+              </a:ext>
+            </a:extLst>
+          </p:cNvPr>
+          <p:cNvSpPr>
+            <a:spLocks xmlns:a="http://schemas.openxmlformats.org/drawingml/2006/main" noGrp="1"/>
+          </p:cNvSpPr>
+          <p:nvPr/>
+        </p:nvSpPr>
+        <p:spPr>
+          <a:xfrm xmlns:a="http://schemas.openxmlformats.org/drawingml/2006/main">
+            <a:off x="8553450" y="2133600"/>
+            <a:ext cx="2095500" cy="1676400"/>
+          </a:xfrm>
+          <a:prstGeom xmlns:a="http://schemas.openxmlformats.org/drawingml/2006/main" prst="roundRect">
+            <a:avLst>
+              <a:gd name="adj" fmla="val 4545"/>
+            </a:avLst>
+          </a:prstGeom>
+          <a:solidFill xmlns:a="http://schemas.openxmlformats.org/drawingml/2006/main">
+            <a:srgbClr val="FFFFFF"/>
+          </a:solidFill>
+          <a:ln xmlns:a="http://schemas.openxmlformats.org/drawingml/2006/main" w="9525">
+            <a:solidFill>
+              <a:srgbClr val="EDEDED"/>
+            </a:solidFill>
+          </a:ln>
+        </p:spPr>
+      </p:sp>
+      <p:sp>
+        <p:nvSpPr>
+          <p:cNvPr id="22" name="">
+            <a:extLst xmlns:a="http://schemas.openxmlformats.org/drawingml/2006/main">
+              <a:ext uri="{FF2B5EF4-FFF2-40B4-BE49-F238E27FC236}">
+                <a16:creationId xmlns:a16="http://schemas.microsoft.com/office/drawing/2014/main" id="{8A876ED7-C4F5-4BD9-9B1A-F843FFE0D0AC}"/>
+              </a:ext>
+            </a:extLst>
+          </p:cNvPr>
+          <p:cNvSpPr>
+            <a:spLocks xmlns:a="http://schemas.openxmlformats.org/drawingml/2006/main" noGrp="1"/>
+          </p:cNvSpPr>
+          <p:nvPr/>
+        </p:nvSpPr>
+        <p:spPr>
+          <a:xfrm xmlns:a="http://schemas.openxmlformats.org/drawingml/2006/main">
+            <a:off x="8763000" y="2381250"/>
+            <a:ext cx="1676400" cy="247650"/>
+          </a:xfrm>
+          <a:prstGeom xmlns:a="http://schemas.openxmlformats.org/drawingml/2006/main" prst="rect">
+            <a:avLst/>
+          </a:prstGeom>
+          <a:noFill xmlns:a="http://schemas.openxmlformats.org/drawingml/2006/main"/>
+          <a:ln xmlns:a="http://schemas.openxmlformats.org/drawingml/2006/main" w="0">
+            <a:noFill/>
+          </a:ln>
+        </p:spPr>
+        <p:txBody>
+          <a:bodyPr xmlns:a="http://schemas.openxmlformats.org/drawingml/2006/main" wrap="square" lIns="38100" tIns="38100" rIns="38100" bIns="38100">
+            <a:noAutofit/>
+          </a:bodyPr>
+          <a:lstStyle xmlns:a="http://schemas.openxmlformats.org/drawingml/2006/main"/>
+          <a:p xmlns:a="http://schemas.openxmlformats.org/drawingml/2006/main">
+            <a:r>
+              <a:rPr sz="1575" b="1">
+                <a:solidFill>
+                  <a:srgbClr val="181818"/>
+                </a:solidFill>
+                <a:latin typeface="Inter"/>
+                <a:ea typeface="Inter"/>
+                <a:cs typeface="Inter"/>
+              </a:rPr>
+              <a:t>Compressed brief</a:t>
+            </a:r>
+          </a:p>
+        </p:txBody>
+      </p:sp>
+      <p:sp>
+        <p:nvSpPr>
+          <p:cNvPr id="23" name="">
+            <a:extLst xmlns:a="http://schemas.openxmlformats.org/drawingml/2006/main">
+              <a:ext uri="{FF2B5EF4-FFF2-40B4-BE49-F238E27FC236}">
+                <a16:creationId xmlns:a16="http://schemas.microsoft.com/office/drawing/2014/main" id="{4A6672AD-10CD-42F8-9BFB-E7053D22E318}"/>
+              </a:ext>
+            </a:extLst>
+          </p:cNvPr>
+          <p:cNvSpPr>
+            <a:spLocks xmlns:a="http://schemas.openxmlformats.org/drawingml/2006/main" noGrp="1"/>
+          </p:cNvSpPr>
+          <p:nvPr/>
+        </p:nvSpPr>
+        <p:spPr>
+          <a:xfrm xmlns:a="http://schemas.openxmlformats.org/drawingml/2006/main">
+            <a:off x="8763000" y="2819400"/>
+            <a:ext cx="1676400" cy="914400"/>
+          </a:xfrm>
+          <a:prstGeom xmlns:a="http://schemas.openxmlformats.org/drawingml/2006/main" prst="rect">
+            <a:avLst/>
+          </a:prstGeom>
+          <a:noFill xmlns:a="http://schemas.openxmlformats.org/drawingml/2006/main"/>
+          <a:ln xmlns:a="http://schemas.openxmlformats.org/drawingml/2006/main" w="0">
+            <a:noFill/>
+          </a:ln>
+        </p:spPr>
+        <p:txBody>
+          <a:bodyPr xmlns:a="http://schemas.openxmlformats.org/drawingml/2006/main" wrap="square" lIns="38100" tIns="38100" rIns="38100" bIns="38100">
+            <a:noAutofit/>
+          </a:bodyPr>
+          <a:lstStyle xmlns:a="http://schemas.openxmlformats.org/drawingml/2006/main"/>
+          <a:p xmlns:a="http://schemas.openxmlformats.org/drawingml/2006/main">
+            <a:r>
+              <a:rPr sz="1275">
+                <a:solidFill>
+                  <a:srgbClr val="282828"/>
+                </a:solidFill>
+                <a:latin typeface="Inter"/>
+                <a:ea typeface="Inter"/>
+                <a:cs typeface="Inter"/>
+              </a:rPr>
+              <a:t>only real cruxes</a:t>
+            </a:r>
+          </a:p>
+          <a:p xmlns:a="http://schemas.openxmlformats.org/drawingml/2006/main">
+            <a:r>
+              <a:rPr sz="1275">
+                <a:solidFill>
+                  <a:srgbClr val="282828"/>
+                </a:solidFill>
+                <a:latin typeface="Inter"/>
+                <a:ea typeface="Inter"/>
+                <a:cs typeface="Inter"/>
+              </a:rPr>
+              <a:t>provenance</a:t>
+            </a:r>
+          </a:p>
+          <a:p xmlns:a="http://schemas.openxmlformats.org/drawingml/2006/main">
+            <a:r>
+              <a:rPr sz="1275">
+                <a:solidFill>
+                  <a:srgbClr val="282828"/>
+                </a:solidFill>
+                <a:latin typeface="Inter"/>
+                <a:ea typeface="Inter"/>
+                <a:cs typeface="Inter"/>
+              </a:rPr>
+              <a:t>human-owned</a:t>
+            </a:r>
+          </a:p>
+        </p:txBody>
+      </p:sp>
+      <p:sp>
+        <p:nvSpPr>
+          <p:cNvPr id="24" name="">
+            <a:extLst xmlns:a="http://schemas.openxmlformats.org/drawingml/2006/main">
+              <a:ext uri="{FF2B5EF4-FFF2-40B4-BE49-F238E27FC236}">
+                <a16:creationId xmlns:a16="http://schemas.microsoft.com/office/drawing/2014/main" id="{70065D86-01DD-4C99-A738-35EC29C14C08}"/>
+              </a:ext>
+            </a:extLst>
+          </p:cNvPr>
+          <p:cNvSpPr>
+            <a:spLocks xmlns:a="http://schemas.openxmlformats.org/drawingml/2006/main" noGrp="1"/>
+          </p:cNvSpPr>
+          <p:nvPr/>
+        </p:nvSpPr>
+        <p:spPr>
+          <a:xfrm xmlns:a="http://schemas.openxmlformats.org/drawingml/2006/main">
+            <a:off x="895350" y="4038600"/>
+            <a:ext cx="4762500" cy="1276350"/>
+          </a:xfrm>
+          <a:prstGeom xmlns:a="http://schemas.openxmlformats.org/drawingml/2006/main" prst="roundRect">
+            <a:avLst>
+              <a:gd name="adj" fmla="val 5970"/>
+            </a:avLst>
+          </a:prstGeom>
+          <a:solidFill xmlns:a="http://schemas.openxmlformats.org/drawingml/2006/main">
+            <a:srgbClr val="FFFFFF"/>
+          </a:solidFill>
+          <a:ln xmlns:a="http://schemas.openxmlformats.org/drawingml/2006/main" w="9525">
+            <a:solidFill>
+              <a:srgbClr val="EDEDED"/>
+            </a:solidFill>
+          </a:ln>
+        </p:spPr>
+      </p:sp>
+      <p:sp>
+        <p:nvSpPr>
+          <p:cNvPr id="25" name="">
+            <a:extLst xmlns:a="http://schemas.openxmlformats.org/drawingml/2006/main">
+              <a:ext uri="{FF2B5EF4-FFF2-40B4-BE49-F238E27FC236}">
+                <a16:creationId xmlns:a16="http://schemas.microsoft.com/office/drawing/2014/main" id="{1B9AD73C-0720-45BF-99AE-14ABD0216361}"/>
+              </a:ext>
+            </a:extLst>
+          </p:cNvPr>
+          <p:cNvSpPr>
+            <a:spLocks xmlns:a="http://schemas.openxmlformats.org/drawingml/2006/main" noGrp="1"/>
+          </p:cNvSpPr>
+          <p:nvPr/>
+        </p:nvSpPr>
+        <p:spPr>
+          <a:xfrm xmlns:a="http://schemas.openxmlformats.org/drawingml/2006/main">
+            <a:off x="1143000" y="4248150"/>
+            <a:ext cx="1905000" cy="190500"/>
+          </a:xfrm>
+          <a:prstGeom xmlns:a="http://schemas.openxmlformats.org/drawingml/2006/main" prst="rect">
+            <a:avLst/>
+          </a:prstGeom>
+          <a:noFill xmlns:a="http://schemas.openxmlformats.org/drawingml/2006/main"/>
+          <a:ln xmlns:a="http://schemas.openxmlformats.org/drawingml/2006/main" w="0">
+            <a:noFill/>
+          </a:ln>
+        </p:spPr>
+        <p:txBody>
+          <a:bodyPr xmlns:a="http://schemas.openxmlformats.org/drawingml/2006/main" wrap="square" lIns="38100" tIns="38100" rIns="38100" bIns="38100">
+            <a:noAutofit/>
+          </a:bodyPr>
+          <a:lstStyle xmlns:a="http://schemas.openxmlformats.org/drawingml/2006/main"/>
+          <a:p xmlns:a="http://schemas.openxmlformats.org/drawingml/2006/main">
+            <a:r>
+              <a:rPr sz="975" b="1">
+                <a:solidFill>
+                  <a:srgbClr val="5D605E"/>
+                </a:solidFill>
+                <a:latin typeface="Inter"/>
+                <a:ea typeface="Inter"/>
+                <a:cs typeface="Inter"/>
+              </a:rPr>
+              <a:t>Today</a:t>
+            </a:r>
+          </a:p>
+        </p:txBody>
+      </p:sp>
+      <p:sp>
+        <p:nvSpPr>
+          <p:cNvPr id="26" name="">
+            <a:extLst xmlns:a="http://schemas.openxmlformats.org/drawingml/2006/main">
+              <a:ext uri="{FF2B5EF4-FFF2-40B4-BE49-F238E27FC236}">
+                <a16:creationId xmlns:a16="http://schemas.microsoft.com/office/drawing/2014/main" id="{BB7F0C46-B44B-4FE1-938D-FB455BCCA4A3}"/>
+              </a:ext>
+            </a:extLst>
+          </p:cNvPr>
+          <p:cNvSpPr>
+            <a:spLocks xmlns:a="http://schemas.openxmlformats.org/drawingml/2006/main" noGrp="1"/>
+          </p:cNvSpPr>
+          <p:nvPr/>
+        </p:nvSpPr>
+        <p:spPr>
+          <a:xfrm xmlns:a="http://schemas.openxmlformats.org/drawingml/2006/main">
+            <a:off x="1143000" y="4495800"/>
+            <a:ext cx="4248150" cy="571500"/>
+          </a:xfrm>
+          <a:prstGeom xmlns:a="http://schemas.openxmlformats.org/drawingml/2006/main" prst="rect">
+            <a:avLst/>
+          </a:prstGeom>
+          <a:noFill xmlns:a="http://schemas.openxmlformats.org/drawingml/2006/main"/>
+          <a:ln xmlns:a="http://schemas.openxmlformats.org/drawingml/2006/main" w="0">
+            <a:noFill/>
+          </a:ln>
+        </p:spPr>
+        <p:txBody>
+          <a:bodyPr xmlns:a="http://schemas.openxmlformats.org/drawingml/2006/main" wrap="square" lIns="38100" tIns="38100" rIns="38100" bIns="38100">
+            <a:noAutofit/>
+          </a:bodyPr>
+          <a:lstStyle xmlns:a="http://schemas.openxmlformats.org/drawingml/2006/main"/>
+          <a:p xmlns:a="http://schemas.openxmlformats.org/drawingml/2006/main">
+            <a:r>
+              <a:rPr sz="1425">
+                <a:solidFill>
+                  <a:srgbClr val="181818"/>
+                </a:solidFill>
+                <a:latin typeface="Inter"/>
+                <a:ea typeface="Inter"/>
+                <a:cs typeface="Inter"/>
+              </a:rPr>
+              <a:t>Managed agents fill the stance contract for each person.</a:t>
+            </a:r>
+          </a:p>
+        </p:txBody>
+      </p:sp>
+      <p:sp>
+        <p:nvSpPr>
+          <p:cNvPr id="27" name="">
+            <a:extLst xmlns:a="http://schemas.openxmlformats.org/drawingml/2006/main">
+              <a:ext uri="{FF2B5EF4-FFF2-40B4-BE49-F238E27FC236}">
+                <a16:creationId xmlns:a16="http://schemas.microsoft.com/office/drawing/2014/main" id="{BA3550BF-C579-4FE9-89B2-CC2B3603005A}"/>
+              </a:ext>
+            </a:extLst>
+          </p:cNvPr>
+          <p:cNvSpPr>
+            <a:spLocks xmlns:a="http://schemas.openxmlformats.org/drawingml/2006/main" noGrp="1"/>
+          </p:cNvSpPr>
+          <p:nvPr/>
+        </p:nvSpPr>
+        <p:spPr>
+          <a:xfrm xmlns:a="http://schemas.openxmlformats.org/drawingml/2006/main">
+            <a:off x="5829300" y="4038600"/>
+            <a:ext cx="4762500" cy="1276350"/>
+          </a:xfrm>
+          <a:prstGeom xmlns:a="http://schemas.openxmlformats.org/drawingml/2006/main" prst="roundRect">
+            <a:avLst>
+              <a:gd name="adj" fmla="val 5970"/>
+            </a:avLst>
+          </a:prstGeom>
+          <a:solidFill xmlns:a="http://schemas.openxmlformats.org/drawingml/2006/main">
+            <a:srgbClr val="F9F9F9"/>
+          </a:solidFill>
+          <a:ln xmlns:a="http://schemas.openxmlformats.org/drawingml/2006/main" w="9525">
+            <a:solidFill>
+              <a:srgbClr val="282828"/>
+            </a:solidFill>
+          </a:ln>
+        </p:spPr>
+      </p:sp>
+      <p:sp>
+        <p:nvSpPr>
+          <p:cNvPr id="28" name="">
+            <a:extLst xmlns:a="http://schemas.openxmlformats.org/drawingml/2006/main">
+              <a:ext uri="{FF2B5EF4-FFF2-40B4-BE49-F238E27FC236}">
+                <a16:creationId xmlns:a16="http://schemas.microsoft.com/office/drawing/2014/main" id="{8E5CED1F-F673-4F29-9C39-1DEFF06EF2F8}"/>
+              </a:ext>
+            </a:extLst>
+          </p:cNvPr>
+          <p:cNvSpPr>
+            <a:spLocks xmlns:a="http://schemas.openxmlformats.org/drawingml/2006/main" noGrp="1"/>
+          </p:cNvSpPr>
+          <p:nvPr/>
+        </p:nvSpPr>
+        <p:spPr>
+          <a:xfrm xmlns:a="http://schemas.openxmlformats.org/drawingml/2006/main">
+            <a:off x="6076950" y="4210050"/>
+            <a:ext cx="1066800" cy="323850"/>
+          </a:xfrm>
+          <a:prstGeom xmlns:a="http://schemas.openxmlformats.org/drawingml/2006/main" prst="roundRect">
+            <a:avLst>
+              <a:gd name="adj" fmla="val 50000"/>
+            </a:avLst>
+          </a:prstGeom>
+          <a:solidFill xmlns:a="http://schemas.openxmlformats.org/drawingml/2006/main">
+            <a:srgbClr val="DDEBFF"/>
+          </a:solidFill>
+          <a:ln xmlns:a="http://schemas.openxmlformats.org/drawingml/2006/main" w="9525">
+            <a:solidFill>
+              <a:srgbClr val="2636B8"/>
+            </a:solidFill>
+          </a:ln>
+        </p:spPr>
+      </p:sp>
+      <p:sp>
+        <p:nvSpPr>
+          <p:cNvPr id="29" name="">
+            <a:extLst xmlns:a="http://schemas.openxmlformats.org/drawingml/2006/main">
+              <a:ext uri="{FF2B5EF4-FFF2-40B4-BE49-F238E27FC236}">
+                <a16:creationId xmlns:a16="http://schemas.microsoft.com/office/drawing/2014/main" id="{D6C22963-3819-4CA6-B13B-22F4AA713E78}"/>
+              </a:ext>
+            </a:extLst>
+          </p:cNvPr>
+          <p:cNvSpPr>
+            <a:spLocks xmlns:a="http://schemas.openxmlformats.org/drawingml/2006/main" noGrp="1"/>
+          </p:cNvSpPr>
+          <p:nvPr/>
+        </p:nvSpPr>
+        <p:spPr>
+          <a:xfrm xmlns:a="http://schemas.openxmlformats.org/drawingml/2006/main">
+            <a:off x="6191250" y="4276725"/>
+            <a:ext cx="838200" cy="171450"/>
+          </a:xfrm>
+          <a:prstGeom xmlns:a="http://schemas.openxmlformats.org/drawingml/2006/main" prst="rect">
+            <a:avLst/>
+          </a:prstGeom>
+          <a:noFill xmlns:a="http://schemas.openxmlformats.org/drawingml/2006/main"/>
+          <a:ln xmlns:a="http://schemas.openxmlformats.org/drawingml/2006/main" w="0">
+            <a:noFill/>
+          </a:ln>
+        </p:spPr>
+        <p:txBody>
+          <a:bodyPr xmlns:a="http://schemas.openxmlformats.org/drawingml/2006/main" wrap="square" lIns="0" tIns="0" rIns="0" bIns="0">
+            <a:noAutofit/>
+          </a:bodyPr>
+          <a:lstStyle xmlns:a="http://schemas.openxmlformats.org/drawingml/2006/main"/>
+          <a:p xmlns:a="http://schemas.openxmlformats.org/drawingml/2006/main">
+            <a:pPr algn="ctr">
+              <a:defRPr sz="900" b="1">
+                <a:solidFill>
+                  <a:srgbClr val="2636B8"/>
+                </a:solidFill>
+                <a:latin typeface="Inter"/>
+                <a:ea typeface="Inter"/>
+                <a:cs typeface="Inter"/>
+              </a:defRPr>
+            </a:pPr>
+            <a:r>
+              <a:rPr sz="900" b="1">
+                <a:solidFill>
+                  <a:srgbClr val="2636B8"/>
+                </a:solidFill>
+                <a:latin typeface="Inter"/>
+                <a:ea typeface="Inter"/>
+                <a:cs typeface="Inter"/>
+              </a:rPr>
+              <a:t>ROADMAP</a:t>
+            </a:r>
+          </a:p>
+        </p:txBody>
+      </p:sp>
+      <p:sp>
+        <p:nvSpPr>
+          <p:cNvPr id="30" name="">
+            <a:extLst xmlns:a="http://schemas.openxmlformats.org/drawingml/2006/main">
+              <a:ext uri="{FF2B5EF4-FFF2-40B4-BE49-F238E27FC236}">
+                <a16:creationId xmlns:a16="http://schemas.microsoft.com/office/drawing/2014/main" id="{F34F5D75-676F-4B6C-A5EA-65AD677A2906}"/>
+              </a:ext>
+            </a:extLst>
+          </p:cNvPr>
+          <p:cNvSpPr>
+            <a:spLocks xmlns:a="http://schemas.openxmlformats.org/drawingml/2006/main" noGrp="1"/>
+          </p:cNvSpPr>
+          <p:nvPr/>
+        </p:nvSpPr>
+        <p:spPr>
+          <a:xfrm xmlns:a="http://schemas.openxmlformats.org/drawingml/2006/main">
+            <a:off x="7258050" y="4248150"/>
+            <a:ext cx="3143250" cy="209550"/>
+          </a:xfrm>
+          <a:prstGeom xmlns:a="http://schemas.openxmlformats.org/drawingml/2006/main" prst="rect">
+            <a:avLst/>
+          </a:prstGeom>
+          <a:noFill xmlns:a="http://schemas.openxmlformats.org/drawingml/2006/main"/>
+          <a:ln xmlns:a="http://schemas.openxmlformats.org/drawingml/2006/main" w="0">
+            <a:noFill/>
+          </a:ln>
+        </p:spPr>
+        <p:txBody>
+          <a:bodyPr xmlns:a="http://schemas.openxmlformats.org/drawingml/2006/main" wrap="square" lIns="38100" tIns="38100" rIns="38100" bIns="38100">
+            <a:noAutofit/>
+          </a:bodyPr>
+          <a:lstStyle xmlns:a="http://schemas.openxmlformats.org/drawingml/2006/main"/>
+          <a:p xmlns:a="http://schemas.openxmlformats.org/drawingml/2006/main">
+            <a:r>
+              <a:rPr sz="1125" b="1">
+                <a:solidFill>
+                  <a:srgbClr val="282828"/>
+                </a:solidFill>
+                <a:latin typeface="Inter"/>
+                <a:ea typeface="Inter"/>
+                <a:cs typeface="Inter"/>
+              </a:rPr>
+              <a:t>Bring your own agent</a:t>
+            </a:r>
+          </a:p>
+        </p:txBody>
+      </p:sp>
+      <p:sp>
+        <p:nvSpPr>
+          <p:cNvPr id="31" name="">
+            <a:extLst xmlns:a="http://schemas.openxmlformats.org/drawingml/2006/main">
+              <a:ext uri="{FF2B5EF4-FFF2-40B4-BE49-F238E27FC236}">
+                <a16:creationId xmlns:a16="http://schemas.microsoft.com/office/drawing/2014/main" id="{B5E46720-4273-4B67-967B-7F20BEAFC060}"/>
+              </a:ext>
+            </a:extLst>
+          </p:cNvPr>
+          <p:cNvSpPr>
+            <a:spLocks xmlns:a="http://schemas.openxmlformats.org/drawingml/2006/main" noGrp="1"/>
+          </p:cNvSpPr>
+          <p:nvPr/>
+        </p:nvSpPr>
+        <p:spPr>
+          <a:xfrm xmlns:a="http://schemas.openxmlformats.org/drawingml/2006/main">
+            <a:off x="6076950" y="4591050"/>
+            <a:ext cx="4305300" cy="666750"/>
+          </a:xfrm>
+          <a:prstGeom xmlns:a="http://schemas.openxmlformats.org/drawingml/2006/main" prst="rect">
+            <a:avLst/>
+          </a:prstGeom>
+          <a:noFill xmlns:a="http://schemas.openxmlformats.org/drawingml/2006/main"/>
+          <a:ln xmlns:a="http://schemas.openxmlformats.org/drawingml/2006/main" w="0">
+            <a:noFill/>
+          </a:ln>
+        </p:spPr>
+        <p:txBody>
+          <a:bodyPr xmlns:a="http://schemas.openxmlformats.org/drawingml/2006/main" wrap="square" lIns="38100" tIns="38100" rIns="38100" bIns="38100">
+            <a:noAutofit/>
+          </a:bodyPr>
+          <a:lstStyle xmlns:a="http://schemas.openxmlformats.org/drawingml/2006/main"/>
+          <a:p xmlns:a="http://schemas.openxmlformats.org/drawingml/2006/main">
+            <a:r>
+              <a:rPr sz="1275">
+                <a:solidFill>
+                  <a:srgbClr val="181818"/>
+                </a:solidFill>
+                <a:latin typeface="Inter"/>
+                <a:ea typeface="Inter"/>
+                <a:cs typeface="Inter"/>
+              </a:rPr>
+              <a:t>Point your own agent at Mochi. It speaks the stance contract, keeps your context private, and emits only a structured stance.</a:t>
+            </a:r>
+          </a:p>
+        </p:txBody>
+      </p:sp>
+      <p:sp>
+        <p:nvSpPr>
+          <p:cNvPr id="32" name="">
+            <a:extLst xmlns:a="http://schemas.openxmlformats.org/drawingml/2006/main">
+              <a:ext uri="{FF2B5EF4-FFF2-40B4-BE49-F238E27FC236}">
+                <a16:creationId xmlns:a16="http://schemas.microsoft.com/office/drawing/2014/main" id="{4FF45627-FE4C-4E74-9A63-F9659F7D8A97}"/>
+              </a:ext>
+            </a:extLst>
+          </p:cNvPr>
+          <p:cNvSpPr>
+            <a:spLocks xmlns:a="http://schemas.openxmlformats.org/drawingml/2006/main" noGrp="1"/>
+          </p:cNvSpPr>
+          <p:nvPr/>
+        </p:nvSpPr>
+        <p:spPr>
+          <a:xfrm xmlns:a="http://schemas.openxmlformats.org/drawingml/2006/main">
+            <a:off x="895350" y="5562600"/>
+            <a:ext cx="9696450" cy="533400"/>
+          </a:xfrm>
+          <a:prstGeom xmlns:a="http://schemas.openxmlformats.org/drawingml/2006/main" prst="roundRect">
+            <a:avLst>
+              <a:gd name="adj" fmla="val 14286"/>
+            </a:avLst>
+          </a:prstGeom>
+          <a:solidFill xmlns:a="http://schemas.openxmlformats.org/drawingml/2006/main">
+            <a:srgbClr val="17191A"/>
+          </a:solidFill>
+          <a:ln xmlns:a="http://schemas.openxmlformats.org/drawingml/2006/main" w="0">
+            <a:noFill/>
+          </a:ln>
+        </p:spPr>
+      </p:sp>
+      <p:sp>
+        <p:nvSpPr>
+          <p:cNvPr id="33" name="">
+            <a:extLst xmlns:a="http://schemas.openxmlformats.org/drawingml/2006/main">
+              <a:ext uri="{FF2B5EF4-FFF2-40B4-BE49-F238E27FC236}">
+                <a16:creationId xmlns:a16="http://schemas.microsoft.com/office/drawing/2014/main" id="{7BC7F6E4-74FA-4B93-AB7D-3FF1FCCC5318}"/>
+              </a:ext>
+            </a:extLst>
+          </p:cNvPr>
+          <p:cNvSpPr>
+            <a:spLocks xmlns:a="http://schemas.openxmlformats.org/drawingml/2006/main" noGrp="1"/>
+          </p:cNvSpPr>
+          <p:nvPr/>
+        </p:nvSpPr>
+        <p:spPr>
+          <a:xfrm xmlns:a="http://schemas.openxmlformats.org/drawingml/2006/main">
+            <a:off x="1162050" y="5734050"/>
+            <a:ext cx="1428750" cy="171450"/>
+          </a:xfrm>
+          <a:prstGeom xmlns:a="http://schemas.openxmlformats.org/drawingml/2006/main" prst="rect">
+            <a:avLst/>
+          </a:prstGeom>
+          <a:noFill xmlns:a="http://schemas.openxmlformats.org/drawingml/2006/main"/>
+          <a:ln xmlns:a="http://schemas.openxmlformats.org/drawingml/2006/main" w="0">
+            <a:noFill/>
+          </a:ln>
+        </p:spPr>
+        <p:txBody>
+          <a:bodyPr xmlns:a="http://schemas.openxmlformats.org/drawingml/2006/main" wrap="square" lIns="38100" tIns="38100" rIns="38100" bIns="38100">
+            <a:noAutofit/>
+          </a:bodyPr>
+          <a:lstStyle xmlns:a="http://schemas.openxmlformats.org/drawingml/2006/main"/>
+          <a:p xmlns:a="http://schemas.openxmlformats.org/drawingml/2006/main">
+            <a:r>
+              <a:rPr sz="975" b="1">
+                <a:solidFill>
+                  <a:srgbClr val="BFC5C9"/>
+                </a:solidFill>
+                <a:latin typeface="Inter"/>
+                <a:ea typeface="Inter"/>
+                <a:cs typeface="Inter"/>
+              </a:rPr>
+              <a:t>The protocol</a:t>
+            </a:r>
+          </a:p>
+        </p:txBody>
+      </p:sp>
+      <p:sp>
+        <p:nvSpPr>
+          <p:cNvPr id="34" name="">
+            <a:extLst xmlns:a="http://schemas.openxmlformats.org/drawingml/2006/main">
+              <a:ext uri="{FF2B5EF4-FFF2-40B4-BE49-F238E27FC236}">
+                <a16:creationId xmlns:a16="http://schemas.microsoft.com/office/drawing/2014/main" id="{6634E353-F48D-4E29-BE3A-F960E95724E9}"/>
+              </a:ext>
+            </a:extLst>
+          </p:cNvPr>
+          <p:cNvSpPr>
+            <a:spLocks xmlns:a="http://schemas.openxmlformats.org/drawingml/2006/main" noGrp="1"/>
+          </p:cNvSpPr>
+          <p:nvPr/>
+        </p:nvSpPr>
+        <p:spPr>
+          <a:xfrm xmlns:a="http://schemas.openxmlformats.org/drawingml/2006/main">
+            <a:off x="2743200" y="5715000"/>
+            <a:ext cx="7620000" cy="228600"/>
+          </a:xfrm>
+          <a:prstGeom xmlns:a="http://schemas.openxmlformats.org/drawingml/2006/main" prst="rect">
+            <a:avLst/>
+          </a:prstGeom>
+          <a:noFill xmlns:a="http://schemas.openxmlformats.org/drawingml/2006/main"/>
+          <a:ln xmlns:a="http://schemas.openxmlformats.org/drawingml/2006/main" w="0">
+            <a:noFill/>
+          </a:ln>
+        </p:spPr>
+        <p:txBody>
+          <a:bodyPr xmlns:a="http://schemas.openxmlformats.org/drawingml/2006/main" wrap="square" lIns="38100" tIns="38100" rIns="38100" bIns="38100">
+            <a:noAutofit/>
+          </a:bodyPr>
+          <a:lstStyle xmlns:a="http://schemas.openxmlformats.org/drawingml/2006/main"/>
+          <a:p xmlns:a="http://schemas.openxmlformats.org/drawingml/2006/main">
+            <a:r>
+              <a:rPr sz="1500" b="1">
+                <a:solidFill>
+                  <a:srgbClr val="FFFFFF"/>
+                </a:solidFill>
+                <a:latin typeface="Inter"/>
+                <a:ea typeface="Inter"/>
+                <a:cs typeface="Inter"/>
+              </a:rPr>
+              <a:t>Mochi is the protocol for pre-meeting agent reasoning, not the silo.</a:t>
+            </a:r>
+          </a:p>
+        </p:txBody>
+      </p:sp>
+    </p:spTree>
+    <p:extLst>
+      <p:ext uri="{BB962C8B-B14F-4D97-AF65-F5344CB8AC3E}">
+        <p14:creationId xmlns:p14="http://schemas.microsoft.com/office/powerpoint/2010/main" val="1762086898"/>
+      </p:ext>
+    </p:extLst>
+  </p:cSld>
+</p:sld>
+</file>
+
+<file path=ppt/slides/slide9.xml><?xml version="1.0" encoding="utf-8"?>
+<p:sld xmlns:p="http://schemas.openxmlformats.org/presentationml/2006/main">
+  <p:cSld>
+    <p:bg>
+      <p:bgPr>
+        <a:solidFill xmlns:a="http://schemas.openxmlformats.org/drawingml/2006/main">
+          <a:srgbClr val="FFFFFF"/>
+        </a:solidFill>
+      </p:bgPr>
+    </p:bg>
+    <p:spTree>
+      <p:nvGrpSpPr>
+        <p:cNvPr id="1" name=""/>
+        <p:cNvGrpSpPr/>
+        <p:nvPr/>
+      </p:nvGrpSpPr>
+      <p:grpSpPr>
+        <a:xfrm xmlns:a="http://schemas.openxmlformats.org/drawingml/2006/main"/>
+      </p:grpSpPr>
+      <p:pic>
+        <p:nvPicPr>
+          <p:cNvPr id="1" name=""/>
+          <p:cNvPicPr>
+            <a:picLocks xmlns:a="http://schemas.openxmlformats.org/drawingml/2006/main" noChangeAspect="1"/>
+          </p:cNvPicPr>
+          <p:nvPr/>
+        </p:nvPicPr>
+        <p:blipFill>
+          <a:blip xmlns:r="http://schemas.openxmlformats.org/officeDocument/2006/relationships" xmlns:a="http://schemas.openxmlformats.org/drawingml/2006/main" r:embed="R3f6955c68f54461c"/>
+          <a:srcRect xmlns:a="http://schemas.openxmlformats.org/drawingml/2006/main" l="0" t="0" r="0" b="0"/>
+          <a:stretch xmlns:a="http://schemas.openxmlformats.org/drawingml/2006/main">
+            <a:fillRect l="0" t="0" r="0" b="0"/>
+          </a:stretch>
+        </p:blipFill>
+        <p:spPr>
+          <a:xfrm xmlns:a="http://schemas.openxmlformats.org/drawingml/2006/main">
+            <a:off x="0" y="0"/>
+            <a:ext cx="12192000" cy="6858000"/>
+          </a:xfrm>
+          <a:prstGeom xmlns:a="http://schemas.openxmlformats.org/drawingml/2006/main" prst="rect">
+            <a:avLst/>
+          </a:prstGeom>
+        </p:spPr>
+      </p:pic>
+      <p:sp>
+        <p:nvSpPr>
+          <p:cNvPr id="2" name="">
+            <a:extLst xmlns:a="http://schemas.openxmlformats.org/drawingml/2006/main">
+              <a:ext uri="{FF2B5EF4-FFF2-40B4-BE49-F238E27FC236}">
+                <a16:creationId xmlns:a16="http://schemas.microsoft.com/office/drawing/2014/main" id="{46F50D42-9208-45CC-A4F9-7A41F786C0C2}"/>
+              </a:ext>
+            </a:extLst>
+          </p:cNvPr>
+          <p:cNvSpPr>
+            <a:spLocks xmlns:a="http://schemas.openxmlformats.org/drawingml/2006/main" noGrp="1"/>
+          </p:cNvSpPr>
+          <p:nvPr/>
+        </p:nvSpPr>
+        <p:spPr>
+          <a:xfrm xmlns:a="http://schemas.openxmlformats.org/drawingml/2006/main">
+            <a:off x="685800" y="419100"/>
+            <a:ext cx="2857500" cy="228600"/>
+          </a:xfrm>
+          <a:prstGeom xmlns:a="http://schemas.openxmlformats.org/drawingml/2006/main" prst="rect">
+            <a:avLst/>
+          </a:prstGeom>
+          <a:noFill xmlns:a="http://schemas.openxmlformats.org/drawingml/2006/main"/>
+          <a:ln xmlns:a="http://schemas.openxmlformats.org/drawingml/2006/main" w="0">
+            <a:noFill/>
+          </a:ln>
+        </p:spPr>
+        <p:txBody>
+          <a:bodyPr xmlns:a="http://schemas.openxmlformats.org/drawingml/2006/main" wrap="square" lIns="0" tIns="19050" rIns="0" bIns="0">
+            <a:noAutofit/>
+          </a:bodyPr>
+          <a:lstStyle xmlns:a="http://schemas.openxmlformats.org/drawingml/2006/main"/>
+          <a:p xmlns:a="http://schemas.openxmlformats.org/drawingml/2006/main">
+            <a:r>
+              <a:rPr sz="975" b="1">
+                <a:solidFill>
+                  <a:srgbClr val="5D605E"/>
+                </a:solidFill>
+                <a:latin typeface="Inter"/>
+                <a:ea typeface="Inter"/>
+                <a:cs typeface="Inter"/>
+              </a:rPr>
+              <a:t>CLOSE</a:t>
+            </a:r>
+          </a:p>
+        </p:txBody>
+      </p:sp>
+      <p:sp>
+        <p:nvSpPr>
+          <p:cNvPr id="3" name="">
+            <a:extLst xmlns:a="http://schemas.openxmlformats.org/drawingml/2006/main">
+              <a:ext uri="{FF2B5EF4-FFF2-40B4-BE49-F238E27FC236}">
+                <a16:creationId xmlns:a16="http://schemas.microsoft.com/office/drawing/2014/main" id="{0A0DB2EB-9286-4651-A000-9FB2C36FCB14}"/>
+              </a:ext>
+            </a:extLst>
+          </p:cNvPr>
+          <p:cNvSpPr>
+            <a:spLocks xmlns:a="http://schemas.openxmlformats.org/drawingml/2006/main" noGrp="1"/>
+          </p:cNvSpPr>
+          <p:nvPr/>
+        </p:nvSpPr>
+        <p:spPr>
+          <a:xfrm xmlns:a="http://schemas.openxmlformats.org/drawingml/2006/main">
+            <a:off x="666750" y="723900"/>
+            <a:ext cx="8763000" cy="1066800"/>
+          </a:xfrm>
+          <a:prstGeom xmlns:a="http://schemas.openxmlformats.org/drawingml/2006/main" prst="rect">
+            <a:avLst/>
+          </a:prstGeom>
+          <a:noFill xmlns:a="http://schemas.openxmlformats.org/drawingml/2006/main"/>
+          <a:ln xmlns:a="http://schemas.openxmlformats.org/drawingml/2006/main" w="0">
+            <a:noFill/>
+          </a:ln>
+        </p:spPr>
+        <p:txBody>
+          <a:bodyPr xmlns:a="http://schemas.openxmlformats.org/drawingml/2006/main" wrap="square" lIns="0" tIns="0" rIns="0" bIns="0">
+            <a:noAutofit/>
+          </a:bodyPr>
+          <a:lstStyle xmlns:a="http://schemas.openxmlformats.org/drawingml/2006/main"/>
+          <a:p xmlns:a="http://schemas.openxmlformats.org/drawingml/2006/main">
+            <a:r>
+              <a:rPr sz="3000">
+                <a:solidFill>
+                  <a:srgbClr val="181818"/>
+                </a:solidFill>
+                <a:latin typeface="Inter"/>
+                <a:ea typeface="Inter"/>
+                <a:cs typeface="Inter"/>
+              </a:rPr>
+              <a:t>Mochi catches fake agreement</a:t>
+            </a:r>
+          </a:p>
+          <a:p xmlns:a="http://schemas.openxmlformats.org/drawingml/2006/main">
+            <a:r>
+              <a:rPr sz="3000">
+                <a:solidFill>
+                  <a:srgbClr val="181818"/>
+                </a:solidFill>
+                <a:latin typeface="Inter"/>
+                <a:ea typeface="Inter"/>
+                <a:cs typeface="Inter"/>
+              </a:rPr>
+              <a:t>before the hour is gone.</a:t>
+            </a:r>
+          </a:p>
+        </p:txBody>
+      </p:sp>
+      <p:sp>
+        <p:nvSpPr>
+          <p:cNvPr id="4" name="">
+            <a:extLst xmlns:a="http://schemas.openxmlformats.org/drawingml/2006/main">
+              <a:ext uri="{FF2B5EF4-FFF2-40B4-BE49-F238E27FC236}">
+                <a16:creationId xmlns:a16="http://schemas.microsoft.com/office/drawing/2014/main" id="{423A5FB3-B336-4A3B-9B62-12D8F9F610F8}"/>
+              </a:ext>
+            </a:extLst>
+          </p:cNvPr>
+          <p:cNvSpPr>
+            <a:spLocks xmlns:a="http://schemas.openxmlformats.org/drawingml/2006/main" noGrp="1"/>
+          </p:cNvSpPr>
+          <p:nvPr/>
+        </p:nvSpPr>
+        <p:spPr>
+          <a:xfrm xmlns:a="http://schemas.openxmlformats.org/drawingml/2006/main">
+            <a:off x="685800" y="6515100"/>
+            <a:ext cx="7239000" cy="171450"/>
+          </a:xfrm>
+          <a:prstGeom xmlns:a="http://schemas.openxmlformats.org/drawingml/2006/main" prst="rect">
+            <a:avLst/>
+          </a:prstGeom>
+          <a:noFill xmlns:a="http://schemas.openxmlformats.org/drawingml/2006/main"/>
+          <a:ln xmlns:a="http://schemas.openxmlformats.org/drawingml/2006/main" w="0">
+            <a:noFill/>
+          </a:ln>
+        </p:spPr>
+        <p:txBody>
+          <a:bodyPr xmlns:a="http://schemas.openxmlformats.org/drawingml/2006/main" wrap="square" lIns="0" tIns="0" rIns="0" bIns="0">
+            <a:noAutofit/>
+          </a:bodyPr>
+          <a:lstStyle xmlns:a="http://schemas.openxmlformats.org/drawingml/2006/main"/>
+          <a:p xmlns:a="http://schemas.openxmlformats.org/drawingml/2006/main">
+            <a:r>
+              <a:rPr sz="750">
+                <a:solidFill>
+                  <a:srgbClr val="5D605E"/>
+                </a:solidFill>
+                <a:latin typeface="Inter"/>
+                <a:ea typeface="Inter"/>
+                <a:cs typeface="Inter"/>
+              </a:rPr>
+              <a:t>Sources: docs/pitch-script.md, docs/submission-checklist.md</a:t>
+            </a:r>
+          </a:p>
+        </p:txBody>
+      </p:sp>
+      <p:sp>
+        <p:nvSpPr>
+          <p:cNvPr id="5" name="">
+            <a:extLst xmlns:a="http://schemas.openxmlformats.org/drawingml/2006/main">
+              <a:ext uri="{FF2B5EF4-FFF2-40B4-BE49-F238E27FC236}">
+                <a16:creationId xmlns:a16="http://schemas.microsoft.com/office/drawing/2014/main" id="{B2D175D1-33EA-4434-AFB3-7FF4EE4C81E6}"/>
+              </a:ext>
+            </a:extLst>
+          </p:cNvPr>
+          <p:cNvSpPr>
+            <a:spLocks xmlns:a="http://schemas.openxmlformats.org/drawingml/2006/main" noGrp="1"/>
+          </p:cNvSpPr>
+          <p:nvPr/>
+        </p:nvSpPr>
+        <p:spPr>
+          <a:xfrm xmlns:a="http://schemas.openxmlformats.org/drawingml/2006/main">
+            <a:off x="11239500" y="6515100"/>
+            <a:ext cx="381000" cy="171450"/>
+          </a:xfrm>
+          <a:prstGeom xmlns:a="http://schemas.openxmlformats.org/drawingml/2006/main" prst="rect">
+            <a:avLst/>
+          </a:prstGeom>
+          <a:noFill xmlns:a="http://schemas.openxmlformats.org/drawingml/2006/main"/>
+          <a:ln xmlns:a="http://schemas.openxmlformats.org/drawingml/2006/main" w="0">
+            <a:noFill/>
+          </a:ln>
+        </p:spPr>
+        <p:txBody>
+          <a:bodyPr xmlns:a="http://schemas.openxmlformats.org/drawingml/2006/main" wrap="square" lIns="0" tIns="0" rIns="0" bIns="0">
+            <a:noAutofit/>
+          </a:bodyPr>
+          <a:lstStyle xmlns:a="http://schemas.openxmlformats.org/drawingml/2006/main"/>
+          <a:p xmlns:a="http://schemas.openxmlformats.org/drawingml/2006/main">
+            <a:pPr algn="r">
+              <a:defRPr sz="750">
+                <a:solidFill>
+                  <a:srgbClr val="5D605E"/>
+                </a:solidFill>
+                <a:latin typeface="Inter"/>
+                <a:ea typeface="Inter"/>
+                <a:cs typeface="Inter"/>
+              </a:defRPr>
+            </a:pPr>
+            <a:r>
+              <a:rPr sz="750">
+                <a:solidFill>
+                  <a:srgbClr val="5D605E"/>
+                </a:solidFill>
+                <a:latin typeface="Inter"/>
+                <a:ea typeface="Inter"/>
+                <a:cs typeface="Inter"/>
+              </a:rPr>
+              <a:t>09</a:t>
+            </a:r>
+          </a:p>
+        </p:txBody>
+      </p:sp>
+      <p:sp>
+        <p:nvSpPr>
+          <p:cNvPr id="6" name="">
+            <a:extLst xmlns:a="http://schemas.openxmlformats.org/drawingml/2006/main">
+              <a:ext uri="{FF2B5EF4-FFF2-40B4-BE49-F238E27FC236}">
+                <a16:creationId xmlns:a16="http://schemas.microsoft.com/office/drawing/2014/main" id="{A2DA483C-9139-4BBE-80D3-3B04ACAEED1E}"/>
+              </a:ext>
+            </a:extLst>
+          </p:cNvPr>
+          <p:cNvSpPr>
+            <a:spLocks xmlns:a="http://schemas.openxmlformats.org/drawingml/2006/main" noGrp="1"/>
+          </p:cNvSpPr>
+          <p:nvPr/>
+        </p:nvSpPr>
+        <p:spPr>
+          <a:xfrm xmlns:a="http://schemas.openxmlformats.org/drawingml/2006/main">
+            <a:off x="876300" y="2038350"/>
+            <a:ext cx="5905500" cy="1257300"/>
+          </a:xfrm>
+          <a:prstGeom xmlns:a="http://schemas.openxmlformats.org/drawingml/2006/main" prst="rect">
+            <a:avLst/>
+          </a:prstGeom>
+          <a:noFill xmlns:a="http://schemas.openxmlformats.org/drawingml/2006/main"/>
+          <a:ln xmlns:a="http://schemas.openxmlformats.org/drawingml/2006/main" w="0">
+            <a:noFill/>
+          </a:ln>
+        </p:spPr>
+        <p:txBody>
+          <a:bodyPr xmlns:a="http://schemas.openxmlformats.org/drawingml/2006/main" wrap="square" lIns="38100" tIns="38100" rIns="38100" bIns="38100">
+            <a:noAutofit/>
+          </a:bodyPr>
+          <a:lstStyle xmlns:a="http://schemas.openxmlformats.org/drawingml/2006/main"/>
+          <a:p xmlns:a="http://schemas.openxmlformats.org/drawingml/2006/main">
+            <a:r>
+              <a:rPr sz="2700">
+                <a:solidFill>
+                  <a:srgbClr val="181818"/>
+                </a:solidFill>
+                <a:latin typeface="Inter"/>
+                <a:ea typeface="Inter"/>
+                <a:cs typeface="Inter"/>
+              </a:rPr>
+              <a:t>Not after-meeting summary.</a:t>
+            </a:r>
+          </a:p>
+          <a:p xmlns:a="http://schemas.openxmlformats.org/drawingml/2006/main">
+            <a:r>
+              <a:rPr sz="2700">
+                <a:solidFill>
+                  <a:srgbClr val="181818"/>
+                </a:solidFill>
+                <a:latin typeface="Inter"/>
+                <a:ea typeface="Inter"/>
+                <a:cs typeface="Inter"/>
+              </a:rPr>
+              <a:t>Before-meeting crux.</a:t>
+            </a:r>
+          </a:p>
+          <a:p xmlns:a="http://schemas.openxmlformats.org/drawingml/2006/main">
+            <a:r>
+              <a:rPr sz="2700">
+                <a:solidFill>
+                  <a:srgbClr val="181818"/>
+                </a:solidFill>
+                <a:latin typeface="Inter"/>
+                <a:ea typeface="Inter"/>
+                <a:cs typeface="Inter"/>
+              </a:rPr>
+              <a:t>Inside Slack.</a:t>
+            </a:r>
+          </a:p>
+        </p:txBody>
+      </p:sp>
+      <p:pic>
+        <p:nvPicPr>
+          <p:cNvPr id="7" name=""/>
+          <p:cNvPicPr>
+            <a:picLocks xmlns:a="http://schemas.openxmlformats.org/drawingml/2006/main" noChangeAspect="1"/>
+          </p:cNvPicPr>
+          <p:nvPr/>
+        </p:nvPicPr>
+        <p:blipFill>
+          <a:blip xmlns:r="http://schemas.openxmlformats.org/officeDocument/2006/relationships" xmlns:a="http://schemas.openxmlformats.org/drawingml/2006/main" r:embed="Rabd9879436b54ced"/>
+          <a:srcRect xmlns:a="http://schemas.openxmlformats.org/drawingml/2006/main" l="0" t="0" r="0" b="0"/>
+          <a:stretch xmlns:a="http://schemas.openxmlformats.org/drawingml/2006/main">
+            <a:fillRect l="0" t="0" r="0" b="0"/>
+          </a:stretch>
+        </p:blipFill>
+        <p:spPr>
+          <a:xfrm xmlns:a="http://schemas.openxmlformats.org/drawingml/2006/main">
+            <a:off x="7524750" y="2019300"/>
+            <a:ext cx="1676400" cy="1676400"/>
+          </a:xfrm>
+          <a:prstGeom xmlns:a="http://schemas.openxmlformats.org/drawingml/2006/main" prst="rect">
+            <a:avLst/>
+          </a:prstGeom>
+        </p:spPr>
+      </p:pic>
+      <p:sp>
+        <p:nvSpPr>
+          <p:cNvPr id="8" name="">
+            <a:extLst xmlns:a="http://schemas.openxmlformats.org/drawingml/2006/main">
+              <a:ext uri="{FF2B5EF4-FFF2-40B4-BE49-F238E27FC236}">
+                <a16:creationId xmlns:a16="http://schemas.microsoft.com/office/drawing/2014/main" id="{A32037B5-FD53-4297-B43F-A735DC0D103F}"/>
+              </a:ext>
+            </a:extLst>
+          </p:cNvPr>
+          <p:cNvSpPr>
+            <a:spLocks xmlns:a="http://schemas.openxmlformats.org/drawingml/2006/main" noGrp="1"/>
+          </p:cNvSpPr>
+          <p:nvPr/>
+        </p:nvSpPr>
+        <p:spPr>
+          <a:xfrm xmlns:a="http://schemas.openxmlformats.org/drawingml/2006/main">
+            <a:off x="876300" y="3695700"/>
+            <a:ext cx="6610350" cy="1295400"/>
+          </a:xfrm>
+          <a:prstGeom xmlns:a="http://schemas.openxmlformats.org/drawingml/2006/main" prst="roundRect">
+            <a:avLst>
+              <a:gd name="adj" fmla="val 5882"/>
+            </a:avLst>
+          </a:prstGeom>
+          <a:solidFill xmlns:a="http://schemas.openxmlformats.org/drawingml/2006/main">
+            <a:srgbClr val="FFFFFF"/>
+          </a:solidFill>
+          <a:ln xmlns:a="http://schemas.openxmlformats.org/drawingml/2006/main" w="9525">
+            <a:solidFill>
+              <a:srgbClr val="EDEDED"/>
+            </a:solidFill>
+          </a:ln>
+        </p:spPr>
+      </p:sp>
+      <p:sp>
+        <p:nvSpPr>
+          <p:cNvPr id="9" name="">
+            <a:extLst xmlns:a="http://schemas.openxmlformats.org/drawingml/2006/main">
+              <a:ext uri="{FF2B5EF4-FFF2-40B4-BE49-F238E27FC236}">
+                <a16:creationId xmlns:a16="http://schemas.microsoft.com/office/drawing/2014/main" id="{9AB051D5-B5F3-4399-9141-D5957F517897}"/>
               </a:ext>
             </a:extLst>
           </p:cNvPr>
@@ -9792,7 +11397,7 @@
           <p:cNvPr id="10" name="">
             <a:extLst xmlns:a="http://schemas.openxmlformats.org/drawingml/2006/main">
               <a:ext uri="{FF2B5EF4-FFF2-40B4-BE49-F238E27FC236}">
-                <a16:creationId xmlns:a16="http://schemas.microsoft.com/office/drawing/2014/main" id="{ACCB8818-7CE2-4357-814C-EA8A19E2E9CA}"/>
+                <a16:creationId xmlns:a16="http://schemas.microsoft.com/office/drawing/2014/main" id="{7809ED5E-3CED-4B33-9C86-F655EBABF625}"/>
               </a:ext>
             </a:extLst>
           </p:cNvPr>
@@ -9839,7 +11444,7 @@
           <p:cNvPr id="11" name="">
             <a:extLst xmlns:a="http://schemas.openxmlformats.org/drawingml/2006/main">
               <a:ext uri="{FF2B5EF4-FFF2-40B4-BE49-F238E27FC236}">
-                <a16:creationId xmlns:a16="http://schemas.microsoft.com/office/drawing/2014/main" id="{0031D4D6-F7C7-42C0-81B8-40CDE397A8F3}"/>
+                <a16:creationId xmlns:a16="http://schemas.microsoft.com/office/drawing/2014/main" id="{501DEE7A-16EC-4F0D-937E-0A0C34B63B69}"/>
               </a:ext>
             </a:extLst>
           </p:cNvPr>
@@ -9886,7 +11491,7 @@
           <p:cNvPr id="12" name="">
             <a:extLst xmlns:a="http://schemas.openxmlformats.org/drawingml/2006/main">
               <a:ext uri="{FF2B5EF4-FFF2-40B4-BE49-F238E27FC236}">
-                <a16:creationId xmlns:a16="http://schemas.microsoft.com/office/drawing/2014/main" id="{6E26F4AA-FC5C-4ADA-8C95-C01E7DD1D81A}"/>
+                <a16:creationId xmlns:a16="http://schemas.microsoft.com/office/drawing/2014/main" id="{4D4D37DE-FFFA-408C-A651-D447F5284439}"/>
               </a:ext>
             </a:extLst>
           </p:cNvPr>
@@ -9933,7 +11538,7 @@
           <p:cNvPr id="13" name="">
             <a:extLst xmlns:a="http://schemas.openxmlformats.org/drawingml/2006/main">
               <a:ext uri="{FF2B5EF4-FFF2-40B4-BE49-F238E27FC236}">
-                <a16:creationId xmlns:a16="http://schemas.microsoft.com/office/drawing/2014/main" id="{0A8B431D-D058-4B7F-AE0D-53E1C01E8320}"/>
+                <a16:creationId xmlns:a16="http://schemas.microsoft.com/office/drawing/2014/main" id="{311E81F7-3D85-4AFA-8AF3-8A215B445F61}"/>
               </a:ext>
             </a:extLst>
           </p:cNvPr>
@@ -9980,7 +11585,7 @@
           <p:cNvPr id="14" name="">
             <a:extLst xmlns:a="http://schemas.openxmlformats.org/drawingml/2006/main">
               <a:ext uri="{FF2B5EF4-FFF2-40B4-BE49-F238E27FC236}">
-                <a16:creationId xmlns:a16="http://schemas.microsoft.com/office/drawing/2014/main" id="{D691BCDB-D516-461D-B5DB-4A6E8283A63A}"/>
+                <a16:creationId xmlns:a16="http://schemas.microsoft.com/office/drawing/2014/main" id="{F0731B52-58FA-489D-A0DF-0721881CA3F0}"/>
               </a:ext>
             </a:extLst>
           </p:cNvPr>
@@ -10027,7 +11632,7 @@
           <p:cNvPr id="15" name="">
             <a:extLst xmlns:a="http://schemas.openxmlformats.org/drawingml/2006/main">
               <a:ext uri="{FF2B5EF4-FFF2-40B4-BE49-F238E27FC236}">
-                <a16:creationId xmlns:a16="http://schemas.microsoft.com/office/drawing/2014/main" id="{DB0190B3-381E-4453-9D7B-60811738C390}"/>
+                <a16:creationId xmlns:a16="http://schemas.microsoft.com/office/drawing/2014/main" id="{D6C3B02C-7AFD-454E-9285-FFB6F4DBDFE8}"/>
               </a:ext>
             </a:extLst>
           </p:cNvPr>
@@ -10074,7 +11679,7 @@
           <p:cNvPr id="16" name="">
             <a:extLst xmlns:a="http://schemas.openxmlformats.org/drawingml/2006/main">
               <a:ext uri="{FF2B5EF4-FFF2-40B4-BE49-F238E27FC236}">
-                <a16:creationId xmlns:a16="http://schemas.microsoft.com/office/drawing/2014/main" id="{619801BB-3049-454A-83C0-48FA7A925342}"/>
+                <a16:creationId xmlns:a16="http://schemas.microsoft.com/office/drawing/2014/main" id="{78FA5560-3EEF-4B1C-A4E5-0B4870573E59}"/>
               </a:ext>
             </a:extLst>
           </p:cNvPr>
@@ -10121,7 +11726,7 @@
           <p:cNvPr id="17" name="">
             <a:extLst xmlns:a="http://schemas.openxmlformats.org/drawingml/2006/main">
               <a:ext uri="{FF2B5EF4-FFF2-40B4-BE49-F238E27FC236}">
-                <a16:creationId xmlns:a16="http://schemas.microsoft.com/office/drawing/2014/main" id="{7528D991-F51F-44D2-A949-8AF1C3C3BA92}"/>
+                <a16:creationId xmlns:a16="http://schemas.microsoft.com/office/drawing/2014/main" id="{C86F94FC-FE56-462F-A175-16556BBA5B17}"/>
               </a:ext>
             </a:extLst>
           </p:cNvPr>
@@ -10153,7 +11758,7 @@
           <p:cNvPr id="18" name="">
             <a:extLst xmlns:a="http://schemas.openxmlformats.org/drawingml/2006/main">
               <a:ext uri="{FF2B5EF4-FFF2-40B4-BE49-F238E27FC236}">
-                <a16:creationId xmlns:a16="http://schemas.microsoft.com/office/drawing/2014/main" id="{8C1EB426-CF08-4F17-AB2A-AA5FA2D8BB04}"/>
+                <a16:creationId xmlns:a16="http://schemas.microsoft.com/office/drawing/2014/main" id="{A26D8212-99EB-4F3C-9B93-AEB1F83EE380}"/>
               </a:ext>
             </a:extLst>
           </p:cNvPr>
@@ -10200,7 +11805,7 @@
           <p:cNvPr id="19" name="">
             <a:extLst xmlns:a="http://schemas.openxmlformats.org/drawingml/2006/main">
               <a:ext uri="{FF2B5EF4-FFF2-40B4-BE49-F238E27FC236}">
-                <a16:creationId xmlns:a16="http://schemas.microsoft.com/office/drawing/2014/main" id="{CEF6751B-20E6-44FE-B08D-F6E8626108A4}"/>
+                <a16:creationId xmlns:a16="http://schemas.microsoft.com/office/drawing/2014/main" id="{EC4A18EC-C49F-4897-AFCF-A288A799FE59}"/>
               </a:ext>
             </a:extLst>
           </p:cNvPr>
@@ -10245,7 +11850,7 @@
     </p:spTree>
     <p:extLst>
       <p:ext uri="{BB962C8B-B14F-4D97-AF65-F5344CB8AC3E}">
-        <p14:creationId xmlns:p14="http://schemas.microsoft.com/office/powerpoint/2010/main" val="1164750939"/>
+        <p14:creationId xmlns:p14="http://schemas.microsoft.com/office/powerpoint/2010/main" val="182323769"/>
       </p:ext>
     </p:extLst>
   </p:cSld>

</xml_diff>